<commit_message>
Update report and slides with challenge-aligned benchmark
</commit_message>
<xml_diff>
--- a/docs/project_deliverables/DSP501_final_presentation.pptx
+++ b/docs/project_deliverables/DSP501_final_presentation.pptx
@@ -7185,7 +7185,7 @@
         <p:spPr>
           <a:xfrm>
             <a:off x="685800" y="6053328"/>
-            <a:ext cx="7955280" cy="256032"/>
+            <a:ext cx="8595360" cy="256032"/>
           </a:xfrm>
           <a:prstGeom prst="rect">
             <a:avLst/>
@@ -7203,7 +7203,7 @@
               <a:buNone/>
             </a:pPr>
             <a:r>
-              <a:rPr lang="en-US" sz="1500" b="1" dirty="0">
+              <a:rPr lang="en-US" sz="1400" b="1" dirty="0">
                 <a:solidFill>
                   <a:srgbClr val="2B7A78"/>
                 </a:solidFill>
@@ -7211,9 +7211,9 @@
                 <a:ea typeface="Aptos" pitchFamily="34" charset="-122"/>
                 <a:cs typeface="Aptos" pitchFamily="34" charset="-120"/>
               </a:rPr>
-              <a:t>942 metadata patients · 3,163 WAV · 874 labeled · split 611 / 131 / 132</a:t>
-            </a:r>
-            <a:endParaRPr lang="en-US" sz="1500" dirty="0"/>
+              <a:t>Secondary binary benchmark · 874 labeled · split 611 / 131 / 132 · primary track is 3-class</a:t>
+            </a:r>
+            <a:endParaRPr lang="en-US" sz="1400" dirty="0"/>
           </a:p>
         </p:txBody>
       </p:sp>
@@ -7511,7 +7511,7 @@
         <p:spPr>
           <a:xfrm>
             <a:off x="685800" y="1234440"/>
-            <a:ext cx="8412480" cy="274320"/>
+            <a:ext cx="9418320" cy="274320"/>
           </a:xfrm>
           <a:prstGeom prst="rect">
             <a:avLst/>
@@ -7537,7 +7537,7 @@
                 <a:ea typeface="Aptos" pitchFamily="34" charset="-122"/>
                 <a:cs typeface="Aptos" pitchFamily="34" charset="-120"/>
               </a:rPr>
-              <a:t>Target fs = 1 kHz · quantization = 16-bit · seed 42 · test = 132 patients</a:t>
+              <a:t>3-class primary · target fs = 1 kHz · 16-bit · seed 42 · test = 236 patients</a:t>
             </a:r>
             <a:endParaRPr lang="en-US" sz="1800" dirty="0"/>
           </a:p>
@@ -7558,20 +7558,21 @@
           </p:nvPr>
         </p:nvGraphicFramePr>
         <p:xfrm>
-          <a:off x="640080" y="1691640"/>
-          <a:ext cx="8092440" cy="4343400"/>
+          <a:off x="502920" y="1691640"/>
+          <a:ext cx="8458200" cy="4343400"/>
         </p:xfrm>
         <a:graphic>
           <a:graphicData uri="http://schemas.openxmlformats.org/drawingml/2006/table">
             <a:tbl>
               <a:tblPr/>
               <a:tblGrid>
-                <a:gridCol w="1051560"/>
-                <a:gridCol w="1508760"/>
-                <a:gridCol w="1554480"/>
+                <a:gridCol w="960120"/>
                 <a:gridCol w="1234440"/>
-                <a:gridCol w="1508760"/>
-                <a:gridCol w="1234440"/>
+                <a:gridCol w="1280160"/>
+                <a:gridCol w="1097280"/>
+                <a:gridCol w="1005840"/>
+                <a:gridCol w="1143000"/>
+                <a:gridCol w="1143000"/>
               </a:tblGrid>
               <a:tr h="457200">
                 <a:tc>
@@ -7583,7 +7584,7 @@
                         <a:buNone/>
                       </a:pPr>
                       <a:r>
-                        <a:rPr lang="en-US" sz="1400" b="1" dirty="0">
+                        <a:rPr lang="en-US" sz="1300" b="1" dirty="0">
                           <a:solidFill>
                             <a:srgbClr val="FFFDF8"/>
                           </a:solidFill>
@@ -7593,14 +7594,14 @@
                         </a:rPr>
                         <a:t>Model</a:t>
                       </a:r>
-                      <a:endParaRPr lang="en-US" sz="1400" dirty="0">
+                      <a:endParaRPr lang="en-US" sz="1300" dirty="0">
                         <a:latin typeface="Aptos" charset="0"/>
                         <a:ea typeface="Aptos" charset="0"/>
                         <a:cs typeface="Aptos" charset="0"/>
                       </a:endParaRPr>
                     </a:p>
                   </a:txBody>
-                  <a:tcPr marL="54864" marR="54864" marT="54864" marB="54864" anchor="mid">
+                  <a:tcPr marL="45720" marR="45720" marT="45720" marB="45720" anchor="mid">
                     <a:lnL w="12700" cap="flat" cmpd="sng" algn="ctr">
                       <a:solidFill>
                         <a:srgbClr val="C8C1B5"/>
@@ -7651,7 +7652,7 @@
                         <a:buNone/>
                       </a:pPr>
                       <a:r>
-                        <a:rPr lang="en-US" sz="1400" b="1" dirty="0">
+                        <a:rPr lang="en-US" sz="1300" b="1" dirty="0">
                           <a:solidFill>
                             <a:srgbClr val="FFFDF8"/>
                           </a:solidFill>
@@ -7661,14 +7662,14 @@
                         </a:rPr>
                         <a:t>Filter</a:t>
                       </a:r>
-                      <a:endParaRPr lang="en-US" sz="1400" dirty="0">
+                      <a:endParaRPr lang="en-US" sz="1300" dirty="0">
                         <a:latin typeface="Aptos" charset="0"/>
                         <a:ea typeface="Aptos" charset="0"/>
                         <a:cs typeface="Aptos" charset="0"/>
                       </a:endParaRPr>
                     </a:p>
                   </a:txBody>
-                  <a:tcPr marL="54864" marR="54864" marT="54864" marB="54864" anchor="mid">
+                  <a:tcPr marL="45720" marR="45720" marT="45720" marB="45720" anchor="mid">
                     <a:lnL w="12700" cap="flat" cmpd="sng" algn="ctr">
                       <a:solidFill>
                         <a:srgbClr val="C8C1B5"/>
@@ -7719,7 +7720,7 @@
                         <a:buNone/>
                       </a:pPr>
                       <a:r>
-                        <a:rPr lang="en-US" sz="1400" b="1" dirty="0">
+                        <a:rPr lang="en-US" sz="1300" b="1" dirty="0">
                           <a:solidFill>
                             <a:srgbClr val="FFFDF8"/>
                           </a:solidFill>
@@ -7729,14 +7730,14 @@
                         </a:rPr>
                         <a:t>Feature</a:t>
                       </a:r>
-                      <a:endParaRPr lang="en-US" sz="1400" dirty="0">
+                      <a:endParaRPr lang="en-US" sz="1300" dirty="0">
                         <a:latin typeface="Aptos" charset="0"/>
                         <a:ea typeface="Aptos" charset="0"/>
                         <a:cs typeface="Aptos" charset="0"/>
                       </a:endParaRPr>
                     </a:p>
                   </a:txBody>
-                  <a:tcPr marL="54864" marR="54864" marT="54864" marB="54864" anchor="mid">
+                  <a:tcPr marL="45720" marR="45720" marT="45720" marB="45720" anchor="mid">
                     <a:lnL w="12700" cap="flat" cmpd="sng" algn="ctr">
                       <a:solidFill>
                         <a:srgbClr val="C8C1B5"/>
@@ -7787,7 +7788,7 @@
                         <a:buNone/>
                       </a:pPr>
                       <a:r>
-                        <a:rPr lang="en-US" sz="1400" b="1" dirty="0">
+                        <a:rPr lang="en-US" sz="1300" b="1" dirty="0">
                           <a:solidFill>
                             <a:srgbClr val="FFFDF8"/>
                           </a:solidFill>
@@ -7795,16 +7796,16 @@
                           <a:ea typeface="Aptos" pitchFamily="34" charset="-122"/>
                           <a:cs typeface="Aptos" pitchFamily="34" charset="-120"/>
                         </a:rPr>
-                        <a:t>Accuracy</a:t>
+                        <a:t>WAcc</a:t>
                       </a:r>
-                      <a:endParaRPr lang="en-US" sz="1400" dirty="0">
+                      <a:endParaRPr lang="en-US" sz="1300" dirty="0">
                         <a:latin typeface="Aptos" charset="0"/>
                         <a:ea typeface="Aptos" charset="0"/>
                         <a:cs typeface="Aptos" charset="0"/>
                       </a:endParaRPr>
                     </a:p>
                   </a:txBody>
-                  <a:tcPr marL="54864" marR="54864" marT="54864" marB="54864" anchor="mid">
+                  <a:tcPr marL="45720" marR="45720" marT="45720" marB="45720" anchor="mid">
                     <a:lnL w="12700" cap="flat" cmpd="sng" algn="ctr">
                       <a:solidFill>
                         <a:srgbClr val="C8C1B5"/>
@@ -7855,7 +7856,7 @@
                         <a:buNone/>
                       </a:pPr>
                       <a:r>
-                        <a:rPr lang="en-US" sz="1400" b="1" dirty="0">
+                        <a:rPr lang="en-US" sz="1300" b="1" dirty="0">
                           <a:solidFill>
                             <a:srgbClr val="FFFDF8"/>
                           </a:solidFill>
@@ -7863,16 +7864,16 @@
                           <a:ea typeface="Aptos" pitchFamily="34" charset="-122"/>
                           <a:cs typeface="Aptos" pitchFamily="34" charset="-120"/>
                         </a:rPr>
-                        <a:t>Balanced acc.</a:t>
+                        <a:t>UAR</a:t>
                       </a:r>
-                      <a:endParaRPr lang="en-US" sz="1400" dirty="0">
+                      <a:endParaRPr lang="en-US" sz="1300" dirty="0">
                         <a:latin typeface="Aptos" charset="0"/>
                         <a:ea typeface="Aptos" charset="0"/>
                         <a:cs typeface="Aptos" charset="0"/>
                       </a:endParaRPr>
                     </a:p>
                   </a:txBody>
-                  <a:tcPr marL="54864" marR="54864" marT="54864" marB="54864" anchor="mid">
+                  <a:tcPr marL="45720" marR="45720" marT="45720" marB="45720" anchor="mid">
                     <a:lnL w="12700" cap="flat" cmpd="sng" algn="ctr">
                       <a:solidFill>
                         <a:srgbClr val="C8C1B5"/>
@@ -7923,7 +7924,7 @@
                         <a:buNone/>
                       </a:pPr>
                       <a:r>
-                        <a:rPr lang="en-US" sz="1400" b="1" dirty="0">
+                        <a:rPr lang="en-US" sz="1300" b="1" dirty="0">
                           <a:solidFill>
                             <a:srgbClr val="FFFDF8"/>
                           </a:solidFill>
@@ -7931,16 +7932,16 @@
                           <a:ea typeface="Aptos" pitchFamily="34" charset="-122"/>
                           <a:cs typeface="Aptos" pitchFamily="34" charset="-120"/>
                         </a:rPr>
-                        <a:t>Macro-F1</a:t>
+                        <a:t>AUROC</a:t>
                       </a:r>
-                      <a:endParaRPr lang="en-US" sz="1400" dirty="0">
+                      <a:endParaRPr lang="en-US" sz="1300" dirty="0">
                         <a:latin typeface="Aptos" charset="0"/>
                         <a:ea typeface="Aptos" charset="0"/>
                         <a:cs typeface="Aptos" charset="0"/>
                       </a:endParaRPr>
                     </a:p>
                   </a:txBody>
-                  <a:tcPr marL="54864" marR="54864" marT="54864" marB="54864" anchor="mid">
+                  <a:tcPr marL="45720" marR="45720" marT="45720" marB="45720" anchor="mid">
                     <a:lnL w="12700" cap="flat" cmpd="sng" algn="ctr">
                       <a:solidFill>
                         <a:srgbClr val="C8C1B5"/>
@@ -7982,8 +7983,6 @@
                     </a:solidFill>
                   </a:tcPr>
                 </a:tc>
-              </a:tr>
-              <a:tr h="530352">
                 <a:tc>
                   <a:txBody>
                     <a:bodyPr/>
@@ -7993,7 +7992,77 @@
                         <a:buNone/>
                       </a:pPr>
                       <a:r>
-                        <a:rPr lang="en-US" sz="1400" dirty="0">
+                        <a:rPr lang="en-US" sz="1300" b="1" dirty="0">
+                          <a:solidFill>
+                            <a:srgbClr val="FFFDF8"/>
+                          </a:solidFill>
+                          <a:latin typeface="Aptos" pitchFamily="34" charset="0"/>
+                          <a:ea typeface="Aptos" pitchFamily="34" charset="-122"/>
+                          <a:cs typeface="Aptos" pitchFamily="34" charset="-120"/>
+                        </a:rPr>
+                        <a:t>AUPRC</a:t>
+                      </a:r>
+                      <a:endParaRPr lang="en-US" sz="1300" dirty="0">
+                        <a:latin typeface="Aptos" charset="0"/>
+                        <a:ea typeface="Aptos" charset="0"/>
+                        <a:cs typeface="Aptos" charset="0"/>
+                      </a:endParaRPr>
+                    </a:p>
+                  </a:txBody>
+                  <a:tcPr marL="45720" marR="45720" marT="45720" marB="45720" anchor="mid">
+                    <a:lnL w="12700" cap="flat" cmpd="sng" algn="ctr">
+                      <a:solidFill>
+                        <a:srgbClr val="C8C1B5"/>
+                      </a:solidFill>
+                      <a:prstDash val="solid"/>
+                      <a:round/>
+                      <a:headEnd type="none" w="med" len="med"/>
+                      <a:tailEnd type="none" w="med" len="med"/>
+                    </a:lnL>
+                    <a:lnR w="12700" cap="flat" cmpd="sng" algn="ctr">
+                      <a:solidFill>
+                        <a:srgbClr val="C8C1B5"/>
+                      </a:solidFill>
+                      <a:prstDash val="solid"/>
+                      <a:round/>
+                      <a:headEnd type="none" w="med" len="med"/>
+                      <a:tailEnd type="none" w="med" len="med"/>
+                    </a:lnR>
+                    <a:lnT w="12700" cap="flat" cmpd="sng" algn="ctr">
+                      <a:solidFill>
+                        <a:srgbClr val="C8C1B5"/>
+                      </a:solidFill>
+                      <a:prstDash val="solid"/>
+                      <a:round/>
+                      <a:headEnd type="none" w="med" len="med"/>
+                      <a:tailEnd type="none" w="med" len="med"/>
+                    </a:lnT>
+                    <a:lnB w="12700" cap="flat" cmpd="sng" algn="ctr">
+                      <a:solidFill>
+                        <a:srgbClr val="C8C1B5"/>
+                      </a:solidFill>
+                      <a:prstDash val="solid"/>
+                      <a:round/>
+                      <a:headEnd type="none" w="med" len="med"/>
+                      <a:tailEnd type="none" w="med" len="med"/>
+                    </a:lnB>
+                    <a:solidFill>
+                      <a:srgbClr val="1D3D49"/>
+                    </a:solidFill>
+                  </a:tcPr>
+                </a:tc>
+              </a:tr>
+              <a:tr h="621792">
+                <a:tc>
+                  <a:txBody>
+                    <a:bodyPr/>
+                    <a:lstStyle/>
+                    <a:p>
+                      <a:pPr algn="ctr" indent="0" marL="0">
+                        <a:buNone/>
+                      </a:pPr>
+                      <a:r>
+                        <a:rPr lang="en-US" sz="1300" dirty="0">
                           <a:solidFill>
                             <a:srgbClr val="17313B"/>
                           </a:solidFill>
@@ -8001,16 +8070,16 @@
                           <a:ea typeface="Aptos" pitchFamily="34" charset="-122"/>
                           <a:cs typeface="Aptos" pitchFamily="34" charset="-120"/>
                         </a:rPr>
-                        <a:t>MLP</a:t>
+                        <a:t>SVM</a:t>
                       </a:r>
-                      <a:endParaRPr lang="en-US" sz="1400" dirty="0">
+                      <a:endParaRPr lang="en-US" sz="1300" dirty="0">
                         <a:latin typeface="Aptos" charset="0"/>
                         <a:ea typeface="Aptos" charset="0"/>
                         <a:cs typeface="Aptos" charset="0"/>
                       </a:endParaRPr>
                     </a:p>
                   </a:txBody>
-                  <a:tcPr marL="54864" marR="54864" marT="54864" marB="54864" anchor="mid">
+                  <a:tcPr marL="45720" marR="45720" marT="45720" marB="45720" anchor="mid">
                     <a:lnL w="12700" cap="flat" cmpd="sng" algn="ctr">
                       <a:solidFill>
                         <a:srgbClr val="C8C1B5"/>
@@ -8061,7 +8130,7 @@
                         <a:buNone/>
                       </a:pPr>
                       <a:r>
-                        <a:rPr lang="en-US" sz="1400" dirty="0">
+                        <a:rPr lang="en-US" sz="1300" dirty="0">
                           <a:solidFill>
                             <a:srgbClr val="17313B"/>
                           </a:solidFill>
@@ -8071,14 +8140,14 @@
                         </a:rPr>
                         <a:t>None</a:t>
                       </a:r>
-                      <a:endParaRPr lang="en-US" sz="1400" dirty="0">
+                      <a:endParaRPr lang="en-US" sz="1300" dirty="0">
                         <a:latin typeface="Aptos" charset="0"/>
                         <a:ea typeface="Aptos" charset="0"/>
                         <a:cs typeface="Aptos" charset="0"/>
                       </a:endParaRPr>
                     </a:p>
                   </a:txBody>
-                  <a:tcPr marL="54864" marR="54864" marT="54864" marB="54864" anchor="mid">
+                  <a:tcPr marL="45720" marR="45720" marT="45720" marB="45720" anchor="mid">
                     <a:lnL w="12700" cap="flat" cmpd="sng" algn="ctr">
                       <a:solidFill>
                         <a:srgbClr val="C8C1B5"/>
@@ -8129,7 +8198,7 @@
                         <a:buNone/>
                       </a:pPr>
                       <a:r>
-                        <a:rPr lang="en-US" sz="1400" dirty="0">
+                        <a:rPr lang="en-US" sz="1300" dirty="0">
                           <a:solidFill>
                             <a:srgbClr val="17313B"/>
                           </a:solidFill>
@@ -8137,16 +8206,16 @@
                           <a:ea typeface="Aptos" pitchFamily="34" charset="-122"/>
                           <a:cs typeface="Aptos" pitchFamily="34" charset="-120"/>
                         </a:rPr>
-                        <a:t>MFCC</a:t>
+                        <a:t>Hybrid</a:t>
                       </a:r>
-                      <a:endParaRPr lang="en-US" sz="1400" dirty="0">
+                      <a:endParaRPr lang="en-US" sz="1300" dirty="0">
                         <a:latin typeface="Aptos" charset="0"/>
                         <a:ea typeface="Aptos" charset="0"/>
                         <a:cs typeface="Aptos" charset="0"/>
                       </a:endParaRPr>
                     </a:p>
                   </a:txBody>
-                  <a:tcPr marL="54864" marR="54864" marT="54864" marB="54864" anchor="mid">
+                  <a:tcPr marL="45720" marR="45720" marT="45720" marB="45720" anchor="mid">
                     <a:lnL w="12700" cap="flat" cmpd="sng" algn="ctr">
                       <a:solidFill>
                         <a:srgbClr val="C8C1B5"/>
@@ -8197,7 +8266,7 @@
                         <a:buNone/>
                       </a:pPr>
                       <a:r>
-                        <a:rPr lang="en-US" sz="1400" dirty="0">
+                        <a:rPr lang="en-US" sz="1300" dirty="0">
                           <a:solidFill>
                             <a:srgbClr val="17313B"/>
                           </a:solidFill>
@@ -8205,16 +8274,16 @@
                           <a:ea typeface="Aptos" pitchFamily="34" charset="-122"/>
                           <a:cs typeface="Aptos" pitchFamily="34" charset="-120"/>
                         </a:rPr>
-                        <a:t>0.848</a:t>
+                        <a:t>0.644</a:t>
                       </a:r>
-                      <a:endParaRPr lang="en-US" sz="1400" dirty="0">
+                      <a:endParaRPr lang="en-US" sz="1300" dirty="0">
                         <a:latin typeface="Aptos" charset="0"/>
                         <a:ea typeface="Aptos" charset="0"/>
                         <a:cs typeface="Aptos" charset="0"/>
                       </a:endParaRPr>
                     </a:p>
                   </a:txBody>
-                  <a:tcPr marL="54864" marR="54864" marT="54864" marB="54864" anchor="mid">
+                  <a:tcPr marL="45720" marR="45720" marT="45720" marB="45720" anchor="mid">
                     <a:lnL w="12700" cap="flat" cmpd="sng" algn="ctr">
                       <a:solidFill>
                         <a:srgbClr val="C8C1B5"/>
@@ -8265,7 +8334,7 @@
                         <a:buNone/>
                       </a:pPr>
                       <a:r>
-                        <a:rPr lang="en-US" sz="1400" dirty="0">
+                        <a:rPr lang="en-US" sz="1300" dirty="0">
                           <a:solidFill>
                             <a:srgbClr val="17313B"/>
                           </a:solidFill>
@@ -8273,16 +8342,16 @@
                           <a:ea typeface="Aptos" pitchFamily="34" charset="-122"/>
                           <a:cs typeface="Aptos" pitchFamily="34" charset="-120"/>
                         </a:rPr>
-                        <a:t>0.657</a:t>
+                        <a:t>0.596</a:t>
                       </a:r>
-                      <a:endParaRPr lang="en-US" sz="1400" dirty="0">
+                      <a:endParaRPr lang="en-US" sz="1300" dirty="0">
                         <a:latin typeface="Aptos" charset="0"/>
                         <a:ea typeface="Aptos" charset="0"/>
                         <a:cs typeface="Aptos" charset="0"/>
                       </a:endParaRPr>
                     </a:p>
                   </a:txBody>
-                  <a:tcPr marL="54864" marR="54864" marT="54864" marB="54864" anchor="mid">
+                  <a:tcPr marL="45720" marR="45720" marT="45720" marB="45720" anchor="mid">
                     <a:lnL w="12700" cap="flat" cmpd="sng" algn="ctr">
                       <a:solidFill>
                         <a:srgbClr val="C8C1B5"/>
@@ -8333,7 +8402,7 @@
                         <a:buNone/>
                       </a:pPr>
                       <a:r>
-                        <a:rPr lang="en-US" sz="1400" dirty="0">
+                        <a:rPr lang="en-US" sz="1300" dirty="0">
                           <a:solidFill>
                             <a:srgbClr val="17313B"/>
                           </a:solidFill>
@@ -8341,86 +8410,16 @@
                           <a:ea typeface="Aptos" pitchFamily="34" charset="-122"/>
                           <a:cs typeface="Aptos" pitchFamily="34" charset="-120"/>
                         </a:rPr>
-                        <a:t>0.693</a:t>
+                        <a:t>0.775</a:t>
                       </a:r>
-                      <a:endParaRPr lang="en-US" sz="1400" dirty="0">
+                      <a:endParaRPr lang="en-US" sz="1300" dirty="0">
                         <a:latin typeface="Aptos" charset="0"/>
                         <a:ea typeface="Aptos" charset="0"/>
                         <a:cs typeface="Aptos" charset="0"/>
                       </a:endParaRPr>
                     </a:p>
                   </a:txBody>
-                  <a:tcPr marL="54864" marR="54864" marT="54864" marB="54864" anchor="mid">
-                    <a:lnL w="12700" cap="flat" cmpd="sng" algn="ctr">
-                      <a:solidFill>
-                        <a:srgbClr val="C8C1B5"/>
-                      </a:solidFill>
-                      <a:prstDash val="solid"/>
-                      <a:round/>
-                      <a:headEnd type="none" w="med" len="med"/>
-                      <a:tailEnd type="none" w="med" len="med"/>
-                    </a:lnL>
-                    <a:lnR w="12700" cap="flat" cmpd="sng" algn="ctr">
-                      <a:solidFill>
-                        <a:srgbClr val="C8C1B5"/>
-                      </a:solidFill>
-                      <a:prstDash val="solid"/>
-                      <a:round/>
-                      <a:headEnd type="none" w="med" len="med"/>
-                      <a:tailEnd type="none" w="med" len="med"/>
-                    </a:lnR>
-                    <a:lnT w="12700" cap="flat" cmpd="sng" algn="ctr">
-                      <a:solidFill>
-                        <a:srgbClr val="C8C1B5"/>
-                      </a:solidFill>
-                      <a:prstDash val="solid"/>
-                      <a:round/>
-                      <a:headEnd type="none" w="med" len="med"/>
-                      <a:tailEnd type="none" w="med" len="med"/>
-                    </a:lnT>
-                    <a:lnB w="12700" cap="flat" cmpd="sng" algn="ctr">
-                      <a:solidFill>
-                        <a:srgbClr val="C8C1B5"/>
-                      </a:solidFill>
-                      <a:prstDash val="solid"/>
-                      <a:round/>
-                      <a:headEnd type="none" w="med" len="med"/>
-                      <a:tailEnd type="none" w="med" len="med"/>
-                    </a:lnB>
-                    <a:solidFill>
-                      <a:srgbClr val="FFFDF8"/>
-                    </a:solidFill>
-                  </a:tcPr>
-                </a:tc>
-              </a:tr>
-              <a:tr h="530352">
-                <a:tc>
-                  <a:txBody>
-                    <a:bodyPr/>
-                    <a:lstStyle/>
-                    <a:p>
-                      <a:pPr algn="ctr" indent="0" marL="0">
-                        <a:buNone/>
-                      </a:pPr>
-                      <a:r>
-                        <a:rPr lang="en-US" sz="1400" dirty="0">
-                          <a:solidFill>
-                            <a:srgbClr val="17313B"/>
-                          </a:solidFill>
-                          <a:latin typeface="Aptos" pitchFamily="34" charset="0"/>
-                          <a:ea typeface="Aptos" pitchFamily="34" charset="-122"/>
-                          <a:cs typeface="Aptos" pitchFamily="34" charset="-120"/>
-                        </a:rPr>
-                        <a:t>MLP</a:t>
-                      </a:r>
-                      <a:endParaRPr lang="en-US" sz="1400" dirty="0">
-                        <a:latin typeface="Aptos" charset="0"/>
-                        <a:ea typeface="Aptos" charset="0"/>
-                        <a:cs typeface="Aptos" charset="0"/>
-                      </a:endParaRPr>
-                    </a:p>
-                  </a:txBody>
-                  <a:tcPr marL="54864" marR="54864" marT="54864" marB="54864" anchor="mid">
+                  <a:tcPr marL="45720" marR="45720" marT="45720" marB="45720" anchor="mid">
                     <a:lnL w="12700" cap="flat" cmpd="sng" algn="ctr">
                       <a:solidFill>
                         <a:srgbClr val="C8C1B5"/>
@@ -8471,7 +8470,7 @@
                         <a:buNone/>
                       </a:pPr>
                       <a:r>
-                        <a:rPr lang="en-US" sz="1400" dirty="0">
+                        <a:rPr lang="en-US" sz="1300" dirty="0">
                           <a:solidFill>
                             <a:srgbClr val="17313B"/>
                           </a:solidFill>
@@ -8479,16 +8478,86 @@
                           <a:ea typeface="Aptos" pitchFamily="34" charset="-122"/>
                           <a:cs typeface="Aptos" pitchFamily="34" charset="-120"/>
                         </a:rPr>
-                        <a:t>None</a:t>
+                        <a:t>0.587</a:t>
                       </a:r>
-                      <a:endParaRPr lang="en-US" sz="1400" dirty="0">
+                      <a:endParaRPr lang="en-US" sz="1300" dirty="0">
                         <a:latin typeface="Aptos" charset="0"/>
                         <a:ea typeface="Aptos" charset="0"/>
                         <a:cs typeface="Aptos" charset="0"/>
                       </a:endParaRPr>
                     </a:p>
                   </a:txBody>
-                  <a:tcPr marL="54864" marR="54864" marT="54864" marB="54864" anchor="mid">
+                  <a:tcPr marL="45720" marR="45720" marT="45720" marB="45720" anchor="mid">
+                    <a:lnL w="12700" cap="flat" cmpd="sng" algn="ctr">
+                      <a:solidFill>
+                        <a:srgbClr val="C8C1B5"/>
+                      </a:solidFill>
+                      <a:prstDash val="solid"/>
+                      <a:round/>
+                      <a:headEnd type="none" w="med" len="med"/>
+                      <a:tailEnd type="none" w="med" len="med"/>
+                    </a:lnL>
+                    <a:lnR w="12700" cap="flat" cmpd="sng" algn="ctr">
+                      <a:solidFill>
+                        <a:srgbClr val="C8C1B5"/>
+                      </a:solidFill>
+                      <a:prstDash val="solid"/>
+                      <a:round/>
+                      <a:headEnd type="none" w="med" len="med"/>
+                      <a:tailEnd type="none" w="med" len="med"/>
+                    </a:lnR>
+                    <a:lnT w="12700" cap="flat" cmpd="sng" algn="ctr">
+                      <a:solidFill>
+                        <a:srgbClr val="C8C1B5"/>
+                      </a:solidFill>
+                      <a:prstDash val="solid"/>
+                      <a:round/>
+                      <a:headEnd type="none" w="med" len="med"/>
+                      <a:tailEnd type="none" w="med" len="med"/>
+                    </a:lnT>
+                    <a:lnB w="12700" cap="flat" cmpd="sng" algn="ctr">
+                      <a:solidFill>
+                        <a:srgbClr val="C8C1B5"/>
+                      </a:solidFill>
+                      <a:prstDash val="solid"/>
+                      <a:round/>
+                      <a:headEnd type="none" w="med" len="med"/>
+                      <a:tailEnd type="none" w="med" len="med"/>
+                    </a:lnB>
+                    <a:solidFill>
+                      <a:srgbClr val="FFFDF8"/>
+                    </a:solidFill>
+                  </a:tcPr>
+                </a:tc>
+              </a:tr>
+              <a:tr h="621792">
+                <a:tc>
+                  <a:txBody>
+                    <a:bodyPr/>
+                    <a:lstStyle/>
+                    <a:p>
+                      <a:pPr algn="ctr" indent="0" marL="0">
+                        <a:buNone/>
+                      </a:pPr>
+                      <a:r>
+                        <a:rPr lang="en-US" sz="1300" dirty="0">
+                          <a:solidFill>
+                            <a:srgbClr val="17313B"/>
+                          </a:solidFill>
+                          <a:latin typeface="Aptos" pitchFamily="34" charset="0"/>
+                          <a:ea typeface="Aptos" pitchFamily="34" charset="-122"/>
+                          <a:cs typeface="Aptos" pitchFamily="34" charset="-120"/>
+                        </a:rPr>
+                        <a:t>SVM</a:t>
+                      </a:r>
+                      <a:endParaRPr lang="en-US" sz="1300" dirty="0">
+                        <a:latin typeface="Aptos" charset="0"/>
+                        <a:ea typeface="Aptos" charset="0"/>
+                        <a:cs typeface="Aptos" charset="0"/>
+                      </a:endParaRPr>
+                    </a:p>
+                  </a:txBody>
+                  <a:tcPr marL="45720" marR="45720" marT="45720" marB="45720" anchor="mid">
                     <a:lnL w="12700" cap="flat" cmpd="sng" algn="ctr">
                       <a:solidFill>
                         <a:srgbClr val="C8C1B5"/>
@@ -8539,7 +8608,7 @@
                         <a:buNone/>
                       </a:pPr>
                       <a:r>
-                        <a:rPr lang="en-US" sz="1400" dirty="0">
+                        <a:rPr lang="en-US" sz="1300" dirty="0">
                           <a:solidFill>
                             <a:srgbClr val="17313B"/>
                           </a:solidFill>
@@ -8547,16 +8616,16 @@
                           <a:ea typeface="Aptos" pitchFamily="34" charset="-122"/>
                           <a:cs typeface="Aptos" pitchFamily="34" charset="-120"/>
                         </a:rPr>
-                        <a:t>Hybrid</a:t>
+                        <a:t>None</a:t>
                       </a:r>
-                      <a:endParaRPr lang="en-US" sz="1400" dirty="0">
+                      <a:endParaRPr lang="en-US" sz="1300" dirty="0">
                         <a:latin typeface="Aptos" charset="0"/>
                         <a:ea typeface="Aptos" charset="0"/>
                         <a:cs typeface="Aptos" charset="0"/>
                       </a:endParaRPr>
                     </a:p>
                   </a:txBody>
-                  <a:tcPr marL="54864" marR="54864" marT="54864" marB="54864" anchor="mid">
+                  <a:tcPr marL="45720" marR="45720" marT="45720" marB="45720" anchor="mid">
                     <a:lnL w="12700" cap="flat" cmpd="sng" algn="ctr">
                       <a:solidFill>
                         <a:srgbClr val="C8C1B5"/>
@@ -8607,7 +8676,7 @@
                         <a:buNone/>
                       </a:pPr>
                       <a:r>
-                        <a:rPr lang="en-US" sz="1400" dirty="0">
+                        <a:rPr lang="en-US" sz="1300" dirty="0">
                           <a:solidFill>
                             <a:srgbClr val="17313B"/>
                           </a:solidFill>
@@ -8615,16 +8684,16 @@
                           <a:ea typeface="Aptos" pitchFamily="34" charset="-122"/>
                           <a:cs typeface="Aptos" pitchFamily="34" charset="-120"/>
                         </a:rPr>
-                        <a:t>0.841</a:t>
+                        <a:t>MFCC</a:t>
                       </a:r>
-                      <a:endParaRPr lang="en-US" sz="1400" dirty="0">
+                      <a:endParaRPr lang="en-US" sz="1300" dirty="0">
                         <a:latin typeface="Aptos" charset="0"/>
                         <a:ea typeface="Aptos" charset="0"/>
                         <a:cs typeface="Aptos" charset="0"/>
                       </a:endParaRPr>
                     </a:p>
                   </a:txBody>
-                  <a:tcPr marL="54864" marR="54864" marT="54864" marB="54864" anchor="mid">
+                  <a:tcPr marL="45720" marR="45720" marT="45720" marB="45720" anchor="mid">
                     <a:lnL w="12700" cap="flat" cmpd="sng" algn="ctr">
                       <a:solidFill>
                         <a:srgbClr val="C8C1B5"/>
@@ -8675,7 +8744,7 @@
                         <a:buNone/>
                       </a:pPr>
                       <a:r>
-                        <a:rPr lang="en-US" sz="1400" dirty="0">
+                        <a:rPr lang="en-US" sz="1300" dirty="0">
                           <a:solidFill>
                             <a:srgbClr val="17313B"/>
                           </a:solidFill>
@@ -8683,16 +8752,16 @@
                           <a:ea typeface="Aptos" pitchFamily="34" charset="-122"/>
                           <a:cs typeface="Aptos" pitchFamily="34" charset="-120"/>
                         </a:rPr>
-                        <a:t>0.625</a:t>
+                        <a:t>0.629</a:t>
                       </a:r>
-                      <a:endParaRPr lang="en-US" sz="1400" dirty="0">
+                      <a:endParaRPr lang="en-US" sz="1300" dirty="0">
                         <a:latin typeface="Aptos" charset="0"/>
                         <a:ea typeface="Aptos" charset="0"/>
                         <a:cs typeface="Aptos" charset="0"/>
                       </a:endParaRPr>
                     </a:p>
                   </a:txBody>
-                  <a:tcPr marL="54864" marR="54864" marT="54864" marB="54864" anchor="mid">
+                  <a:tcPr marL="45720" marR="45720" marT="45720" marB="45720" anchor="mid">
                     <a:lnL w="12700" cap="flat" cmpd="sng" algn="ctr">
                       <a:solidFill>
                         <a:srgbClr val="C8C1B5"/>
@@ -8743,7 +8812,7 @@
                         <a:buNone/>
                       </a:pPr>
                       <a:r>
-                        <a:rPr lang="en-US" sz="1400" dirty="0">
+                        <a:rPr lang="en-US" sz="1300" dirty="0">
                           <a:solidFill>
                             <a:srgbClr val="17313B"/>
                           </a:solidFill>
@@ -8751,86 +8820,16 @@
                           <a:ea typeface="Aptos" pitchFamily="34" charset="-122"/>
                           <a:cs typeface="Aptos" pitchFamily="34" charset="-120"/>
                         </a:rPr>
-                        <a:t>0.654</a:t>
+                        <a:t>0.571</a:t>
                       </a:r>
-                      <a:endParaRPr lang="en-US" sz="1400" dirty="0">
+                      <a:endParaRPr lang="en-US" sz="1300" dirty="0">
                         <a:latin typeface="Aptos" charset="0"/>
                         <a:ea typeface="Aptos" charset="0"/>
                         <a:cs typeface="Aptos" charset="0"/>
                       </a:endParaRPr>
                     </a:p>
                   </a:txBody>
-                  <a:tcPr marL="54864" marR="54864" marT="54864" marB="54864" anchor="mid">
-                    <a:lnL w="12700" cap="flat" cmpd="sng" algn="ctr">
-                      <a:solidFill>
-                        <a:srgbClr val="C8C1B5"/>
-                      </a:solidFill>
-                      <a:prstDash val="solid"/>
-                      <a:round/>
-                      <a:headEnd type="none" w="med" len="med"/>
-                      <a:tailEnd type="none" w="med" len="med"/>
-                    </a:lnL>
-                    <a:lnR w="12700" cap="flat" cmpd="sng" algn="ctr">
-                      <a:solidFill>
-                        <a:srgbClr val="C8C1B5"/>
-                      </a:solidFill>
-                      <a:prstDash val="solid"/>
-                      <a:round/>
-                      <a:headEnd type="none" w="med" len="med"/>
-                      <a:tailEnd type="none" w="med" len="med"/>
-                    </a:lnR>
-                    <a:lnT w="12700" cap="flat" cmpd="sng" algn="ctr">
-                      <a:solidFill>
-                        <a:srgbClr val="C8C1B5"/>
-                      </a:solidFill>
-                      <a:prstDash val="solid"/>
-                      <a:round/>
-                      <a:headEnd type="none" w="med" len="med"/>
-                      <a:tailEnd type="none" w="med" len="med"/>
-                    </a:lnT>
-                    <a:lnB w="12700" cap="flat" cmpd="sng" algn="ctr">
-                      <a:solidFill>
-                        <a:srgbClr val="C8C1B5"/>
-                      </a:solidFill>
-                      <a:prstDash val="solid"/>
-                      <a:round/>
-                      <a:headEnd type="none" w="med" len="med"/>
-                      <a:tailEnd type="none" w="med" len="med"/>
-                    </a:lnB>
-                    <a:solidFill>
-                      <a:srgbClr val="FFFDF8"/>
-                    </a:solidFill>
-                  </a:tcPr>
-                </a:tc>
-              </a:tr>
-              <a:tr h="530352">
-                <a:tc>
-                  <a:txBody>
-                    <a:bodyPr/>
-                    <a:lstStyle/>
-                    <a:p>
-                      <a:pPr algn="ctr" indent="0" marL="0">
-                        <a:buNone/>
-                      </a:pPr>
-                      <a:r>
-                        <a:rPr lang="en-US" sz="1400" dirty="0">
-                          <a:solidFill>
-                            <a:srgbClr val="17313B"/>
-                          </a:solidFill>
-                          <a:latin typeface="Aptos" pitchFamily="34" charset="0"/>
-                          <a:ea typeface="Aptos" pitchFamily="34" charset="-122"/>
-                          <a:cs typeface="Aptos" pitchFamily="34" charset="-120"/>
-                        </a:rPr>
-                        <a:t>SVM</a:t>
-                      </a:r>
-                      <a:endParaRPr lang="en-US" sz="1400" dirty="0">
-                        <a:latin typeface="Aptos" charset="0"/>
-                        <a:ea typeface="Aptos" charset="0"/>
-                        <a:cs typeface="Aptos" charset="0"/>
-                      </a:endParaRPr>
-                    </a:p>
-                  </a:txBody>
-                  <a:tcPr marL="54864" marR="54864" marT="54864" marB="54864" anchor="mid">
+                  <a:tcPr marL="45720" marR="45720" marT="45720" marB="45720" anchor="mid">
                     <a:lnL w="12700" cap="flat" cmpd="sng" algn="ctr">
                       <a:solidFill>
                         <a:srgbClr val="C8C1B5"/>
@@ -8881,7 +8880,7 @@
                         <a:buNone/>
                       </a:pPr>
                       <a:r>
-                        <a:rPr lang="en-US" sz="1400" dirty="0">
+                        <a:rPr lang="en-US" sz="1300" dirty="0">
                           <a:solidFill>
                             <a:srgbClr val="17313B"/>
                           </a:solidFill>
@@ -8889,16 +8888,16 @@
                           <a:ea typeface="Aptos" pitchFamily="34" charset="-122"/>
                           <a:cs typeface="Aptos" pitchFamily="34" charset="-120"/>
                         </a:rPr>
-                        <a:t>None</a:t>
+                        <a:t>0.776</a:t>
                       </a:r>
-                      <a:endParaRPr lang="en-US" sz="1400" dirty="0">
+                      <a:endParaRPr lang="en-US" sz="1300" dirty="0">
                         <a:latin typeface="Aptos" charset="0"/>
                         <a:ea typeface="Aptos" charset="0"/>
                         <a:cs typeface="Aptos" charset="0"/>
                       </a:endParaRPr>
                     </a:p>
                   </a:txBody>
-                  <a:tcPr marL="54864" marR="54864" marT="54864" marB="54864" anchor="mid">
+                  <a:tcPr marL="45720" marR="45720" marT="45720" marB="45720" anchor="mid">
                     <a:lnL w="12700" cap="flat" cmpd="sng" algn="ctr">
                       <a:solidFill>
                         <a:srgbClr val="C8C1B5"/>
@@ -8949,7 +8948,7 @@
                         <a:buNone/>
                       </a:pPr>
                       <a:r>
-                        <a:rPr lang="en-US" sz="1400" dirty="0">
+                        <a:rPr lang="en-US" sz="1300" dirty="0">
                           <a:solidFill>
                             <a:srgbClr val="17313B"/>
                           </a:solidFill>
@@ -8957,16 +8956,86 @@
                           <a:ea typeface="Aptos" pitchFamily="34" charset="-122"/>
                           <a:cs typeface="Aptos" pitchFamily="34" charset="-120"/>
                         </a:rPr>
-                        <a:t>Hybrid</a:t>
+                        <a:t>0.579</a:t>
                       </a:r>
-                      <a:endParaRPr lang="en-US" sz="1400" dirty="0">
+                      <a:endParaRPr lang="en-US" sz="1300" dirty="0">
                         <a:latin typeface="Aptos" charset="0"/>
                         <a:ea typeface="Aptos" charset="0"/>
                         <a:cs typeface="Aptos" charset="0"/>
                       </a:endParaRPr>
                     </a:p>
                   </a:txBody>
-                  <a:tcPr marL="54864" marR="54864" marT="54864" marB="54864" anchor="mid">
+                  <a:tcPr marL="45720" marR="45720" marT="45720" marB="45720" anchor="mid">
+                    <a:lnL w="12700" cap="flat" cmpd="sng" algn="ctr">
+                      <a:solidFill>
+                        <a:srgbClr val="C8C1B5"/>
+                      </a:solidFill>
+                      <a:prstDash val="solid"/>
+                      <a:round/>
+                      <a:headEnd type="none" w="med" len="med"/>
+                      <a:tailEnd type="none" w="med" len="med"/>
+                    </a:lnL>
+                    <a:lnR w="12700" cap="flat" cmpd="sng" algn="ctr">
+                      <a:solidFill>
+                        <a:srgbClr val="C8C1B5"/>
+                      </a:solidFill>
+                      <a:prstDash val="solid"/>
+                      <a:round/>
+                      <a:headEnd type="none" w="med" len="med"/>
+                      <a:tailEnd type="none" w="med" len="med"/>
+                    </a:lnR>
+                    <a:lnT w="12700" cap="flat" cmpd="sng" algn="ctr">
+                      <a:solidFill>
+                        <a:srgbClr val="C8C1B5"/>
+                      </a:solidFill>
+                      <a:prstDash val="solid"/>
+                      <a:round/>
+                      <a:headEnd type="none" w="med" len="med"/>
+                      <a:tailEnd type="none" w="med" len="med"/>
+                    </a:lnT>
+                    <a:lnB w="12700" cap="flat" cmpd="sng" algn="ctr">
+                      <a:solidFill>
+                        <a:srgbClr val="C8C1B5"/>
+                      </a:solidFill>
+                      <a:prstDash val="solid"/>
+                      <a:round/>
+                      <a:headEnd type="none" w="med" len="med"/>
+                      <a:tailEnd type="none" w="med" len="med"/>
+                    </a:lnB>
+                    <a:solidFill>
+                      <a:srgbClr val="FFFDF8"/>
+                    </a:solidFill>
+                  </a:tcPr>
+                </a:tc>
+              </a:tr>
+              <a:tr h="621792">
+                <a:tc>
+                  <a:txBody>
+                    <a:bodyPr/>
+                    <a:lstStyle/>
+                    <a:p>
+                      <a:pPr algn="ctr" indent="0" marL="0">
+                        <a:buNone/>
+                      </a:pPr>
+                      <a:r>
+                        <a:rPr lang="en-US" sz="1300" dirty="0">
+                          <a:solidFill>
+                            <a:srgbClr val="17313B"/>
+                          </a:solidFill>
+                          <a:latin typeface="Aptos" pitchFamily="34" charset="0"/>
+                          <a:ea typeface="Aptos" pitchFamily="34" charset="-122"/>
+                          <a:cs typeface="Aptos" pitchFamily="34" charset="-120"/>
+                        </a:rPr>
+                        <a:t>SVM</a:t>
+                      </a:r>
+                      <a:endParaRPr lang="en-US" sz="1300" dirty="0">
+                        <a:latin typeface="Aptos" charset="0"/>
+                        <a:ea typeface="Aptos" charset="0"/>
+                        <a:cs typeface="Aptos" charset="0"/>
+                      </a:endParaRPr>
+                    </a:p>
+                  </a:txBody>
+                  <a:tcPr marL="45720" marR="45720" marT="45720" marB="45720" anchor="mid">
                     <a:lnL w="12700" cap="flat" cmpd="sng" algn="ctr">
                       <a:solidFill>
                         <a:srgbClr val="C8C1B5"/>
@@ -9017,7 +9086,7 @@
                         <a:buNone/>
                       </a:pPr>
                       <a:r>
-                        <a:rPr lang="en-US" sz="1400" dirty="0">
+                        <a:rPr lang="en-US" sz="1300" dirty="0">
                           <a:solidFill>
                             <a:srgbClr val="17313B"/>
                           </a:solidFill>
@@ -9025,16 +9094,16 @@
                           <a:ea typeface="Aptos" pitchFamily="34" charset="-122"/>
                           <a:cs typeface="Aptos" pitchFamily="34" charset="-120"/>
                         </a:rPr>
-                        <a:t>0.750</a:t>
+                        <a:t>Butterworth</a:t>
                       </a:r>
-                      <a:endParaRPr lang="en-US" sz="1400" dirty="0">
+                      <a:endParaRPr lang="en-US" sz="1300" dirty="0">
                         <a:latin typeface="Aptos" charset="0"/>
                         <a:ea typeface="Aptos" charset="0"/>
                         <a:cs typeface="Aptos" charset="0"/>
                       </a:endParaRPr>
                     </a:p>
                   </a:txBody>
-                  <a:tcPr marL="54864" marR="54864" marT="54864" marB="54864" anchor="mid">
+                  <a:tcPr marL="45720" marR="45720" marT="45720" marB="45720" anchor="mid">
                     <a:lnL w="12700" cap="flat" cmpd="sng" algn="ctr">
                       <a:solidFill>
                         <a:srgbClr val="C8C1B5"/>
@@ -9085,7 +9154,7 @@
                         <a:buNone/>
                       </a:pPr>
                       <a:r>
-                        <a:rPr lang="en-US" sz="1400" dirty="0">
+                        <a:rPr lang="en-US" sz="1300" dirty="0">
                           <a:solidFill>
                             <a:srgbClr val="17313B"/>
                           </a:solidFill>
@@ -9093,16 +9162,16 @@
                           <a:ea typeface="Aptos" pitchFamily="34" charset="-122"/>
                           <a:cs typeface="Aptos" pitchFamily="34" charset="-120"/>
                         </a:rPr>
-                        <a:t>0.664</a:t>
+                        <a:t>Hybrid</a:t>
                       </a:r>
-                      <a:endParaRPr lang="en-US" sz="1400" dirty="0">
+                      <a:endParaRPr lang="en-US" sz="1300" dirty="0">
                         <a:latin typeface="Aptos" charset="0"/>
                         <a:ea typeface="Aptos" charset="0"/>
                         <a:cs typeface="Aptos" charset="0"/>
                       </a:endParaRPr>
                     </a:p>
                   </a:txBody>
-                  <a:tcPr marL="54864" marR="54864" marT="54864" marB="54864" anchor="mid">
+                  <a:tcPr marL="45720" marR="45720" marT="45720" marB="45720" anchor="mid">
                     <a:lnL w="12700" cap="flat" cmpd="sng" algn="ctr">
                       <a:solidFill>
                         <a:srgbClr val="C8C1B5"/>
@@ -9153,7 +9222,7 @@
                         <a:buNone/>
                       </a:pPr>
                       <a:r>
-                        <a:rPr lang="en-US" sz="1400" dirty="0">
+                        <a:rPr lang="en-US" sz="1300" dirty="0">
                           <a:solidFill>
                             <a:srgbClr val="17313B"/>
                           </a:solidFill>
@@ -9161,86 +9230,16 @@
                           <a:ea typeface="Aptos" pitchFamily="34" charset="-122"/>
                           <a:cs typeface="Aptos" pitchFamily="34" charset="-120"/>
                         </a:rPr>
-                        <a:t>0.648</a:t>
+                        <a:t>0.622</a:t>
                       </a:r>
-                      <a:endParaRPr lang="en-US" sz="1400" dirty="0">
+                      <a:endParaRPr lang="en-US" sz="1300" dirty="0">
                         <a:latin typeface="Aptos" charset="0"/>
                         <a:ea typeface="Aptos" charset="0"/>
                         <a:cs typeface="Aptos" charset="0"/>
                       </a:endParaRPr>
                     </a:p>
                   </a:txBody>
-                  <a:tcPr marL="54864" marR="54864" marT="54864" marB="54864" anchor="mid">
-                    <a:lnL w="12700" cap="flat" cmpd="sng" algn="ctr">
-                      <a:solidFill>
-                        <a:srgbClr val="C8C1B5"/>
-                      </a:solidFill>
-                      <a:prstDash val="solid"/>
-                      <a:round/>
-                      <a:headEnd type="none" w="med" len="med"/>
-                      <a:tailEnd type="none" w="med" len="med"/>
-                    </a:lnL>
-                    <a:lnR w="12700" cap="flat" cmpd="sng" algn="ctr">
-                      <a:solidFill>
-                        <a:srgbClr val="C8C1B5"/>
-                      </a:solidFill>
-                      <a:prstDash val="solid"/>
-                      <a:round/>
-                      <a:headEnd type="none" w="med" len="med"/>
-                      <a:tailEnd type="none" w="med" len="med"/>
-                    </a:lnR>
-                    <a:lnT w="12700" cap="flat" cmpd="sng" algn="ctr">
-                      <a:solidFill>
-                        <a:srgbClr val="C8C1B5"/>
-                      </a:solidFill>
-                      <a:prstDash val="solid"/>
-                      <a:round/>
-                      <a:headEnd type="none" w="med" len="med"/>
-                      <a:tailEnd type="none" w="med" len="med"/>
-                    </a:lnT>
-                    <a:lnB w="12700" cap="flat" cmpd="sng" algn="ctr">
-                      <a:solidFill>
-                        <a:srgbClr val="C8C1B5"/>
-                      </a:solidFill>
-                      <a:prstDash val="solid"/>
-                      <a:round/>
-                      <a:headEnd type="none" w="med" len="med"/>
-                      <a:tailEnd type="none" w="med" len="med"/>
-                    </a:lnB>
-                    <a:solidFill>
-                      <a:srgbClr val="FFFDF8"/>
-                    </a:solidFill>
-                  </a:tcPr>
-                </a:tc>
-              </a:tr>
-              <a:tr h="530352">
-                <a:tc>
-                  <a:txBody>
-                    <a:bodyPr/>
-                    <a:lstStyle/>
-                    <a:p>
-                      <a:pPr algn="ctr" indent="0" marL="0">
-                        <a:buNone/>
-                      </a:pPr>
-                      <a:r>
-                        <a:rPr lang="en-US" sz="1400" dirty="0">
-                          <a:solidFill>
-                            <a:srgbClr val="17313B"/>
-                          </a:solidFill>
-                          <a:latin typeface="Aptos" pitchFamily="34" charset="0"/>
-                          <a:ea typeface="Aptos" pitchFamily="34" charset="-122"/>
-                          <a:cs typeface="Aptos" pitchFamily="34" charset="-120"/>
-                        </a:rPr>
-                        <a:t>SVM</a:t>
-                      </a:r>
-                      <a:endParaRPr lang="en-US" sz="1400" dirty="0">
-                        <a:latin typeface="Aptos" charset="0"/>
-                        <a:ea typeface="Aptos" charset="0"/>
-                        <a:cs typeface="Aptos" charset="0"/>
-                      </a:endParaRPr>
-                    </a:p>
-                  </a:txBody>
-                  <a:tcPr marL="54864" marR="54864" marT="54864" marB="54864" anchor="mid">
+                  <a:tcPr marL="45720" marR="45720" marT="45720" marB="45720" anchor="mid">
                     <a:lnL w="12700" cap="flat" cmpd="sng" algn="ctr">
                       <a:solidFill>
                         <a:srgbClr val="C8C1B5"/>
@@ -9291,7 +9290,7 @@
                         <a:buNone/>
                       </a:pPr>
                       <a:r>
-                        <a:rPr lang="en-US" sz="1400" dirty="0">
+                        <a:rPr lang="en-US" sz="1300" dirty="0">
                           <a:solidFill>
                             <a:srgbClr val="17313B"/>
                           </a:solidFill>
@@ -9299,16 +9298,16 @@
                           <a:ea typeface="Aptos" pitchFamily="34" charset="-122"/>
                           <a:cs typeface="Aptos" pitchFamily="34" charset="-120"/>
                         </a:rPr>
-                        <a:t>FIR</a:t>
+                        <a:t>0.597</a:t>
                       </a:r>
-                      <a:endParaRPr lang="en-US" sz="1400" dirty="0">
+                      <a:endParaRPr lang="en-US" sz="1300" dirty="0">
                         <a:latin typeface="Aptos" charset="0"/>
                         <a:ea typeface="Aptos" charset="0"/>
                         <a:cs typeface="Aptos" charset="0"/>
                       </a:endParaRPr>
                     </a:p>
                   </a:txBody>
-                  <a:tcPr marL="54864" marR="54864" marT="54864" marB="54864" anchor="mid">
+                  <a:tcPr marL="45720" marR="45720" marT="45720" marB="45720" anchor="mid">
                     <a:lnL w="12700" cap="flat" cmpd="sng" algn="ctr">
                       <a:solidFill>
                         <a:srgbClr val="C8C1B5"/>
@@ -9359,7 +9358,7 @@
                         <a:buNone/>
                       </a:pPr>
                       <a:r>
-                        <a:rPr lang="en-US" sz="1400" dirty="0">
+                        <a:rPr lang="en-US" sz="1300" dirty="0">
                           <a:solidFill>
                             <a:srgbClr val="17313B"/>
                           </a:solidFill>
@@ -9367,16 +9366,16 @@
                           <a:ea typeface="Aptos" pitchFamily="34" charset="-122"/>
                           <a:cs typeface="Aptos" pitchFamily="34" charset="-120"/>
                         </a:rPr>
-                        <a:t>Hybrid</a:t>
+                        <a:t>0.791</a:t>
                       </a:r>
-                      <a:endParaRPr lang="en-US" sz="1400" dirty="0">
+                      <a:endParaRPr lang="en-US" sz="1300" dirty="0">
                         <a:latin typeface="Aptos" charset="0"/>
                         <a:ea typeface="Aptos" charset="0"/>
                         <a:cs typeface="Aptos" charset="0"/>
                       </a:endParaRPr>
                     </a:p>
                   </a:txBody>
-                  <a:tcPr marL="54864" marR="54864" marT="54864" marB="54864" anchor="mid">
+                  <a:tcPr marL="45720" marR="45720" marT="45720" marB="45720" anchor="mid">
                     <a:lnL w="12700" cap="flat" cmpd="sng" algn="ctr">
                       <a:solidFill>
                         <a:srgbClr val="C8C1B5"/>
@@ -9427,7 +9426,7 @@
                         <a:buNone/>
                       </a:pPr>
                       <a:r>
-                        <a:rPr lang="en-US" sz="1400" dirty="0">
+                        <a:rPr lang="en-US" sz="1300" dirty="0">
                           <a:solidFill>
                             <a:srgbClr val="17313B"/>
                           </a:solidFill>
@@ -9435,16 +9434,86 @@
                           <a:ea typeface="Aptos" pitchFamily="34" charset="-122"/>
                           <a:cs typeface="Aptos" pitchFamily="34" charset="-120"/>
                         </a:rPr>
-                        <a:t>0.765</a:t>
+                        <a:t>0.585</a:t>
                       </a:r>
-                      <a:endParaRPr lang="en-US" sz="1400" dirty="0">
+                      <a:endParaRPr lang="en-US" sz="1300" dirty="0">
                         <a:latin typeface="Aptos" charset="0"/>
                         <a:ea typeface="Aptos" charset="0"/>
                         <a:cs typeface="Aptos" charset="0"/>
                       </a:endParaRPr>
                     </a:p>
                   </a:txBody>
-                  <a:tcPr marL="54864" marR="54864" marT="54864" marB="54864" anchor="mid">
+                  <a:tcPr marL="45720" marR="45720" marT="45720" marB="45720" anchor="mid">
+                    <a:lnL w="12700" cap="flat" cmpd="sng" algn="ctr">
+                      <a:solidFill>
+                        <a:srgbClr val="C8C1B5"/>
+                      </a:solidFill>
+                      <a:prstDash val="solid"/>
+                      <a:round/>
+                      <a:headEnd type="none" w="med" len="med"/>
+                      <a:tailEnd type="none" w="med" len="med"/>
+                    </a:lnL>
+                    <a:lnR w="12700" cap="flat" cmpd="sng" algn="ctr">
+                      <a:solidFill>
+                        <a:srgbClr val="C8C1B5"/>
+                      </a:solidFill>
+                      <a:prstDash val="solid"/>
+                      <a:round/>
+                      <a:headEnd type="none" w="med" len="med"/>
+                      <a:tailEnd type="none" w="med" len="med"/>
+                    </a:lnR>
+                    <a:lnT w="12700" cap="flat" cmpd="sng" algn="ctr">
+                      <a:solidFill>
+                        <a:srgbClr val="C8C1B5"/>
+                      </a:solidFill>
+                      <a:prstDash val="solid"/>
+                      <a:round/>
+                      <a:headEnd type="none" w="med" len="med"/>
+                      <a:tailEnd type="none" w="med" len="med"/>
+                    </a:lnT>
+                    <a:lnB w="12700" cap="flat" cmpd="sng" algn="ctr">
+                      <a:solidFill>
+                        <a:srgbClr val="C8C1B5"/>
+                      </a:solidFill>
+                      <a:prstDash val="solid"/>
+                      <a:round/>
+                      <a:headEnd type="none" w="med" len="med"/>
+                      <a:tailEnd type="none" w="med" len="med"/>
+                    </a:lnB>
+                    <a:solidFill>
+                      <a:srgbClr val="FFFDF8"/>
+                    </a:solidFill>
+                  </a:tcPr>
+                </a:tc>
+              </a:tr>
+              <a:tr h="621792">
+                <a:tc>
+                  <a:txBody>
+                    <a:bodyPr/>
+                    <a:lstStyle/>
+                    <a:p>
+                      <a:pPr algn="ctr" indent="0" marL="0">
+                        <a:buNone/>
+                      </a:pPr>
+                      <a:r>
+                        <a:rPr lang="en-US" sz="1300" dirty="0">
+                          <a:solidFill>
+                            <a:srgbClr val="17313B"/>
+                          </a:solidFill>
+                          <a:latin typeface="Aptos" pitchFamily="34" charset="0"/>
+                          <a:ea typeface="Aptos" pitchFamily="34" charset="-122"/>
+                          <a:cs typeface="Aptos" pitchFamily="34" charset="-120"/>
+                        </a:rPr>
+                        <a:t>SVM</a:t>
+                      </a:r>
+                      <a:endParaRPr lang="en-US" sz="1300" dirty="0">
+                        <a:latin typeface="Aptos" charset="0"/>
+                        <a:ea typeface="Aptos" charset="0"/>
+                        <a:cs typeface="Aptos" charset="0"/>
+                      </a:endParaRPr>
+                    </a:p>
+                  </a:txBody>
+                  <a:tcPr marL="45720" marR="45720" marT="45720" marB="45720" anchor="mid">
                     <a:lnL w="12700" cap="flat" cmpd="sng" algn="ctr">
                       <a:solidFill>
                         <a:srgbClr val="C8C1B5"/>
@@ -9495,7 +9564,7 @@
                         <a:buNone/>
                       </a:pPr>
                       <a:r>
-                        <a:rPr lang="en-US" sz="1400" dirty="0">
+                        <a:rPr lang="en-US" sz="1300" dirty="0">
                           <a:solidFill>
                             <a:srgbClr val="17313B"/>
                           </a:solidFill>
@@ -9503,16 +9572,16 @@
                           <a:ea typeface="Aptos" pitchFamily="34" charset="-122"/>
                           <a:cs typeface="Aptos" pitchFamily="34" charset="-120"/>
                         </a:rPr>
-                        <a:t>0.646</a:t>
+                        <a:t>FIR</a:t>
                       </a:r>
-                      <a:endParaRPr lang="en-US" sz="1400" dirty="0">
+                      <a:endParaRPr lang="en-US" sz="1300" dirty="0">
                         <a:latin typeface="Aptos" charset="0"/>
                         <a:ea typeface="Aptos" charset="0"/>
                         <a:cs typeface="Aptos" charset="0"/>
                       </a:endParaRPr>
                     </a:p>
                   </a:txBody>
-                  <a:tcPr marL="54864" marR="54864" marT="54864" marB="54864" anchor="mid">
+                  <a:tcPr marL="45720" marR="45720" marT="45720" marB="45720" anchor="mid">
                     <a:lnL w="12700" cap="flat" cmpd="sng" algn="ctr">
                       <a:solidFill>
                         <a:srgbClr val="C8C1B5"/>
@@ -9563,7 +9632,7 @@
                         <a:buNone/>
                       </a:pPr>
                       <a:r>
-                        <a:rPr lang="en-US" sz="1400" dirty="0">
+                        <a:rPr lang="en-US" sz="1300" dirty="0">
                           <a:solidFill>
                             <a:srgbClr val="17313B"/>
                           </a:solidFill>
@@ -9571,86 +9640,16 @@
                           <a:ea typeface="Aptos" pitchFamily="34" charset="-122"/>
                           <a:cs typeface="Aptos" pitchFamily="34" charset="-120"/>
                         </a:rPr>
-                        <a:t>0.644</a:t>
+                        <a:t>Hybrid</a:t>
                       </a:r>
-                      <a:endParaRPr lang="en-US" sz="1400" dirty="0">
+                      <a:endParaRPr lang="en-US" sz="1300" dirty="0">
                         <a:latin typeface="Aptos" charset="0"/>
                         <a:ea typeface="Aptos" charset="0"/>
                         <a:cs typeface="Aptos" charset="0"/>
                       </a:endParaRPr>
                     </a:p>
                   </a:txBody>
-                  <a:tcPr marL="54864" marR="54864" marT="54864" marB="54864" anchor="mid">
-                    <a:lnL w="12700" cap="flat" cmpd="sng" algn="ctr">
-                      <a:solidFill>
-                        <a:srgbClr val="C8C1B5"/>
-                      </a:solidFill>
-                      <a:prstDash val="solid"/>
-                      <a:round/>
-                      <a:headEnd type="none" w="med" len="med"/>
-                      <a:tailEnd type="none" w="med" len="med"/>
-                    </a:lnL>
-                    <a:lnR w="12700" cap="flat" cmpd="sng" algn="ctr">
-                      <a:solidFill>
-                        <a:srgbClr val="C8C1B5"/>
-                      </a:solidFill>
-                      <a:prstDash val="solid"/>
-                      <a:round/>
-                      <a:headEnd type="none" w="med" len="med"/>
-                      <a:tailEnd type="none" w="med" len="med"/>
-                    </a:lnR>
-                    <a:lnT w="12700" cap="flat" cmpd="sng" algn="ctr">
-                      <a:solidFill>
-                        <a:srgbClr val="C8C1B5"/>
-                      </a:solidFill>
-                      <a:prstDash val="solid"/>
-                      <a:round/>
-                      <a:headEnd type="none" w="med" len="med"/>
-                      <a:tailEnd type="none" w="med" len="med"/>
-                    </a:lnT>
-                    <a:lnB w="12700" cap="flat" cmpd="sng" algn="ctr">
-                      <a:solidFill>
-                        <a:srgbClr val="C8C1B5"/>
-                      </a:solidFill>
-                      <a:prstDash val="solid"/>
-                      <a:round/>
-                      <a:headEnd type="none" w="med" len="med"/>
-                      <a:tailEnd type="none" w="med" len="med"/>
-                    </a:lnB>
-                    <a:solidFill>
-                      <a:srgbClr val="FFFDF8"/>
-                    </a:solidFill>
-                  </a:tcPr>
-                </a:tc>
-              </a:tr>
-              <a:tr h="530352">
-                <a:tc>
-                  <a:txBody>
-                    <a:bodyPr/>
-                    <a:lstStyle/>
-                    <a:p>
-                      <a:pPr algn="ctr" indent="0" marL="0">
-                        <a:buNone/>
-                      </a:pPr>
-                      <a:r>
-                        <a:rPr lang="en-US" sz="1400" dirty="0">
-                          <a:solidFill>
-                            <a:srgbClr val="17313B"/>
-                          </a:solidFill>
-                          <a:latin typeface="Aptos" pitchFamily="34" charset="0"/>
-                          <a:ea typeface="Aptos" pitchFamily="34" charset="-122"/>
-                          <a:cs typeface="Aptos" pitchFamily="34" charset="-120"/>
-                        </a:rPr>
-                        <a:t>SVM</a:t>
-                      </a:r>
-                      <a:endParaRPr lang="en-US" sz="1400" dirty="0">
-                        <a:latin typeface="Aptos" charset="0"/>
-                        <a:ea typeface="Aptos" charset="0"/>
-                        <a:cs typeface="Aptos" charset="0"/>
-                      </a:endParaRPr>
-                    </a:p>
-                  </a:txBody>
-                  <a:tcPr marL="54864" marR="54864" marT="54864" marB="54864" anchor="mid">
+                  <a:tcPr marL="45720" marR="45720" marT="45720" marB="45720" anchor="mid">
                     <a:lnL w="12700" cap="flat" cmpd="sng" algn="ctr">
                       <a:solidFill>
                         <a:srgbClr val="C8C1B5"/>
@@ -9701,7 +9700,7 @@
                         <a:buNone/>
                       </a:pPr>
                       <a:r>
-                        <a:rPr lang="en-US" sz="1400" dirty="0">
+                        <a:rPr lang="en-US" sz="1300" dirty="0">
                           <a:solidFill>
                             <a:srgbClr val="17313B"/>
                           </a:solidFill>
@@ -9709,16 +9708,16 @@
                           <a:ea typeface="Aptos" pitchFamily="34" charset="-122"/>
                           <a:cs typeface="Aptos" pitchFamily="34" charset="-120"/>
                         </a:rPr>
-                        <a:t>None</a:t>
+                        <a:t>0.611</a:t>
                       </a:r>
-                      <a:endParaRPr lang="en-US" sz="1400" dirty="0">
+                      <a:endParaRPr lang="en-US" sz="1300" dirty="0">
                         <a:latin typeface="Aptos" charset="0"/>
                         <a:ea typeface="Aptos" charset="0"/>
                         <a:cs typeface="Aptos" charset="0"/>
                       </a:endParaRPr>
                     </a:p>
                   </a:txBody>
-                  <a:tcPr marL="54864" marR="54864" marT="54864" marB="54864" anchor="mid">
+                  <a:tcPr marL="45720" marR="45720" marT="45720" marB="45720" anchor="mid">
                     <a:lnL w="12700" cap="flat" cmpd="sng" algn="ctr">
                       <a:solidFill>
                         <a:srgbClr val="C8C1B5"/>
@@ -9769,7 +9768,7 @@
                         <a:buNone/>
                       </a:pPr>
                       <a:r>
-                        <a:rPr lang="en-US" sz="1400" dirty="0">
+                        <a:rPr lang="en-US" sz="1300" dirty="0">
                           <a:solidFill>
                             <a:srgbClr val="17313B"/>
                           </a:solidFill>
@@ -9777,16 +9776,16 @@
                           <a:ea typeface="Aptos" pitchFamily="34" charset="-122"/>
                           <a:cs typeface="Aptos" pitchFamily="34" charset="-120"/>
                         </a:rPr>
-                        <a:t>MFCC</a:t>
+                        <a:t>0.544</a:t>
                       </a:r>
-                      <a:endParaRPr lang="en-US" sz="1400" dirty="0">
+                      <a:endParaRPr lang="en-US" sz="1300" dirty="0">
                         <a:latin typeface="Aptos" charset="0"/>
                         <a:ea typeface="Aptos" charset="0"/>
                         <a:cs typeface="Aptos" charset="0"/>
                       </a:endParaRPr>
                     </a:p>
                   </a:txBody>
-                  <a:tcPr marL="54864" marR="54864" marT="54864" marB="54864" anchor="mid">
+                  <a:tcPr marL="45720" marR="45720" marT="45720" marB="45720" anchor="mid">
                     <a:lnL w="12700" cap="flat" cmpd="sng" algn="ctr">
                       <a:solidFill>
                         <a:srgbClr val="C8C1B5"/>
@@ -9837,7 +9836,7 @@
                         <a:buNone/>
                       </a:pPr>
                       <a:r>
-                        <a:rPr lang="en-US" sz="1400" dirty="0">
+                        <a:rPr lang="en-US" sz="1300" dirty="0">
                           <a:solidFill>
                             <a:srgbClr val="17313B"/>
                           </a:solidFill>
@@ -9845,16 +9844,16 @@
                           <a:ea typeface="Aptos" pitchFamily="34" charset="-122"/>
                           <a:cs typeface="Aptos" pitchFamily="34" charset="-120"/>
                         </a:rPr>
-                        <a:t>0.742</a:t>
+                        <a:t>0.763</a:t>
                       </a:r>
-                      <a:endParaRPr lang="en-US" sz="1400" dirty="0">
+                      <a:endParaRPr lang="en-US" sz="1300" dirty="0">
                         <a:latin typeface="Aptos" charset="0"/>
                         <a:ea typeface="Aptos" charset="0"/>
                         <a:cs typeface="Aptos" charset="0"/>
                       </a:endParaRPr>
                     </a:p>
                   </a:txBody>
-                  <a:tcPr marL="54864" marR="54864" marT="54864" marB="54864" anchor="mid">
+                  <a:tcPr marL="45720" marR="45720" marT="45720" marB="45720" anchor="mid">
                     <a:lnL w="12700" cap="flat" cmpd="sng" algn="ctr">
                       <a:solidFill>
                         <a:srgbClr val="C8C1B5"/>
@@ -9905,7 +9904,7 @@
                         <a:buNone/>
                       </a:pPr>
                       <a:r>
-                        <a:rPr lang="en-US" sz="1400" dirty="0">
+                        <a:rPr lang="en-US" sz="1300" dirty="0">
                           <a:solidFill>
                             <a:srgbClr val="17313B"/>
                           </a:solidFill>
@@ -9913,16 +9912,86 @@
                           <a:ea typeface="Aptos" pitchFamily="34" charset="-122"/>
                           <a:cs typeface="Aptos" pitchFamily="34" charset="-120"/>
                         </a:rPr>
-                        <a:t>0.659</a:t>
+                        <a:t>0.558</a:t>
                       </a:r>
-                      <a:endParaRPr lang="en-US" sz="1400" dirty="0">
+                      <a:endParaRPr lang="en-US" sz="1300" dirty="0">
                         <a:latin typeface="Aptos" charset="0"/>
                         <a:ea typeface="Aptos" charset="0"/>
                         <a:cs typeface="Aptos" charset="0"/>
                       </a:endParaRPr>
                     </a:p>
                   </a:txBody>
-                  <a:tcPr marL="54864" marR="54864" marT="54864" marB="54864" anchor="mid">
+                  <a:tcPr marL="45720" marR="45720" marT="45720" marB="45720" anchor="mid">
+                    <a:lnL w="12700" cap="flat" cmpd="sng" algn="ctr">
+                      <a:solidFill>
+                        <a:srgbClr val="C8C1B5"/>
+                      </a:solidFill>
+                      <a:prstDash val="solid"/>
+                      <a:round/>
+                      <a:headEnd type="none" w="med" len="med"/>
+                      <a:tailEnd type="none" w="med" len="med"/>
+                    </a:lnL>
+                    <a:lnR w="12700" cap="flat" cmpd="sng" algn="ctr">
+                      <a:solidFill>
+                        <a:srgbClr val="C8C1B5"/>
+                      </a:solidFill>
+                      <a:prstDash val="solid"/>
+                      <a:round/>
+                      <a:headEnd type="none" w="med" len="med"/>
+                      <a:tailEnd type="none" w="med" len="med"/>
+                    </a:lnR>
+                    <a:lnT w="12700" cap="flat" cmpd="sng" algn="ctr">
+                      <a:solidFill>
+                        <a:srgbClr val="C8C1B5"/>
+                      </a:solidFill>
+                      <a:prstDash val="solid"/>
+                      <a:round/>
+                      <a:headEnd type="none" w="med" len="med"/>
+                      <a:tailEnd type="none" w="med" len="med"/>
+                    </a:lnT>
+                    <a:lnB w="12700" cap="flat" cmpd="sng" algn="ctr">
+                      <a:solidFill>
+                        <a:srgbClr val="C8C1B5"/>
+                      </a:solidFill>
+                      <a:prstDash val="solid"/>
+                      <a:round/>
+                      <a:headEnd type="none" w="med" len="med"/>
+                      <a:tailEnd type="none" w="med" len="med"/>
+                    </a:lnB>
+                    <a:solidFill>
+                      <a:srgbClr val="FFFDF8"/>
+                    </a:solidFill>
+                  </a:tcPr>
+                </a:tc>
+              </a:tr>
+              <a:tr h="621792">
+                <a:tc>
+                  <a:txBody>
+                    <a:bodyPr/>
+                    <a:lstStyle/>
+                    <a:p>
+                      <a:pPr algn="ctr" indent="0" marL="0">
+                        <a:buNone/>
+                      </a:pPr>
+                      <a:r>
+                        <a:rPr lang="en-US" sz="1300" dirty="0">
+                          <a:solidFill>
+                            <a:srgbClr val="17313B"/>
+                          </a:solidFill>
+                          <a:latin typeface="Aptos" pitchFamily="34" charset="0"/>
+                          <a:ea typeface="Aptos" pitchFamily="34" charset="-122"/>
+                          <a:cs typeface="Aptos" pitchFamily="34" charset="-120"/>
+                        </a:rPr>
+                        <a:t>SVM</a:t>
+                      </a:r>
+                      <a:endParaRPr lang="en-US" sz="1300" dirty="0">
+                        <a:latin typeface="Aptos" charset="0"/>
+                        <a:ea typeface="Aptos" charset="0"/>
+                        <a:cs typeface="Aptos" charset="0"/>
+                      </a:endParaRPr>
+                    </a:p>
+                  </a:txBody>
+                  <a:tcPr marL="45720" marR="45720" marT="45720" marB="45720" anchor="mid">
                     <a:lnL w="12700" cap="flat" cmpd="sng" algn="ctr">
                       <a:solidFill>
                         <a:srgbClr val="C8C1B5"/>
@@ -9973,7 +10042,7 @@
                         <a:buNone/>
                       </a:pPr>
                       <a:r>
-                        <a:rPr lang="en-US" sz="1400" dirty="0">
+                        <a:rPr lang="en-US" sz="1300" dirty="0">
                           <a:solidFill>
                             <a:srgbClr val="17313B"/>
                           </a:solidFill>
@@ -9981,86 +10050,16 @@
                           <a:ea typeface="Aptos" pitchFamily="34" charset="-122"/>
                           <a:cs typeface="Aptos" pitchFamily="34" charset="-120"/>
                         </a:rPr>
-                        <a:t>0.642</a:t>
+                        <a:t>Butterworth</a:t>
                       </a:r>
-                      <a:endParaRPr lang="en-US" sz="1400" dirty="0">
+                      <a:endParaRPr lang="en-US" sz="1300" dirty="0">
                         <a:latin typeface="Aptos" charset="0"/>
                         <a:ea typeface="Aptos" charset="0"/>
                         <a:cs typeface="Aptos" charset="0"/>
                       </a:endParaRPr>
                     </a:p>
                   </a:txBody>
-                  <a:tcPr marL="54864" marR="54864" marT="54864" marB="54864" anchor="mid">
-                    <a:lnL w="12700" cap="flat" cmpd="sng" algn="ctr">
-                      <a:solidFill>
-                        <a:srgbClr val="C8C1B5"/>
-                      </a:solidFill>
-                      <a:prstDash val="solid"/>
-                      <a:round/>
-                      <a:headEnd type="none" w="med" len="med"/>
-                      <a:tailEnd type="none" w="med" len="med"/>
-                    </a:lnL>
-                    <a:lnR w="12700" cap="flat" cmpd="sng" algn="ctr">
-                      <a:solidFill>
-                        <a:srgbClr val="C8C1B5"/>
-                      </a:solidFill>
-                      <a:prstDash val="solid"/>
-                      <a:round/>
-                      <a:headEnd type="none" w="med" len="med"/>
-                      <a:tailEnd type="none" w="med" len="med"/>
-                    </a:lnR>
-                    <a:lnT w="12700" cap="flat" cmpd="sng" algn="ctr">
-                      <a:solidFill>
-                        <a:srgbClr val="C8C1B5"/>
-                      </a:solidFill>
-                      <a:prstDash val="solid"/>
-                      <a:round/>
-                      <a:headEnd type="none" w="med" len="med"/>
-                      <a:tailEnd type="none" w="med" len="med"/>
-                    </a:lnT>
-                    <a:lnB w="12700" cap="flat" cmpd="sng" algn="ctr">
-                      <a:solidFill>
-                        <a:srgbClr val="C8C1B5"/>
-                      </a:solidFill>
-                      <a:prstDash val="solid"/>
-                      <a:round/>
-                      <a:headEnd type="none" w="med" len="med"/>
-                      <a:tailEnd type="none" w="med" len="med"/>
-                    </a:lnB>
-                    <a:solidFill>
-                      <a:srgbClr val="FFFDF8"/>
-                    </a:solidFill>
-                  </a:tcPr>
-                </a:tc>
-              </a:tr>
-              <a:tr h="530352">
-                <a:tc>
-                  <a:txBody>
-                    <a:bodyPr/>
-                    <a:lstStyle/>
-                    <a:p>
-                      <a:pPr algn="ctr" indent="0" marL="0">
-                        <a:buNone/>
-                      </a:pPr>
-                      <a:r>
-                        <a:rPr lang="en-US" sz="1400" dirty="0">
-                          <a:solidFill>
-                            <a:srgbClr val="17313B"/>
-                          </a:solidFill>
-                          <a:latin typeface="Aptos" pitchFamily="34" charset="0"/>
-                          <a:ea typeface="Aptos" pitchFamily="34" charset="-122"/>
-                          <a:cs typeface="Aptos" pitchFamily="34" charset="-120"/>
-                        </a:rPr>
-                        <a:t>SVM</a:t>
-                      </a:r>
-                      <a:endParaRPr lang="en-US" sz="1400" dirty="0">
-                        <a:latin typeface="Aptos" charset="0"/>
-                        <a:ea typeface="Aptos" charset="0"/>
-                        <a:cs typeface="Aptos" charset="0"/>
-                      </a:endParaRPr>
-                    </a:p>
-                  </a:txBody>
-                  <a:tcPr marL="54864" marR="54864" marT="54864" marB="54864" anchor="mid">
+                  <a:tcPr marL="45720" marR="45720" marT="45720" marB="45720" anchor="mid">
                     <a:lnL w="12700" cap="flat" cmpd="sng" algn="ctr">
                       <a:solidFill>
                         <a:srgbClr val="C8C1B5"/>
@@ -10111,7 +10110,7 @@
                         <a:buNone/>
                       </a:pPr>
                       <a:r>
-                        <a:rPr lang="en-US" sz="1400" dirty="0">
+                        <a:rPr lang="en-US" sz="1300" dirty="0">
                           <a:solidFill>
                             <a:srgbClr val="17313B"/>
                           </a:solidFill>
@@ -10119,16 +10118,16 @@
                           <a:ea typeface="Aptos" pitchFamily="34" charset="-122"/>
                           <a:cs typeface="Aptos" pitchFamily="34" charset="-120"/>
                         </a:rPr>
-                        <a:t>FIR</a:t>
+                        <a:t>MFCC</a:t>
                       </a:r>
-                      <a:endParaRPr lang="en-US" sz="1400" dirty="0">
+                      <a:endParaRPr lang="en-US" sz="1300" dirty="0">
                         <a:latin typeface="Aptos" charset="0"/>
                         <a:ea typeface="Aptos" charset="0"/>
                         <a:cs typeface="Aptos" charset="0"/>
                       </a:endParaRPr>
                     </a:p>
                   </a:txBody>
-                  <a:tcPr marL="54864" marR="54864" marT="54864" marB="54864" anchor="mid">
+                  <a:tcPr marL="45720" marR="45720" marT="45720" marB="45720" anchor="mid">
                     <a:lnL w="12700" cap="flat" cmpd="sng" algn="ctr">
                       <a:solidFill>
                         <a:srgbClr val="C8C1B5"/>
@@ -10179,7 +10178,7 @@
                         <a:buNone/>
                       </a:pPr>
                       <a:r>
-                        <a:rPr lang="en-US" sz="1400" dirty="0">
+                        <a:rPr lang="en-US" sz="1300" dirty="0">
                           <a:solidFill>
                             <a:srgbClr val="17313B"/>
                           </a:solidFill>
@@ -10187,16 +10186,16 @@
                           <a:ea typeface="Aptos" pitchFamily="34" charset="-122"/>
                           <a:cs typeface="Aptos" pitchFamily="34" charset="-120"/>
                         </a:rPr>
-                        <a:t>MFCC</a:t>
+                        <a:t>0.596</a:t>
                       </a:r>
-                      <a:endParaRPr lang="en-US" sz="1400" dirty="0">
+                      <a:endParaRPr lang="en-US" sz="1300" dirty="0">
                         <a:latin typeface="Aptos" charset="0"/>
                         <a:ea typeface="Aptos" charset="0"/>
                         <a:cs typeface="Aptos" charset="0"/>
                       </a:endParaRPr>
                     </a:p>
                   </a:txBody>
-                  <a:tcPr marL="54864" marR="54864" marT="54864" marB="54864" anchor="mid">
+                  <a:tcPr marL="45720" marR="45720" marT="45720" marB="45720" anchor="mid">
                     <a:lnL w="12700" cap="flat" cmpd="sng" algn="ctr">
                       <a:solidFill>
                         <a:srgbClr val="C8C1B5"/>
@@ -10247,7 +10246,7 @@
                         <a:buNone/>
                       </a:pPr>
                       <a:r>
-                        <a:rPr lang="en-US" sz="1400" dirty="0">
+                        <a:rPr lang="en-US" sz="1300" dirty="0">
                           <a:solidFill>
                             <a:srgbClr val="17313B"/>
                           </a:solidFill>
@@ -10255,16 +10254,16 @@
                           <a:ea typeface="Aptos" pitchFamily="34" charset="-122"/>
                           <a:cs typeface="Aptos" pitchFamily="34" charset="-120"/>
                         </a:rPr>
-                        <a:t>0.758</a:t>
+                        <a:t>0.533</a:t>
                       </a:r>
-                      <a:endParaRPr lang="en-US" sz="1400" dirty="0">
+                      <a:endParaRPr lang="en-US" sz="1300" dirty="0">
                         <a:latin typeface="Aptos" charset="0"/>
                         <a:ea typeface="Aptos" charset="0"/>
                         <a:cs typeface="Aptos" charset="0"/>
                       </a:endParaRPr>
                     </a:p>
                   </a:txBody>
-                  <a:tcPr marL="54864" marR="54864" marT="54864" marB="54864" anchor="mid">
+                  <a:tcPr marL="45720" marR="45720" marT="45720" marB="45720" anchor="mid">
                     <a:lnL w="12700" cap="flat" cmpd="sng" algn="ctr">
                       <a:solidFill>
                         <a:srgbClr val="C8C1B5"/>
@@ -10315,7 +10314,7 @@
                         <a:buNone/>
                       </a:pPr>
                       <a:r>
-                        <a:rPr lang="en-US" sz="1400" dirty="0">
+                        <a:rPr lang="en-US" sz="1300" dirty="0">
                           <a:solidFill>
                             <a:srgbClr val="17313B"/>
                           </a:solidFill>
@@ -10323,16 +10322,16 @@
                           <a:ea typeface="Aptos" pitchFamily="34" charset="-122"/>
                           <a:cs typeface="Aptos" pitchFamily="34" charset="-120"/>
                         </a:rPr>
-                        <a:t>0.628</a:t>
+                        <a:t>0.759</a:t>
                       </a:r>
-                      <a:endParaRPr lang="en-US" sz="1400" dirty="0">
+                      <a:endParaRPr lang="en-US" sz="1300" dirty="0">
                         <a:latin typeface="Aptos" charset="0"/>
                         <a:ea typeface="Aptos" charset="0"/>
                         <a:cs typeface="Aptos" charset="0"/>
                       </a:endParaRPr>
                     </a:p>
                   </a:txBody>
-                  <a:tcPr marL="54864" marR="54864" marT="54864" marB="54864" anchor="mid">
+                  <a:tcPr marL="45720" marR="45720" marT="45720" marB="45720" anchor="mid">
                     <a:lnL w="12700" cap="flat" cmpd="sng" algn="ctr">
                       <a:solidFill>
                         <a:srgbClr val="C8C1B5"/>
@@ -10383,7 +10382,7 @@
                         <a:buNone/>
                       </a:pPr>
                       <a:r>
-                        <a:rPr lang="en-US" sz="1400" dirty="0">
+                        <a:rPr lang="en-US" sz="1300" dirty="0">
                           <a:solidFill>
                             <a:srgbClr val="17313B"/>
                           </a:solidFill>
@@ -10391,16 +10390,16 @@
                           <a:ea typeface="Aptos" pitchFamily="34" charset="-122"/>
                           <a:cs typeface="Aptos" pitchFamily="34" charset="-120"/>
                         </a:rPr>
-                        <a:t>0.628</a:t>
+                        <a:t>0.541</a:t>
                       </a:r>
-                      <a:endParaRPr lang="en-US" sz="1400" dirty="0">
+                      <a:endParaRPr lang="en-US" sz="1300" dirty="0">
                         <a:latin typeface="Aptos" charset="0"/>
                         <a:ea typeface="Aptos" charset="0"/>
                         <a:cs typeface="Aptos" charset="0"/>
                       </a:endParaRPr>
                     </a:p>
                   </a:txBody>
-                  <a:tcPr marL="54864" marR="54864" marT="54864" marB="54864" anchor="mid">
+                  <a:tcPr marL="45720" marR="45720" marT="45720" marB="45720" anchor="mid">
                     <a:lnL w="12700" cap="flat" cmpd="sng" algn="ctr">
                       <a:solidFill>
                         <a:srgbClr val="C8C1B5"/>
@@ -10443,7 +10442,7 @@
                   </a:tcPr>
                 </a:tc>
               </a:tr>
-              <a:tr h="530352">
+              <a:tr h="621792">
                 <a:tc>
                   <a:txBody>
                     <a:bodyPr/>
@@ -10453,7 +10452,7 @@
                         <a:buNone/>
                       </a:pPr>
                       <a:r>
-                        <a:rPr lang="en-US" sz="1400" dirty="0">
+                        <a:rPr lang="en-US" sz="1300" dirty="0">
                           <a:solidFill>
                             <a:srgbClr val="17313B"/>
                           </a:solidFill>
@@ -10461,16 +10460,16 @@
                           <a:ea typeface="Aptos" pitchFamily="34" charset="-122"/>
                           <a:cs typeface="Aptos" pitchFamily="34" charset="-120"/>
                         </a:rPr>
-                        <a:t>SVM</a:t>
+                        <a:t>MLP</a:t>
                       </a:r>
-                      <a:endParaRPr lang="en-US" sz="1400" dirty="0">
+                      <a:endParaRPr lang="en-US" sz="1300" dirty="0">
                         <a:latin typeface="Aptos" charset="0"/>
                         <a:ea typeface="Aptos" charset="0"/>
                         <a:cs typeface="Aptos" charset="0"/>
                       </a:endParaRPr>
                     </a:p>
                   </a:txBody>
-                  <a:tcPr marL="54864" marR="54864" marT="54864" marB="54864" anchor="mid">
+                  <a:tcPr marL="45720" marR="45720" marT="45720" marB="45720" anchor="mid">
                     <a:lnL w="12700" cap="flat" cmpd="sng" algn="ctr">
                       <a:solidFill>
                         <a:srgbClr val="C8C1B5"/>
@@ -10521,7 +10520,7 @@
                         <a:buNone/>
                       </a:pPr>
                       <a:r>
-                        <a:rPr lang="en-US" sz="1400" dirty="0">
+                        <a:rPr lang="en-US" sz="1300" dirty="0">
                           <a:solidFill>
                             <a:srgbClr val="17313B"/>
                           </a:solidFill>
@@ -10529,16 +10528,16 @@
                           <a:ea typeface="Aptos" pitchFamily="34" charset="-122"/>
                           <a:cs typeface="Aptos" pitchFamily="34" charset="-120"/>
                         </a:rPr>
-                        <a:t>Butterworth</a:t>
+                        <a:t>FIR</a:t>
                       </a:r>
-                      <a:endParaRPr lang="en-US" sz="1400" dirty="0">
+                      <a:endParaRPr lang="en-US" sz="1300" dirty="0">
                         <a:latin typeface="Aptos" charset="0"/>
                         <a:ea typeface="Aptos" charset="0"/>
                         <a:cs typeface="Aptos" charset="0"/>
                       </a:endParaRPr>
                     </a:p>
                   </a:txBody>
-                  <a:tcPr marL="54864" marR="54864" marT="54864" marB="54864" anchor="mid">
+                  <a:tcPr marL="45720" marR="45720" marT="45720" marB="45720" anchor="mid">
                     <a:lnL w="12700" cap="flat" cmpd="sng" algn="ctr">
                       <a:solidFill>
                         <a:srgbClr val="C8C1B5"/>
@@ -10589,7 +10588,7 @@
                         <a:buNone/>
                       </a:pPr>
                       <a:r>
-                        <a:rPr lang="en-US" sz="1400" dirty="0">
+                        <a:rPr lang="en-US" sz="1300" dirty="0">
                           <a:solidFill>
                             <a:srgbClr val="17313B"/>
                           </a:solidFill>
@@ -10599,14 +10598,14 @@
                         </a:rPr>
                         <a:t>Hybrid</a:t>
                       </a:r>
-                      <a:endParaRPr lang="en-US" sz="1400" dirty="0">
+                      <a:endParaRPr lang="en-US" sz="1300" dirty="0">
                         <a:latin typeface="Aptos" charset="0"/>
                         <a:ea typeface="Aptos" charset="0"/>
                         <a:cs typeface="Aptos" charset="0"/>
                       </a:endParaRPr>
                     </a:p>
                   </a:txBody>
-                  <a:tcPr marL="54864" marR="54864" marT="54864" marB="54864" anchor="mid">
+                  <a:tcPr marL="45720" marR="45720" marT="45720" marB="45720" anchor="mid">
                     <a:lnL w="12700" cap="flat" cmpd="sng" algn="ctr">
                       <a:solidFill>
                         <a:srgbClr val="C8C1B5"/>
@@ -10657,7 +10656,7 @@
                         <a:buNone/>
                       </a:pPr>
                       <a:r>
-                        <a:rPr lang="en-US" sz="1400" dirty="0">
+                        <a:rPr lang="en-US" sz="1300" dirty="0">
                           <a:solidFill>
                             <a:srgbClr val="17313B"/>
                           </a:solidFill>
@@ -10665,16 +10664,16 @@
                           <a:ea typeface="Aptos" pitchFamily="34" charset="-122"/>
                           <a:cs typeface="Aptos" pitchFamily="34" charset="-120"/>
                         </a:rPr>
-                        <a:t>0.742</a:t>
+                        <a:t>0.564</a:t>
                       </a:r>
-                      <a:endParaRPr lang="en-US" sz="1400" dirty="0">
+                      <a:endParaRPr lang="en-US" sz="1300" dirty="0">
                         <a:latin typeface="Aptos" charset="0"/>
                         <a:ea typeface="Aptos" charset="0"/>
                         <a:cs typeface="Aptos" charset="0"/>
                       </a:endParaRPr>
                     </a:p>
                   </a:txBody>
-                  <a:tcPr marL="54864" marR="54864" marT="54864" marB="54864" anchor="mid">
+                  <a:tcPr marL="45720" marR="45720" marT="45720" marB="45720" anchor="mid">
                     <a:lnL w="12700" cap="flat" cmpd="sng" algn="ctr">
                       <a:solidFill>
                         <a:srgbClr val="C8C1B5"/>
@@ -10725,7 +10724,7 @@
                         <a:buNone/>
                       </a:pPr>
                       <a:r>
-                        <a:rPr lang="en-US" sz="1400" dirty="0">
+                        <a:rPr lang="en-US" sz="1300" dirty="0">
                           <a:solidFill>
                             <a:srgbClr val="17313B"/>
                           </a:solidFill>
@@ -10733,16 +10732,16 @@
                           <a:ea typeface="Aptos" pitchFamily="34" charset="-122"/>
                           <a:cs typeface="Aptos" pitchFamily="34" charset="-120"/>
                         </a:rPr>
-                        <a:t>0.618</a:t>
+                        <a:t>0.461</a:t>
                       </a:r>
-                      <a:endParaRPr lang="en-US" sz="1400" dirty="0">
+                      <a:endParaRPr lang="en-US" sz="1300" dirty="0">
                         <a:latin typeface="Aptos" charset="0"/>
                         <a:ea typeface="Aptos" charset="0"/>
                         <a:cs typeface="Aptos" charset="0"/>
                       </a:endParaRPr>
                     </a:p>
                   </a:txBody>
-                  <a:tcPr marL="54864" marR="54864" marT="54864" marB="54864" anchor="mid">
+                  <a:tcPr marL="45720" marR="45720" marT="45720" marB="45720" anchor="mid">
                     <a:lnL w="12700" cap="flat" cmpd="sng" algn="ctr">
                       <a:solidFill>
                         <a:srgbClr val="C8C1B5"/>
@@ -10793,7 +10792,7 @@
                         <a:buNone/>
                       </a:pPr>
                       <a:r>
-                        <a:rPr lang="en-US" sz="1400" dirty="0">
+                        <a:rPr lang="en-US" sz="1300" dirty="0">
                           <a:solidFill>
                             <a:srgbClr val="17313B"/>
                           </a:solidFill>
@@ -10801,16 +10800,84 @@
                           <a:ea typeface="Aptos" pitchFamily="34" charset="-122"/>
                           <a:cs typeface="Aptos" pitchFamily="34" charset="-120"/>
                         </a:rPr>
-                        <a:t>0.615</a:t>
+                        <a:t>0.793</a:t>
                       </a:r>
-                      <a:endParaRPr lang="en-US" sz="1400" dirty="0">
+                      <a:endParaRPr lang="en-US" sz="1300" dirty="0">
                         <a:latin typeface="Aptos" charset="0"/>
                         <a:ea typeface="Aptos" charset="0"/>
                         <a:cs typeface="Aptos" charset="0"/>
                       </a:endParaRPr>
                     </a:p>
                   </a:txBody>
-                  <a:tcPr marL="54864" marR="54864" marT="54864" marB="54864" anchor="mid">
+                  <a:tcPr marL="45720" marR="45720" marT="45720" marB="45720" anchor="mid">
+                    <a:lnL w="12700" cap="flat" cmpd="sng" algn="ctr">
+                      <a:solidFill>
+                        <a:srgbClr val="C8C1B5"/>
+                      </a:solidFill>
+                      <a:prstDash val="solid"/>
+                      <a:round/>
+                      <a:headEnd type="none" w="med" len="med"/>
+                      <a:tailEnd type="none" w="med" len="med"/>
+                    </a:lnL>
+                    <a:lnR w="12700" cap="flat" cmpd="sng" algn="ctr">
+                      <a:solidFill>
+                        <a:srgbClr val="C8C1B5"/>
+                      </a:solidFill>
+                      <a:prstDash val="solid"/>
+                      <a:round/>
+                      <a:headEnd type="none" w="med" len="med"/>
+                      <a:tailEnd type="none" w="med" len="med"/>
+                    </a:lnR>
+                    <a:lnT w="12700" cap="flat" cmpd="sng" algn="ctr">
+                      <a:solidFill>
+                        <a:srgbClr val="C8C1B5"/>
+                      </a:solidFill>
+                      <a:prstDash val="solid"/>
+                      <a:round/>
+                      <a:headEnd type="none" w="med" len="med"/>
+                      <a:tailEnd type="none" w="med" len="med"/>
+                    </a:lnT>
+                    <a:lnB w="12700" cap="flat" cmpd="sng" algn="ctr">
+                      <a:solidFill>
+                        <a:srgbClr val="C8C1B5"/>
+                      </a:solidFill>
+                      <a:prstDash val="solid"/>
+                      <a:round/>
+                      <a:headEnd type="none" w="med" len="med"/>
+                      <a:tailEnd type="none" w="med" len="med"/>
+                    </a:lnB>
+                    <a:solidFill>
+                      <a:srgbClr val="FFFDF8"/>
+                    </a:solidFill>
+                  </a:tcPr>
+                </a:tc>
+                <a:tc>
+                  <a:txBody>
+                    <a:bodyPr/>
+                    <a:lstStyle/>
+                    <a:p>
+                      <a:pPr algn="ctr" indent="0" marL="0">
+                        <a:buNone/>
+                      </a:pPr>
+                      <a:r>
+                        <a:rPr lang="en-US" sz="1300" dirty="0">
+                          <a:solidFill>
+                            <a:srgbClr val="17313B"/>
+                          </a:solidFill>
+                          <a:latin typeface="Aptos" pitchFamily="34" charset="0"/>
+                          <a:ea typeface="Aptos" pitchFamily="34" charset="-122"/>
+                          <a:cs typeface="Aptos" pitchFamily="34" charset="-120"/>
+                        </a:rPr>
+                        <a:t>0.590</a:t>
+                      </a:r>
+                      <a:endParaRPr lang="en-US" sz="1300" dirty="0">
+                        <a:latin typeface="Aptos" charset="0"/>
+                        <a:ea typeface="Aptos" charset="0"/>
+                        <a:cs typeface="Aptos" charset="0"/>
+                      </a:endParaRPr>
+                    </a:p>
+                  </a:txBody>
+                  <a:tcPr marL="45720" marR="45720" marT="45720" marB="45720" anchor="mid">
                     <a:lnL w="12700" cap="flat" cmpd="sng" algn="ctr">
                       <a:solidFill>
                         <a:srgbClr val="C8C1B5"/>
@@ -10865,8 +10932,8 @@
         </p:nvSpPr>
         <p:spPr>
           <a:xfrm>
-            <a:off x="9006840" y="1691640"/>
-            <a:ext cx="2240280" cy="1325880"/>
+            <a:off x="9189720" y="1691640"/>
+            <a:ext cx="2057400" cy="1325880"/>
           </a:xfrm>
           <a:prstGeom prst="rect">
             <a:avLst/>
@@ -10890,8 +10957,181 @@
         </p:nvSpPr>
         <p:spPr>
           <a:xfrm>
-            <a:off x="9006840" y="1691640"/>
-            <a:ext cx="2240280" cy="73152"/>
+            <a:off x="9189720" y="1691640"/>
+            <a:ext cx="2057400" cy="73152"/>
+          </a:xfrm>
+          <a:prstGeom prst="rect">
+            <a:avLst/>
+          </a:prstGeom>
+          <a:solidFill>
+            <a:srgbClr val="2B7A78"/>
+          </a:solidFill>
+          <a:ln w="12700">
+            <a:solidFill>
+              <a:srgbClr val="2B7A78"/>
+            </a:solidFill>
+            <a:prstDash val="solid"/>
+          </a:ln>
+        </p:spPr>
+      </p:sp>
+      <p:sp>
+        <p:nvSpPr>
+          <p:cNvPr id="10" name="Text 7"/>
+          <p:cNvSpPr/>
+          <p:nvPr/>
+        </p:nvSpPr>
+        <p:spPr>
+          <a:xfrm>
+            <a:off x="9418320" y="1856232"/>
+            <a:ext cx="1691640" cy="420624"/>
+          </a:xfrm>
+          <a:prstGeom prst="rect">
+            <a:avLst/>
+          </a:prstGeom>
+          <a:noFill/>
+          <a:ln/>
+        </p:spPr>
+        <p:txBody>
+          <a:bodyPr wrap="square" lIns="0" tIns="0" rIns="0" bIns="0" rtlCol="0" anchor="t">
+            <a:normAutofit/>
+          </a:bodyPr>
+          <a:lstStyle/>
+          <a:p>
+            <a:pPr algn="l" indent="0" marL="0">
+              <a:buNone/>
+            </a:pPr>
+            <a:r>
+              <a:rPr lang="en-US" sz="2700" b="1" dirty="0">
+                <a:solidFill>
+                  <a:srgbClr val="2B7A78"/>
+                </a:solidFill>
+                <a:latin typeface="Aptos" pitchFamily="34" charset="0"/>
+                <a:ea typeface="Aptos" pitchFamily="34" charset="-122"/>
+                <a:cs typeface="Aptos" pitchFamily="34" charset="-120"/>
+              </a:rPr>
+              <a:t>0.644</a:t>
+            </a:r>
+            <a:endParaRPr lang="en-US" sz="2700" dirty="0"/>
+          </a:p>
+        </p:txBody>
+      </p:sp>
+      <p:sp>
+        <p:nvSpPr>
+          <p:cNvPr id="11" name="Text 8"/>
+          <p:cNvSpPr/>
+          <p:nvPr/>
+        </p:nvSpPr>
+        <p:spPr>
+          <a:xfrm>
+            <a:off x="9418320" y="2350008"/>
+            <a:ext cx="1691640" cy="256032"/>
+          </a:xfrm>
+          <a:prstGeom prst="rect">
+            <a:avLst/>
+          </a:prstGeom>
+          <a:noFill/>
+          <a:ln/>
+        </p:spPr>
+        <p:txBody>
+          <a:bodyPr wrap="square" lIns="0" tIns="0" rIns="0" bIns="0" rtlCol="0" anchor="t">
+            <a:normAutofit/>
+          </a:bodyPr>
+          <a:lstStyle/>
+          <a:p>
+            <a:pPr algn="l" indent="0" marL="0">
+              <a:buNone/>
+            </a:pPr>
+            <a:r>
+              <a:rPr lang="en-US" sz="1500" b="1" dirty="0">
+                <a:solidFill>
+                  <a:srgbClr val="17313B"/>
+                </a:solidFill>
+                <a:latin typeface="Georgia" pitchFamily="34" charset="0"/>
+                <a:ea typeface="Georgia" pitchFamily="34" charset="-122"/>
+                <a:cs typeface="Georgia" pitchFamily="34" charset="-120"/>
+              </a:rPr>
+              <a:t>Best DSP WAcc</a:t>
+            </a:r>
+            <a:endParaRPr lang="en-US" sz="1500" dirty="0"/>
+          </a:p>
+        </p:txBody>
+      </p:sp>
+      <p:sp>
+        <p:nvSpPr>
+          <p:cNvPr id="12" name="Text 9"/>
+          <p:cNvSpPr/>
+          <p:nvPr/>
+        </p:nvSpPr>
+        <p:spPr>
+          <a:xfrm>
+            <a:off x="9418320" y="2642616"/>
+            <a:ext cx="1691640" cy="274320"/>
+          </a:xfrm>
+          <a:prstGeom prst="rect">
+            <a:avLst/>
+          </a:prstGeom>
+          <a:noFill/>
+          <a:ln/>
+        </p:spPr>
+        <p:txBody>
+          <a:bodyPr wrap="square" lIns="0" tIns="0" rIns="0" bIns="0" rtlCol="0" anchor="t">
+            <a:normAutofit/>
+          </a:bodyPr>
+          <a:lstStyle/>
+          <a:p>
+            <a:pPr algn="l" indent="0" marL="0">
+              <a:buNone/>
+            </a:pPr>
+            <a:r>
+              <a:rPr lang="en-US" sz="1300" dirty="0">
+                <a:solidFill>
+                  <a:srgbClr val="6D7775"/>
+                </a:solidFill>
+                <a:latin typeface="Aptos" pitchFamily="34" charset="0"/>
+                <a:ea typeface="Aptos" pitchFamily="34" charset="-122"/>
+                <a:cs typeface="Aptos" pitchFamily="34" charset="-120"/>
+              </a:rPr>
+              <a:t>SVM + none + hybrid</a:t>
+            </a:r>
+            <a:endParaRPr lang="en-US" sz="1300" dirty="0"/>
+          </a:p>
+        </p:txBody>
+      </p:sp>
+      <p:sp>
+        <p:nvSpPr>
+          <p:cNvPr id="13" name="Shape 10"/>
+          <p:cNvSpPr/>
+          <p:nvPr/>
+        </p:nvSpPr>
+        <p:spPr>
+          <a:xfrm>
+            <a:off x="9189720" y="3246120"/>
+            <a:ext cx="2057400" cy="1325880"/>
+          </a:xfrm>
+          <a:prstGeom prst="rect">
+            <a:avLst/>
+          </a:prstGeom>
+          <a:solidFill>
+            <a:srgbClr val="FFFDF8"/>
+          </a:solidFill>
+          <a:ln w="10160">
+            <a:solidFill>
+              <a:srgbClr val="C8C1B5"/>
+            </a:solidFill>
+            <a:prstDash val="solid"/>
+          </a:ln>
+        </p:spPr>
+      </p:sp>
+      <p:sp>
+        <p:nvSpPr>
+          <p:cNvPr id="14" name="Shape 11"/>
+          <p:cNvSpPr/>
+          <p:nvPr/>
+        </p:nvSpPr>
+        <p:spPr>
+          <a:xfrm>
+            <a:off x="9189720" y="3246120"/>
+            <a:ext cx="2057400" cy="73152"/>
           </a:xfrm>
           <a:prstGeom prst="rect">
             <a:avLst/>
@@ -10909,14 +11149,14 @@
       </p:sp>
       <p:sp>
         <p:nvSpPr>
-          <p:cNvPr id="10" name="Text 7"/>
-          <p:cNvSpPr/>
-          <p:nvPr/>
-        </p:nvSpPr>
-        <p:spPr>
-          <a:xfrm>
-            <a:off x="9235440" y="1856232"/>
-            <a:ext cx="1874520" cy="420624"/>
+          <p:cNvPr id="15" name="Text 12"/>
+          <p:cNvSpPr/>
+          <p:nvPr/>
+        </p:nvSpPr>
+        <p:spPr>
+          <a:xfrm>
+            <a:off x="9418320" y="3410712"/>
+            <a:ext cx="1691640" cy="420624"/>
           </a:xfrm>
           <a:prstGeom prst="rect">
             <a:avLst/>
@@ -10942,7 +11182,7 @@
                 <a:ea typeface="Aptos" pitchFamily="34" charset="-122"/>
                 <a:cs typeface="Aptos" pitchFamily="34" charset="-120"/>
               </a:rPr>
-              <a:t>0.693</a:t>
+              <a:t>0.791</a:t>
             </a:r>
             <a:endParaRPr lang="en-US" sz="2700" dirty="0"/>
           </a:p>
@@ -10950,14 +11190,14 @@
       </p:sp>
       <p:sp>
         <p:nvSpPr>
-          <p:cNvPr id="11" name="Text 8"/>
-          <p:cNvSpPr/>
-          <p:nvPr/>
-        </p:nvSpPr>
-        <p:spPr>
-          <a:xfrm>
-            <a:off x="9235440" y="2350008"/>
-            <a:ext cx="1874520" cy="256032"/>
+          <p:cNvPr id="16" name="Text 13"/>
+          <p:cNvSpPr/>
+          <p:nvPr/>
+        </p:nvSpPr>
+        <p:spPr>
+          <a:xfrm>
+            <a:off x="9418320" y="3904488"/>
+            <a:ext cx="1691640" cy="256032"/>
           </a:xfrm>
           <a:prstGeom prst="rect">
             <a:avLst/>
@@ -10983,7 +11223,7 @@
                 <a:ea typeface="Georgia" pitchFamily="34" charset="-122"/>
                 <a:cs typeface="Georgia" pitchFamily="34" charset="-120"/>
               </a:rPr>
-              <a:t>Best Macro-F1</a:t>
+              <a:t>Best DSP AUROC</a:t>
             </a:r>
             <a:endParaRPr lang="en-US" sz="1500" dirty="0"/>
           </a:p>
@@ -10991,14 +11231,14 @@
       </p:sp>
       <p:sp>
         <p:nvSpPr>
-          <p:cNvPr id="12" name="Text 9"/>
-          <p:cNvSpPr/>
-          <p:nvPr/>
-        </p:nvSpPr>
-        <p:spPr>
-          <a:xfrm>
-            <a:off x="9235440" y="2642616"/>
-            <a:ext cx="1874520" cy="274320"/>
+          <p:cNvPr id="17" name="Text 14"/>
+          <p:cNvSpPr/>
+          <p:nvPr/>
+        </p:nvSpPr>
+        <p:spPr>
+          <a:xfrm>
+            <a:off x="9418320" y="4197096"/>
+            <a:ext cx="1691640" cy="274320"/>
           </a:xfrm>
           <a:prstGeom prst="rect">
             <a:avLst/>
@@ -11024,7 +11264,7 @@
                 <a:ea typeface="Aptos" pitchFamily="34" charset="-122"/>
                 <a:cs typeface="Aptos" pitchFamily="34" charset="-120"/>
               </a:rPr>
-              <a:t>MLP + none + MFCC</a:t>
+              <a:t>SVM + Butterworth + hybrid</a:t>
             </a:r>
             <a:endParaRPr lang="en-US" sz="1300" dirty="0"/>
           </a:p>
@@ -11032,14 +11272,14 @@
       </p:sp>
       <p:sp>
         <p:nvSpPr>
-          <p:cNvPr id="13" name="Shape 10"/>
-          <p:cNvSpPr/>
-          <p:nvPr/>
-        </p:nvSpPr>
-        <p:spPr>
-          <a:xfrm>
-            <a:off x="9006840" y="3246120"/>
-            <a:ext cx="2240280" cy="1325880"/>
+          <p:cNvPr id="18" name="Shape 15"/>
+          <p:cNvSpPr/>
+          <p:nvPr/>
+        </p:nvSpPr>
+        <p:spPr>
+          <a:xfrm>
+            <a:off x="9189720" y="4800600"/>
+            <a:ext cx="2057400" cy="1051560"/>
           </a:xfrm>
           <a:prstGeom prst="rect">
             <a:avLst/>
@@ -11057,187 +11297,14 @@
       </p:sp>
       <p:sp>
         <p:nvSpPr>
-          <p:cNvPr id="14" name="Shape 11"/>
-          <p:cNvSpPr/>
-          <p:nvPr/>
-        </p:nvSpPr>
-        <p:spPr>
-          <a:xfrm>
-            <a:off x="9006840" y="3246120"/>
-            <a:ext cx="2240280" cy="73152"/>
-          </a:xfrm>
-          <a:prstGeom prst="rect">
-            <a:avLst/>
-          </a:prstGeom>
-          <a:solidFill>
-            <a:srgbClr val="2B7A78"/>
-          </a:solidFill>
-          <a:ln w="12700">
-            <a:solidFill>
-              <a:srgbClr val="2B7A78"/>
-            </a:solidFill>
-            <a:prstDash val="solid"/>
-          </a:ln>
-        </p:spPr>
-      </p:sp>
-      <p:sp>
-        <p:nvSpPr>
-          <p:cNvPr id="15" name="Text 12"/>
-          <p:cNvSpPr/>
-          <p:nvPr/>
-        </p:nvSpPr>
-        <p:spPr>
-          <a:xfrm>
-            <a:off x="9235440" y="3410712"/>
-            <a:ext cx="1874520" cy="420624"/>
-          </a:xfrm>
-          <a:prstGeom prst="rect">
-            <a:avLst/>
-          </a:prstGeom>
-          <a:noFill/>
-          <a:ln/>
-        </p:spPr>
-        <p:txBody>
-          <a:bodyPr wrap="square" lIns="0" tIns="0" rIns="0" bIns="0" rtlCol="0" anchor="t">
-            <a:normAutofit/>
-          </a:bodyPr>
-          <a:lstStyle/>
-          <a:p>
-            <a:pPr algn="l" indent="0" marL="0">
-              <a:buNone/>
-            </a:pPr>
-            <a:r>
-              <a:rPr lang="en-US" sz="2700" b="1" dirty="0">
-                <a:solidFill>
-                  <a:srgbClr val="2B7A78"/>
-                </a:solidFill>
-                <a:latin typeface="Aptos" pitchFamily="34" charset="0"/>
-                <a:ea typeface="Aptos" pitchFamily="34" charset="-122"/>
-                <a:cs typeface="Aptos" pitchFamily="34" charset="-120"/>
-              </a:rPr>
-              <a:t>0.664</a:t>
-            </a:r>
-            <a:endParaRPr lang="en-US" sz="2700" dirty="0"/>
-          </a:p>
-        </p:txBody>
-      </p:sp>
-      <p:sp>
-        <p:nvSpPr>
-          <p:cNvPr id="16" name="Text 13"/>
-          <p:cNvSpPr/>
-          <p:nvPr/>
-        </p:nvSpPr>
-        <p:spPr>
-          <a:xfrm>
-            <a:off x="9235440" y="3904488"/>
-            <a:ext cx="1874520" cy="256032"/>
-          </a:xfrm>
-          <a:prstGeom prst="rect">
-            <a:avLst/>
-          </a:prstGeom>
-          <a:noFill/>
-          <a:ln/>
-        </p:spPr>
-        <p:txBody>
-          <a:bodyPr wrap="square" lIns="0" tIns="0" rIns="0" bIns="0" rtlCol="0" anchor="t">
-            <a:normAutofit/>
-          </a:bodyPr>
-          <a:lstStyle/>
-          <a:p>
-            <a:pPr algn="l" indent="0" marL="0">
-              <a:buNone/>
-            </a:pPr>
-            <a:r>
-              <a:rPr lang="en-US" sz="1500" b="1" dirty="0">
-                <a:solidFill>
-                  <a:srgbClr val="17313B"/>
-                </a:solidFill>
-                <a:latin typeface="Georgia" pitchFamily="34" charset="0"/>
-                <a:ea typeface="Georgia" pitchFamily="34" charset="-122"/>
-                <a:cs typeface="Georgia" pitchFamily="34" charset="-120"/>
-              </a:rPr>
-              <a:t>Best balanced acc.</a:t>
-            </a:r>
-            <a:endParaRPr lang="en-US" sz="1500" dirty="0"/>
-          </a:p>
-        </p:txBody>
-      </p:sp>
-      <p:sp>
-        <p:nvSpPr>
-          <p:cNvPr id="17" name="Text 14"/>
-          <p:cNvSpPr/>
-          <p:nvPr/>
-        </p:nvSpPr>
-        <p:spPr>
-          <a:xfrm>
-            <a:off x="9235440" y="4197096"/>
-            <a:ext cx="1874520" cy="274320"/>
-          </a:xfrm>
-          <a:prstGeom prst="rect">
-            <a:avLst/>
-          </a:prstGeom>
-          <a:noFill/>
-          <a:ln/>
-        </p:spPr>
-        <p:txBody>
-          <a:bodyPr wrap="square" lIns="0" tIns="0" rIns="0" bIns="0" rtlCol="0" anchor="t">
-            <a:normAutofit/>
-          </a:bodyPr>
-          <a:lstStyle/>
-          <a:p>
-            <a:pPr algn="l" indent="0" marL="0">
-              <a:buNone/>
-            </a:pPr>
-            <a:r>
-              <a:rPr lang="en-US" sz="1300" dirty="0">
-                <a:solidFill>
-                  <a:srgbClr val="6D7775"/>
-                </a:solidFill>
-                <a:latin typeface="Aptos" pitchFamily="34" charset="0"/>
-                <a:ea typeface="Aptos" pitchFamily="34" charset="-122"/>
-                <a:cs typeface="Aptos" pitchFamily="34" charset="-120"/>
-              </a:rPr>
-              <a:t>SVM + none + hybrid</a:t>
-            </a:r>
-            <a:endParaRPr lang="en-US" sz="1300" dirty="0"/>
-          </a:p>
-        </p:txBody>
-      </p:sp>
-      <p:sp>
-        <p:nvSpPr>
-          <p:cNvPr id="18" name="Shape 15"/>
-          <p:cNvSpPr/>
-          <p:nvPr/>
-        </p:nvSpPr>
-        <p:spPr>
-          <a:xfrm>
-            <a:off x="9006840" y="4800600"/>
-            <a:ext cx="2240280" cy="1051560"/>
-          </a:xfrm>
-          <a:prstGeom prst="rect">
-            <a:avLst/>
-          </a:prstGeom>
-          <a:solidFill>
-            <a:srgbClr val="FFFDF8"/>
-          </a:solidFill>
-          <a:ln w="10160">
-            <a:solidFill>
-              <a:srgbClr val="C8C1B5"/>
-            </a:solidFill>
-            <a:prstDash val="solid"/>
-          </a:ln>
-        </p:spPr>
-      </p:sp>
-      <p:sp>
-        <p:nvSpPr>
           <p:cNvPr id="19" name="Shape 16"/>
           <p:cNvSpPr/>
           <p:nvPr/>
         </p:nvSpPr>
         <p:spPr>
           <a:xfrm>
-            <a:off x="9006840" y="4800600"/>
-            <a:ext cx="2240280" cy="73152"/>
+            <a:off x="9189720" y="4800600"/>
+            <a:ext cx="2057400" cy="73152"/>
           </a:xfrm>
           <a:prstGeom prst="rect">
             <a:avLst/>
@@ -11261,8 +11328,8 @@
         </p:nvSpPr>
         <p:spPr>
           <a:xfrm>
-            <a:off x="9235440" y="5001768"/>
-            <a:ext cx="1874520" cy="256032"/>
+            <a:off x="9418320" y="5001768"/>
+            <a:ext cx="1691640" cy="256032"/>
           </a:xfrm>
           <a:prstGeom prst="rect">
             <a:avLst/>
@@ -11288,7 +11355,7 @@
                 <a:ea typeface="Georgia" pitchFamily="34" charset="-122"/>
                 <a:cs typeface="Georgia" pitchFamily="34" charset="-120"/>
               </a:rPr>
-              <a:t>Cảnh báo</a:t>
+              <a:t>Metric set</a:t>
             </a:r>
             <a:endParaRPr lang="en-US" sz="1500" dirty="0"/>
           </a:p>
@@ -11302,8 +11369,8 @@
         </p:nvSpPr>
         <p:spPr>
           <a:xfrm>
-            <a:off x="9235440" y="5330952"/>
-            <a:ext cx="1874520" cy="411480"/>
+            <a:off x="9418320" y="5330952"/>
+            <a:ext cx="1691640" cy="411480"/>
           </a:xfrm>
           <a:prstGeom prst="rect">
             <a:avLst/>
@@ -11329,7 +11396,7 @@
                 <a:ea typeface="Aptos" pitchFamily="34" charset="-122"/>
                 <a:cs typeface="Aptos" pitchFamily="34" charset="-120"/>
               </a:rPr>
-              <a:t>Present: 9/27 đúng ở best F1</a:t>
+              <a:t>WAcc · UAR · AUROC · AUPRC</a:t>
             </a:r>
             <a:endParaRPr lang="en-US" sz="1300" dirty="0"/>
           </a:p>
@@ -11344,7 +11411,7 @@
         <p:spPr>
           <a:xfrm>
             <a:off x="685800" y="6126480"/>
-            <a:ext cx="7955280" cy="228600"/>
+            <a:ext cx="8229600" cy="228600"/>
           </a:xfrm>
           <a:prstGeom prst="rect">
             <a:avLst/>
@@ -11370,7 +11437,7 @@
                 <a:ea typeface="Aptos" pitchFamily="34" charset="-122"/>
                 <a:cs typeface="Aptos" pitchFamily="34" charset="-120"/>
               </a:rPr>
-              <a:t>Không filter thắng trong split này; cần nhiều seed trước khi kết luận ưu thế tổng quát.</a:t>
+              <a:t>WAcc là metric primary; Macro-F1 và confusion matrix được báo cáo kèm trong report.</a:t>
             </a:r>
             <a:endParaRPr lang="en-US" sz="1500" dirty="0"/>
           </a:p>
@@ -11573,7 +11640,7 @@
                 <a:ea typeface="Aptos" pitchFamily="34" charset="-122"/>
                 <a:cs typeface="Aptos" pitchFamily="34" charset="-120"/>
               </a:rPr>
-              <a:t>12 · CNN ABLATION</a:t>
+              <a:t>12 · CNN FILTER ABLATION</a:t>
             </a:r>
             <a:endParaRPr lang="en-US" sz="1000" dirty="0"/>
           </a:p>
@@ -11655,7 +11722,7 @@
                 <a:ea typeface="Georgia" pitchFamily="34" charset="-122"/>
                 <a:cs typeface="Georgia" pitchFamily="34" charset="-120"/>
               </a:rPr>
-              <a:t>CNN nhẹ: MobileNetV3-Small + log-STFT</a:t>
+              <a:t>MobileNetV3-Small: 3-class primary baseline</a:t>
             </a:r>
             <a:endParaRPr lang="en-US" sz="3000" dirty="0"/>
           </a:p>
@@ -11688,7 +11755,7 @@
               <a:buNone/>
             </a:pPr>
             <a:r>
-              <a:rPr lang="en-US" sz="1700" b="1" dirty="0">
+              <a:rPr lang="en-US" sz="1600" b="1" dirty="0">
                 <a:solidFill>
                   <a:srgbClr val="17313B"/>
                 </a:solidFill>
@@ -11696,9 +11763,9 @@
                 <a:ea typeface="Aptos" pitchFamily="34" charset="-122"/>
                 <a:cs typeface="Aptos" pitchFamily="34" charset="-120"/>
               </a:rPr>
-              <a:t>874 labeled patients · same patient-wise split · 2 windows/recording · frozen pretrained backbone</a:t>
-            </a:r>
-            <a:endParaRPr lang="en-US" sz="1700" dirty="0"/>
+              <a:t>942 patients · split 612 / 94 / 236 · log-STFT · mean patient aggregation · frozen pretrained backbone</a:t>
+            </a:r>
+            <a:endParaRPr lang="en-US" sz="1600" dirty="0"/>
           </a:p>
         </p:txBody>
       </p:sp>
@@ -11717,18 +11784,21 @@
           </p:nvPr>
         </p:nvGraphicFramePr>
         <p:xfrm>
-          <a:off x="685800" y="1737360"/>
-          <a:ext cx="7498080" cy="3566160"/>
+          <a:off x="411480" y="1737360"/>
+          <a:ext cx="8641080" cy="3063240"/>
         </p:xfrm>
         <a:graphic>
           <a:graphicData uri="http://schemas.openxmlformats.org/drawingml/2006/table">
             <a:tbl>
               <a:tblPr/>
               <a:tblGrid>
-                <a:gridCol w="3246120"/>
-                <a:gridCol w="1234440"/>
-                <a:gridCol w="1417320"/>
-                <a:gridCol w="1234440"/>
+                <a:gridCol w="1554480"/>
+                <a:gridCol w="1143000"/>
+                <a:gridCol w="1143000"/>
+                <a:gridCol w="1097280"/>
+                <a:gridCol w="1188720"/>
+                <a:gridCol w="1143000"/>
+                <a:gridCol w="1188720"/>
               </a:tblGrid>
               <a:tr h="502920">
                 <a:tc>
@@ -11740,7 +11810,7 @@
                         <a:buNone/>
                       </a:pPr>
                       <a:r>
-                        <a:rPr lang="en-US" sz="1500" b="1" dirty="0">
+                        <a:rPr lang="en-US" sz="1300" b="1" dirty="0">
                           <a:solidFill>
                             <a:srgbClr val="FFFDF8"/>
                           </a:solidFill>
@@ -11748,16 +11818,16 @@
                           <a:ea typeface="Aptos" pitchFamily="34" charset="-122"/>
                           <a:cs typeface="Aptos" pitchFamily="34" charset="-120"/>
                         </a:rPr>
-                        <a:t>Aggregation / training</a:t>
+                        <a:t>Filter</a:t>
                       </a:r>
-                      <a:endParaRPr lang="en-US" sz="1500" dirty="0">
+                      <a:endParaRPr lang="en-US" sz="1300" dirty="0">
                         <a:latin typeface="Aptos" charset="0"/>
                         <a:ea typeface="Aptos" charset="0"/>
                         <a:cs typeface="Aptos" charset="0"/>
                       </a:endParaRPr>
                     </a:p>
                   </a:txBody>
-                  <a:tcPr marL="54864" marR="54864" marT="54864" marB="54864" anchor="mid">
+                  <a:tcPr marL="45720" marR="45720" marT="45720" marB="45720" anchor="mid">
                     <a:lnL w="12700" cap="flat" cmpd="sng" algn="ctr">
                       <a:solidFill>
                         <a:srgbClr val="C8C1B5"/>
@@ -11808,7 +11878,7 @@
                         <a:buNone/>
                       </a:pPr>
                       <a:r>
-                        <a:rPr lang="en-US" sz="1500" b="1" dirty="0">
+                        <a:rPr lang="en-US" sz="1300" b="1" dirty="0">
                           <a:solidFill>
                             <a:srgbClr val="FFFDF8"/>
                           </a:solidFill>
@@ -11818,14 +11888,14 @@
                         </a:rPr>
                         <a:t>Accuracy</a:t>
                       </a:r>
-                      <a:endParaRPr lang="en-US" sz="1500" dirty="0">
+                      <a:endParaRPr lang="en-US" sz="1300" dirty="0">
                         <a:latin typeface="Aptos" charset="0"/>
                         <a:ea typeface="Aptos" charset="0"/>
                         <a:cs typeface="Aptos" charset="0"/>
                       </a:endParaRPr>
                     </a:p>
                   </a:txBody>
-                  <a:tcPr marL="54864" marR="54864" marT="54864" marB="54864" anchor="mid">
+                  <a:tcPr marL="45720" marR="45720" marT="45720" marB="45720" anchor="mid">
                     <a:lnL w="12700" cap="flat" cmpd="sng" algn="ctr">
                       <a:solidFill>
                         <a:srgbClr val="C8C1B5"/>
@@ -11876,7 +11946,7 @@
                         <a:buNone/>
                       </a:pPr>
                       <a:r>
-                        <a:rPr lang="en-US" sz="1500" b="1" dirty="0">
+                        <a:rPr lang="en-US" sz="1300" b="1" dirty="0">
                           <a:solidFill>
                             <a:srgbClr val="FFFDF8"/>
                           </a:solidFill>
@@ -11884,16 +11954,16 @@
                           <a:ea typeface="Aptos" pitchFamily="34" charset="-122"/>
                           <a:cs typeface="Aptos" pitchFamily="34" charset="-120"/>
                         </a:rPr>
-                        <a:t>Balanced acc.</a:t>
+                        <a:t>WAcc</a:t>
                       </a:r>
-                      <a:endParaRPr lang="en-US" sz="1500" dirty="0">
+                      <a:endParaRPr lang="en-US" sz="1300" dirty="0">
                         <a:latin typeface="Aptos" charset="0"/>
                         <a:ea typeface="Aptos" charset="0"/>
                         <a:cs typeface="Aptos" charset="0"/>
                       </a:endParaRPr>
                     </a:p>
                   </a:txBody>
-                  <a:tcPr marL="54864" marR="54864" marT="54864" marB="54864" anchor="mid">
+                  <a:tcPr marL="45720" marR="45720" marT="45720" marB="45720" anchor="mid">
                     <a:lnL w="12700" cap="flat" cmpd="sng" algn="ctr">
                       <a:solidFill>
                         <a:srgbClr val="C8C1B5"/>
@@ -11944,7 +12014,211 @@
                         <a:buNone/>
                       </a:pPr>
                       <a:r>
-                        <a:rPr lang="en-US" sz="1500" b="1" dirty="0">
+                        <a:rPr lang="en-US" sz="1300" b="1" dirty="0">
+                          <a:solidFill>
+                            <a:srgbClr val="FFFDF8"/>
+                          </a:solidFill>
+                          <a:latin typeface="Aptos" pitchFamily="34" charset="0"/>
+                          <a:ea typeface="Aptos" pitchFamily="34" charset="-122"/>
+                          <a:cs typeface="Aptos" pitchFamily="34" charset="-120"/>
+                        </a:rPr>
+                        <a:t>UAR</a:t>
+                      </a:r>
+                      <a:endParaRPr lang="en-US" sz="1300" dirty="0">
+                        <a:latin typeface="Aptos" charset="0"/>
+                        <a:ea typeface="Aptos" charset="0"/>
+                        <a:cs typeface="Aptos" charset="0"/>
+                      </a:endParaRPr>
+                    </a:p>
+                  </a:txBody>
+                  <a:tcPr marL="45720" marR="45720" marT="45720" marB="45720" anchor="mid">
+                    <a:lnL w="12700" cap="flat" cmpd="sng" algn="ctr">
+                      <a:solidFill>
+                        <a:srgbClr val="C8C1B5"/>
+                      </a:solidFill>
+                      <a:prstDash val="solid"/>
+                      <a:round/>
+                      <a:headEnd type="none" w="med" len="med"/>
+                      <a:tailEnd type="none" w="med" len="med"/>
+                    </a:lnL>
+                    <a:lnR w="12700" cap="flat" cmpd="sng" algn="ctr">
+                      <a:solidFill>
+                        <a:srgbClr val="C8C1B5"/>
+                      </a:solidFill>
+                      <a:prstDash val="solid"/>
+                      <a:round/>
+                      <a:headEnd type="none" w="med" len="med"/>
+                      <a:tailEnd type="none" w="med" len="med"/>
+                    </a:lnR>
+                    <a:lnT w="12700" cap="flat" cmpd="sng" algn="ctr">
+                      <a:solidFill>
+                        <a:srgbClr val="C8C1B5"/>
+                      </a:solidFill>
+                      <a:prstDash val="solid"/>
+                      <a:round/>
+                      <a:headEnd type="none" w="med" len="med"/>
+                      <a:tailEnd type="none" w="med" len="med"/>
+                    </a:lnT>
+                    <a:lnB w="12700" cap="flat" cmpd="sng" algn="ctr">
+                      <a:solidFill>
+                        <a:srgbClr val="C8C1B5"/>
+                      </a:solidFill>
+                      <a:prstDash val="solid"/>
+                      <a:round/>
+                      <a:headEnd type="none" w="med" len="med"/>
+                      <a:tailEnd type="none" w="med" len="med"/>
+                    </a:lnB>
+                    <a:solidFill>
+                      <a:srgbClr val="1D3D49"/>
+                    </a:solidFill>
+                  </a:tcPr>
+                </a:tc>
+                <a:tc>
+                  <a:txBody>
+                    <a:bodyPr/>
+                    <a:lstStyle/>
+                    <a:p>
+                      <a:pPr algn="ctr" indent="0" marL="0">
+                        <a:buNone/>
+                      </a:pPr>
+                      <a:r>
+                        <a:rPr lang="en-US" sz="1300" b="1" dirty="0">
+                          <a:solidFill>
+                            <a:srgbClr val="FFFDF8"/>
+                          </a:solidFill>
+                          <a:latin typeface="Aptos" pitchFamily="34" charset="0"/>
+                          <a:ea typeface="Aptos" pitchFamily="34" charset="-122"/>
+                          <a:cs typeface="Aptos" pitchFamily="34" charset="-120"/>
+                        </a:rPr>
+                        <a:t>AUROC</a:t>
+                      </a:r>
+                      <a:endParaRPr lang="en-US" sz="1300" dirty="0">
+                        <a:latin typeface="Aptos" charset="0"/>
+                        <a:ea typeface="Aptos" charset="0"/>
+                        <a:cs typeface="Aptos" charset="0"/>
+                      </a:endParaRPr>
+                    </a:p>
+                  </a:txBody>
+                  <a:tcPr marL="45720" marR="45720" marT="45720" marB="45720" anchor="mid">
+                    <a:lnL w="12700" cap="flat" cmpd="sng" algn="ctr">
+                      <a:solidFill>
+                        <a:srgbClr val="C8C1B5"/>
+                      </a:solidFill>
+                      <a:prstDash val="solid"/>
+                      <a:round/>
+                      <a:headEnd type="none" w="med" len="med"/>
+                      <a:tailEnd type="none" w="med" len="med"/>
+                    </a:lnL>
+                    <a:lnR w="12700" cap="flat" cmpd="sng" algn="ctr">
+                      <a:solidFill>
+                        <a:srgbClr val="C8C1B5"/>
+                      </a:solidFill>
+                      <a:prstDash val="solid"/>
+                      <a:round/>
+                      <a:headEnd type="none" w="med" len="med"/>
+                      <a:tailEnd type="none" w="med" len="med"/>
+                    </a:lnR>
+                    <a:lnT w="12700" cap="flat" cmpd="sng" algn="ctr">
+                      <a:solidFill>
+                        <a:srgbClr val="C8C1B5"/>
+                      </a:solidFill>
+                      <a:prstDash val="solid"/>
+                      <a:round/>
+                      <a:headEnd type="none" w="med" len="med"/>
+                      <a:tailEnd type="none" w="med" len="med"/>
+                    </a:lnT>
+                    <a:lnB w="12700" cap="flat" cmpd="sng" algn="ctr">
+                      <a:solidFill>
+                        <a:srgbClr val="C8C1B5"/>
+                      </a:solidFill>
+                      <a:prstDash val="solid"/>
+                      <a:round/>
+                      <a:headEnd type="none" w="med" len="med"/>
+                      <a:tailEnd type="none" w="med" len="med"/>
+                    </a:lnB>
+                    <a:solidFill>
+                      <a:srgbClr val="1D3D49"/>
+                    </a:solidFill>
+                  </a:tcPr>
+                </a:tc>
+                <a:tc>
+                  <a:txBody>
+                    <a:bodyPr/>
+                    <a:lstStyle/>
+                    <a:p>
+                      <a:pPr algn="ctr" indent="0" marL="0">
+                        <a:buNone/>
+                      </a:pPr>
+                      <a:r>
+                        <a:rPr lang="en-US" sz="1300" b="1" dirty="0">
+                          <a:solidFill>
+                            <a:srgbClr val="FFFDF8"/>
+                          </a:solidFill>
+                          <a:latin typeface="Aptos" pitchFamily="34" charset="0"/>
+                          <a:ea typeface="Aptos" pitchFamily="34" charset="-122"/>
+                          <a:cs typeface="Aptos" pitchFamily="34" charset="-120"/>
+                        </a:rPr>
+                        <a:t>AUPRC</a:t>
+                      </a:r>
+                      <a:endParaRPr lang="en-US" sz="1300" dirty="0">
+                        <a:latin typeface="Aptos" charset="0"/>
+                        <a:ea typeface="Aptos" charset="0"/>
+                        <a:cs typeface="Aptos" charset="0"/>
+                      </a:endParaRPr>
+                    </a:p>
+                  </a:txBody>
+                  <a:tcPr marL="45720" marR="45720" marT="45720" marB="45720" anchor="mid">
+                    <a:lnL w="12700" cap="flat" cmpd="sng" algn="ctr">
+                      <a:solidFill>
+                        <a:srgbClr val="C8C1B5"/>
+                      </a:solidFill>
+                      <a:prstDash val="solid"/>
+                      <a:round/>
+                      <a:headEnd type="none" w="med" len="med"/>
+                      <a:tailEnd type="none" w="med" len="med"/>
+                    </a:lnL>
+                    <a:lnR w="12700" cap="flat" cmpd="sng" algn="ctr">
+                      <a:solidFill>
+                        <a:srgbClr val="C8C1B5"/>
+                      </a:solidFill>
+                      <a:prstDash val="solid"/>
+                      <a:round/>
+                      <a:headEnd type="none" w="med" len="med"/>
+                      <a:tailEnd type="none" w="med" len="med"/>
+                    </a:lnR>
+                    <a:lnT w="12700" cap="flat" cmpd="sng" algn="ctr">
+                      <a:solidFill>
+                        <a:srgbClr val="C8C1B5"/>
+                      </a:solidFill>
+                      <a:prstDash val="solid"/>
+                      <a:round/>
+                      <a:headEnd type="none" w="med" len="med"/>
+                      <a:tailEnd type="none" w="med" len="med"/>
+                    </a:lnT>
+                    <a:lnB w="12700" cap="flat" cmpd="sng" algn="ctr">
+                      <a:solidFill>
+                        <a:srgbClr val="C8C1B5"/>
+                      </a:solidFill>
+                      <a:prstDash val="solid"/>
+                      <a:round/>
+                      <a:headEnd type="none" w="med" len="med"/>
+                      <a:tailEnd type="none" w="med" len="med"/>
+                    </a:lnB>
+                    <a:solidFill>
+                      <a:srgbClr val="1D3D49"/>
+                    </a:solidFill>
+                  </a:tcPr>
+                </a:tc>
+                <a:tc>
+                  <a:txBody>
+                    <a:bodyPr/>
+                    <a:lstStyle/>
+                    <a:p>
+                      <a:pPr algn="ctr" indent="0" marL="0">
+                        <a:buNone/>
+                      </a:pPr>
+                      <a:r>
+                        <a:rPr lang="en-US" sz="1300" b="1" dirty="0">
                           <a:solidFill>
                             <a:srgbClr val="FFFDF8"/>
                           </a:solidFill>
@@ -11954,14 +12228,14 @@
                         </a:rPr>
                         <a:t>Macro-F1</a:t>
                       </a:r>
-                      <a:endParaRPr lang="en-US" sz="1500" dirty="0">
+                      <a:endParaRPr lang="en-US" sz="1300" dirty="0">
                         <a:latin typeface="Aptos" charset="0"/>
                         <a:ea typeface="Aptos" charset="0"/>
                         <a:cs typeface="Aptos" charset="0"/>
                       </a:endParaRPr>
                     </a:p>
                   </a:txBody>
-                  <a:tcPr marL="54864" marR="54864" marT="54864" marB="54864" anchor="mid">
+                  <a:tcPr marL="45720" marR="45720" marT="45720" marB="45720" anchor="mid">
                     <a:lnL w="12700" cap="flat" cmpd="sng" algn="ctr">
                       <a:solidFill>
                         <a:srgbClr val="C8C1B5"/>
@@ -12004,7 +12278,7 @@
                   </a:tcPr>
                 </a:tc>
               </a:tr>
-              <a:tr h="603504">
+              <a:tr h="749808">
                 <a:tc>
                   <a:txBody>
                     <a:bodyPr/>
@@ -12014,7 +12288,7 @@
                         <a:buNone/>
                       </a:pPr>
                       <a:r>
-                        <a:rPr lang="en-US" sz="1500" dirty="0">
+                        <a:rPr lang="en-US" sz="1300" dirty="0">
                           <a:solidFill>
                             <a:srgbClr val="17313B"/>
                           </a:solidFill>
@@ -12022,16 +12296,16 @@
                           <a:ea typeface="Aptos" pitchFamily="34" charset="-122"/>
                           <a:cs typeface="Aptos" pitchFamily="34" charset="-120"/>
                         </a:rPr>
-                        <a:t>Mean + tuned threshold</a:t>
+                        <a:t>None</a:t>
                       </a:r>
-                      <a:endParaRPr lang="en-US" sz="1500" dirty="0">
+                      <a:endParaRPr lang="en-US" sz="1300" dirty="0">
                         <a:latin typeface="Aptos" charset="0"/>
                         <a:ea typeface="Aptos" charset="0"/>
                         <a:cs typeface="Aptos" charset="0"/>
                       </a:endParaRPr>
                     </a:p>
                   </a:txBody>
-                  <a:tcPr marL="54864" marR="54864" marT="54864" marB="54864" anchor="mid">
+                  <a:tcPr marL="45720" marR="45720" marT="45720" marB="45720" anchor="mid">
                     <a:lnL w="12700" cap="flat" cmpd="sng" algn="ctr">
                       <a:solidFill>
                         <a:srgbClr val="C8C1B5"/>
@@ -12082,7 +12356,7 @@
                         <a:buNone/>
                       </a:pPr>
                       <a:r>
-                        <a:rPr lang="en-US" sz="1500" dirty="0">
+                        <a:rPr lang="en-US" sz="1300" dirty="0">
                           <a:solidFill>
                             <a:srgbClr val="17313B"/>
                           </a:solidFill>
@@ -12090,16 +12364,16 @@
                           <a:ea typeface="Aptos" pitchFamily="34" charset="-122"/>
                           <a:cs typeface="Aptos" pitchFamily="34" charset="-120"/>
                         </a:rPr>
-                        <a:t>0.841</a:t>
+                        <a:t>0.716</a:t>
                       </a:r>
-                      <a:endParaRPr lang="en-US" sz="1500" dirty="0">
+                      <a:endParaRPr lang="en-US" sz="1300" dirty="0">
                         <a:latin typeface="Aptos" charset="0"/>
                         <a:ea typeface="Aptos" charset="0"/>
                         <a:cs typeface="Aptos" charset="0"/>
                       </a:endParaRPr>
                     </a:p>
                   </a:txBody>
-                  <a:tcPr marL="54864" marR="54864" marT="54864" marB="54864" anchor="mid">
+                  <a:tcPr marL="45720" marR="45720" marT="45720" marB="45720" anchor="mid">
                     <a:lnL w="12700" cap="flat" cmpd="sng" algn="ctr">
                       <a:solidFill>
                         <a:srgbClr val="C8C1B5"/>
@@ -12150,7 +12424,7 @@
                         <a:buNone/>
                       </a:pPr>
                       <a:r>
-                        <a:rPr lang="en-US" sz="1500" dirty="0">
+                        <a:rPr lang="en-US" sz="1300" dirty="0">
                           <a:solidFill>
                             <a:srgbClr val="17313B"/>
                           </a:solidFill>
@@ -12158,16 +12432,16 @@
                           <a:ea typeface="Aptos" pitchFamily="34" charset="-122"/>
                           <a:cs typeface="Aptos" pitchFamily="34" charset="-120"/>
                         </a:rPr>
-                        <a:t>0.666</a:t>
+                        <a:t>0.638</a:t>
                       </a:r>
-                      <a:endParaRPr lang="en-US" sz="1500" dirty="0">
+                      <a:endParaRPr lang="en-US" sz="1300" dirty="0">
                         <a:latin typeface="Aptos" charset="0"/>
                         <a:ea typeface="Aptos" charset="0"/>
                         <a:cs typeface="Aptos" charset="0"/>
                       </a:endParaRPr>
                     </a:p>
                   </a:txBody>
-                  <a:tcPr marL="54864" marR="54864" marT="54864" marB="54864" anchor="mid">
+                  <a:tcPr marL="45720" marR="45720" marT="45720" marB="45720" anchor="mid">
                     <a:lnL w="12700" cap="flat" cmpd="sng" algn="ctr">
                       <a:solidFill>
                         <a:srgbClr val="C8C1B5"/>
@@ -12218,7 +12492,7 @@
                         <a:buNone/>
                       </a:pPr>
                       <a:r>
-                        <a:rPr lang="en-US" sz="1500" dirty="0">
+                        <a:rPr lang="en-US" sz="1300" dirty="0">
                           <a:solidFill>
                             <a:srgbClr val="17313B"/>
                           </a:solidFill>
@@ -12226,86 +12500,16 @@
                           <a:ea typeface="Aptos" pitchFamily="34" charset="-122"/>
                           <a:cs typeface="Aptos" pitchFamily="34" charset="-120"/>
                         </a:rPr>
-                        <a:t>0.697</a:t>
+                        <a:t>0.620</a:t>
                       </a:r>
-                      <a:endParaRPr lang="en-US" sz="1500" dirty="0">
+                      <a:endParaRPr lang="en-US" sz="1300" dirty="0">
                         <a:latin typeface="Aptos" charset="0"/>
                         <a:ea typeface="Aptos" charset="0"/>
                         <a:cs typeface="Aptos" charset="0"/>
                       </a:endParaRPr>
                     </a:p>
                   </a:txBody>
-                  <a:tcPr marL="54864" marR="54864" marT="54864" marB="54864" anchor="mid">
-                    <a:lnL w="12700" cap="flat" cmpd="sng" algn="ctr">
-                      <a:solidFill>
-                        <a:srgbClr val="C8C1B5"/>
-                      </a:solidFill>
-                      <a:prstDash val="solid"/>
-                      <a:round/>
-                      <a:headEnd type="none" w="med" len="med"/>
-                      <a:tailEnd type="none" w="med" len="med"/>
-                    </a:lnL>
-                    <a:lnR w="12700" cap="flat" cmpd="sng" algn="ctr">
-                      <a:solidFill>
-                        <a:srgbClr val="C8C1B5"/>
-                      </a:solidFill>
-                      <a:prstDash val="solid"/>
-                      <a:round/>
-                      <a:headEnd type="none" w="med" len="med"/>
-                      <a:tailEnd type="none" w="med" len="med"/>
-                    </a:lnR>
-                    <a:lnT w="12700" cap="flat" cmpd="sng" algn="ctr">
-                      <a:solidFill>
-                        <a:srgbClr val="C8C1B5"/>
-                      </a:solidFill>
-                      <a:prstDash val="solid"/>
-                      <a:round/>
-                      <a:headEnd type="none" w="med" len="med"/>
-                      <a:tailEnd type="none" w="med" len="med"/>
-                    </a:lnT>
-                    <a:lnB w="12700" cap="flat" cmpd="sng" algn="ctr">
-                      <a:solidFill>
-                        <a:srgbClr val="C8C1B5"/>
-                      </a:solidFill>
-                      <a:prstDash val="solid"/>
-                      <a:round/>
-                      <a:headEnd type="none" w="med" len="med"/>
-                      <a:tailEnd type="none" w="med" len="med"/>
-                    </a:lnB>
-                    <a:solidFill>
-                      <a:srgbClr val="FFFDF8"/>
-                    </a:solidFill>
-                  </a:tcPr>
-                </a:tc>
-              </a:tr>
-              <a:tr h="603504">
-                <a:tc>
-                  <a:txBody>
-                    <a:bodyPr/>
-                    <a:lstStyle/>
-                    <a:p>
-                      <a:pPr algn="ctr" indent="0" marL="0">
-                        <a:buNone/>
-                      </a:pPr>
-                      <a:r>
-                        <a:rPr lang="en-US" sz="1500" dirty="0">
-                          <a:solidFill>
-                            <a:srgbClr val="17313B"/>
-                          </a:solidFill>
-                          <a:latin typeface="Aptos" pitchFamily="34" charset="0"/>
-                          <a:ea typeface="Aptos" pitchFamily="34" charset="-122"/>
-                          <a:cs typeface="Aptos" pitchFamily="34" charset="-120"/>
-                        </a:rPr>
-                        <a:t>Median + tuned threshold</a:t>
-                      </a:r>
-                      <a:endParaRPr lang="en-US" sz="1500" dirty="0">
-                        <a:latin typeface="Aptos" charset="0"/>
-                        <a:ea typeface="Aptos" charset="0"/>
-                        <a:cs typeface="Aptos" charset="0"/>
-                      </a:endParaRPr>
-                    </a:p>
-                  </a:txBody>
-                  <a:tcPr marL="54864" marR="54864" marT="54864" marB="54864" anchor="mid">
+                  <a:tcPr marL="45720" marR="45720" marT="45720" marB="45720" anchor="mid">
                     <a:lnL w="12700" cap="flat" cmpd="sng" algn="ctr">
                       <a:solidFill>
                         <a:srgbClr val="C8C1B5"/>
@@ -12356,7 +12560,7 @@
                         <a:buNone/>
                       </a:pPr>
                       <a:r>
-                        <a:rPr lang="en-US" sz="1500" dirty="0">
+                        <a:rPr lang="en-US" sz="1300" dirty="0">
                           <a:solidFill>
                             <a:srgbClr val="17313B"/>
                           </a:solidFill>
@@ -12364,16 +12568,16 @@
                           <a:ea typeface="Aptos" pitchFamily="34" charset="-122"/>
                           <a:cs typeface="Aptos" pitchFamily="34" charset="-120"/>
                         </a:rPr>
-                        <a:t>0.833</a:t>
+                        <a:t>0.772</a:t>
                       </a:r>
-                      <a:endParaRPr lang="en-US" sz="1500" dirty="0">
+                      <a:endParaRPr lang="en-US" sz="1300" dirty="0">
                         <a:latin typeface="Aptos" charset="0"/>
                         <a:ea typeface="Aptos" charset="0"/>
                         <a:cs typeface="Aptos" charset="0"/>
                       </a:endParaRPr>
                     </a:p>
                   </a:txBody>
-                  <a:tcPr marL="54864" marR="54864" marT="54864" marB="54864" anchor="mid">
+                  <a:tcPr marL="45720" marR="45720" marT="45720" marB="45720" anchor="mid">
                     <a:lnL w="12700" cap="flat" cmpd="sng" algn="ctr">
                       <a:solidFill>
                         <a:srgbClr val="C8C1B5"/>
@@ -12424,7 +12628,7 @@
                         <a:buNone/>
                       </a:pPr>
                       <a:r>
-                        <a:rPr lang="en-US" sz="1500" dirty="0">
+                        <a:rPr lang="en-US" sz="1300" dirty="0">
                           <a:solidFill>
                             <a:srgbClr val="17313B"/>
                           </a:solidFill>
@@ -12432,16 +12636,16 @@
                           <a:ea typeface="Aptos" pitchFamily="34" charset="-122"/>
                           <a:cs typeface="Aptos" pitchFamily="34" charset="-120"/>
                         </a:rPr>
-                        <a:t>0.689</a:t>
+                        <a:t>0.596</a:t>
                       </a:r>
-                      <a:endParaRPr lang="en-US" sz="1500" dirty="0">
+                      <a:endParaRPr lang="en-US" sz="1300" dirty="0">
                         <a:latin typeface="Aptos" charset="0"/>
                         <a:ea typeface="Aptos" charset="0"/>
                         <a:cs typeface="Aptos" charset="0"/>
                       </a:endParaRPr>
                     </a:p>
                   </a:txBody>
-                  <a:tcPr marL="54864" marR="54864" marT="54864" marB="54864" anchor="mid">
+                  <a:tcPr marL="45720" marR="45720" marT="45720" marB="45720" anchor="mid">
                     <a:lnL w="12700" cap="flat" cmpd="sng" algn="ctr">
                       <a:solidFill>
                         <a:srgbClr val="C8C1B5"/>
@@ -12492,7 +12696,7 @@
                         <a:buNone/>
                       </a:pPr>
                       <a:r>
-                        <a:rPr lang="en-US" sz="1500" dirty="0">
+                        <a:rPr lang="en-US" sz="1300" dirty="0">
                           <a:solidFill>
                             <a:srgbClr val="17313B"/>
                           </a:solidFill>
@@ -12500,16 +12704,16 @@
                           <a:ea typeface="Aptos" pitchFamily="34" charset="-122"/>
                           <a:cs typeface="Aptos" pitchFamily="34" charset="-120"/>
                         </a:rPr>
-                        <a:t>0.710</a:t>
+                        <a:t>0.580</a:t>
                       </a:r>
-                      <a:endParaRPr lang="en-US" sz="1500" dirty="0">
+                      <a:endParaRPr lang="en-US" sz="1300" dirty="0">
                         <a:latin typeface="Aptos" charset="0"/>
                         <a:ea typeface="Aptos" charset="0"/>
                         <a:cs typeface="Aptos" charset="0"/>
                       </a:endParaRPr>
                     </a:p>
                   </a:txBody>
-                  <a:tcPr marL="54864" marR="54864" marT="54864" marB="54864" anchor="mid">
+                  <a:tcPr marL="45720" marR="45720" marT="45720" marB="45720" anchor="mid">
                     <a:lnL w="12700" cap="flat" cmpd="sng" algn="ctr">
                       <a:solidFill>
                         <a:srgbClr val="C8C1B5"/>
@@ -12552,7 +12756,7 @@
                   </a:tcPr>
                 </a:tc>
               </a:tr>
-              <a:tr h="603504">
+              <a:tr h="749808">
                 <a:tc>
                   <a:txBody>
                     <a:bodyPr/>
@@ -12562,7 +12766,7 @@
                         <a:buNone/>
                       </a:pPr>
                       <a:r>
-                        <a:rPr lang="en-US" sz="1500" dirty="0">
+                        <a:rPr lang="en-US" sz="1300" dirty="0">
                           <a:solidFill>
                             <a:srgbClr val="17313B"/>
                           </a:solidFill>
@@ -12570,16 +12774,16 @@
                           <a:ea typeface="Aptos" pitchFamily="34" charset="-122"/>
                           <a:cs typeface="Aptos" pitchFamily="34" charset="-120"/>
                         </a:rPr>
-                        <a:t>Top-25% windows</a:t>
+                        <a:t>Butterworth</a:t>
                       </a:r>
-                      <a:endParaRPr lang="en-US" sz="1500" dirty="0">
+                      <a:endParaRPr lang="en-US" sz="1300" dirty="0">
                         <a:latin typeface="Aptos" charset="0"/>
                         <a:ea typeface="Aptos" charset="0"/>
                         <a:cs typeface="Aptos" charset="0"/>
                       </a:endParaRPr>
                     </a:p>
                   </a:txBody>
-                  <a:tcPr marL="54864" marR="54864" marT="54864" marB="54864" anchor="mid">
+                  <a:tcPr marL="45720" marR="45720" marT="45720" marB="45720" anchor="mid">
                     <a:lnL w="12700" cap="flat" cmpd="sng" algn="ctr">
                       <a:solidFill>
                         <a:srgbClr val="C8C1B5"/>
@@ -12630,7 +12834,7 @@
                         <a:buNone/>
                       </a:pPr>
                       <a:r>
-                        <a:rPr lang="en-US" sz="1500" dirty="0">
+                        <a:rPr lang="en-US" sz="1300" dirty="0">
                           <a:solidFill>
                             <a:srgbClr val="17313B"/>
                           </a:solidFill>
@@ -12638,16 +12842,16 @@
                           <a:ea typeface="Aptos" pitchFamily="34" charset="-122"/>
                           <a:cs typeface="Aptos" pitchFamily="34" charset="-120"/>
                         </a:rPr>
-                        <a:t>0.765</a:t>
+                        <a:t>0.737</a:t>
                       </a:r>
-                      <a:endParaRPr lang="en-US" sz="1500" dirty="0">
+                      <a:endParaRPr lang="en-US" sz="1300" dirty="0">
                         <a:latin typeface="Aptos" charset="0"/>
                         <a:ea typeface="Aptos" charset="0"/>
                         <a:cs typeface="Aptos" charset="0"/>
                       </a:endParaRPr>
                     </a:p>
                   </a:txBody>
-                  <a:tcPr marL="54864" marR="54864" marT="54864" marB="54864" anchor="mid">
+                  <a:tcPr marL="45720" marR="45720" marT="45720" marB="45720" anchor="mid">
                     <a:lnL w="12700" cap="flat" cmpd="sng" algn="ctr">
                       <a:solidFill>
                         <a:srgbClr val="C8C1B5"/>
@@ -12698,7 +12902,7 @@
                         <a:buNone/>
                       </a:pPr>
                       <a:r>
-                        <a:rPr lang="en-US" sz="1500" dirty="0">
+                        <a:rPr lang="en-US" sz="1300" dirty="0">
                           <a:solidFill>
                             <a:srgbClr val="17313B"/>
                           </a:solidFill>
@@ -12706,16 +12910,16 @@
                           <a:ea typeface="Aptos" pitchFamily="34" charset="-122"/>
                           <a:cs typeface="Aptos" pitchFamily="34" charset="-120"/>
                         </a:rPr>
-                        <a:t>0.660</a:t>
+                        <a:t>0.667</a:t>
                       </a:r>
-                      <a:endParaRPr lang="en-US" sz="1500" dirty="0">
+                      <a:endParaRPr lang="en-US" sz="1300" dirty="0">
                         <a:latin typeface="Aptos" charset="0"/>
                         <a:ea typeface="Aptos" charset="0"/>
                         <a:cs typeface="Aptos" charset="0"/>
                       </a:endParaRPr>
                     </a:p>
                   </a:txBody>
-                  <a:tcPr marL="54864" marR="54864" marT="54864" marB="54864" anchor="mid">
+                  <a:tcPr marL="45720" marR="45720" marT="45720" marB="45720" anchor="mid">
                     <a:lnL w="12700" cap="flat" cmpd="sng" algn="ctr">
                       <a:solidFill>
                         <a:srgbClr val="C8C1B5"/>
@@ -12766,7 +12970,7 @@
                         <a:buNone/>
                       </a:pPr>
                       <a:r>
-                        <a:rPr lang="en-US" sz="1500" dirty="0">
+                        <a:rPr lang="en-US" sz="1300" dirty="0">
                           <a:solidFill>
                             <a:srgbClr val="17313B"/>
                           </a:solidFill>
@@ -12774,86 +12978,16 @@
                           <a:ea typeface="Aptos" pitchFamily="34" charset="-122"/>
                           <a:cs typeface="Aptos" pitchFamily="34" charset="-120"/>
                         </a:rPr>
-                        <a:t>0.653</a:t>
+                        <a:t>0.641</a:t>
                       </a:r>
-                      <a:endParaRPr lang="en-US" sz="1500" dirty="0">
+                      <a:endParaRPr lang="en-US" sz="1300" dirty="0">
                         <a:latin typeface="Aptos" charset="0"/>
                         <a:ea typeface="Aptos" charset="0"/>
                         <a:cs typeface="Aptos" charset="0"/>
                       </a:endParaRPr>
                     </a:p>
                   </a:txBody>
-                  <a:tcPr marL="54864" marR="54864" marT="54864" marB="54864" anchor="mid">
-                    <a:lnL w="12700" cap="flat" cmpd="sng" algn="ctr">
-                      <a:solidFill>
-                        <a:srgbClr val="C8C1B5"/>
-                      </a:solidFill>
-                      <a:prstDash val="solid"/>
-                      <a:round/>
-                      <a:headEnd type="none" w="med" len="med"/>
-                      <a:tailEnd type="none" w="med" len="med"/>
-                    </a:lnL>
-                    <a:lnR w="12700" cap="flat" cmpd="sng" algn="ctr">
-                      <a:solidFill>
-                        <a:srgbClr val="C8C1B5"/>
-                      </a:solidFill>
-                      <a:prstDash val="solid"/>
-                      <a:round/>
-                      <a:headEnd type="none" w="med" len="med"/>
-                      <a:tailEnd type="none" w="med" len="med"/>
-                    </a:lnR>
-                    <a:lnT w="12700" cap="flat" cmpd="sng" algn="ctr">
-                      <a:solidFill>
-                        <a:srgbClr val="C8C1B5"/>
-                      </a:solidFill>
-                      <a:prstDash val="solid"/>
-                      <a:round/>
-                      <a:headEnd type="none" w="med" len="med"/>
-                      <a:tailEnd type="none" w="med" len="med"/>
-                    </a:lnT>
-                    <a:lnB w="12700" cap="flat" cmpd="sng" algn="ctr">
-                      <a:solidFill>
-                        <a:srgbClr val="C8C1B5"/>
-                      </a:solidFill>
-                      <a:prstDash val="solid"/>
-                      <a:round/>
-                      <a:headEnd type="none" w="med" len="med"/>
-                      <a:tailEnd type="none" w="med" len="med"/>
-                    </a:lnB>
-                    <a:solidFill>
-                      <a:srgbClr val="FFFDF8"/>
-                    </a:solidFill>
-                  </a:tcPr>
-                </a:tc>
-              </a:tr>
-              <a:tr h="603504">
-                <a:tc>
-                  <a:txBody>
-                    <a:bodyPr/>
-                    <a:lstStyle/>
-                    <a:p>
-                      <a:pPr algn="ctr" indent="0" marL="0">
-                        <a:buNone/>
-                      </a:pPr>
-                      <a:r>
-                        <a:rPr lang="en-US" sz="1500" dirty="0">
-                          <a:solidFill>
-                            <a:srgbClr val="17313B"/>
-                          </a:solidFill>
-                          <a:latin typeface="Aptos" pitchFamily="34" charset="0"/>
-                          <a:ea typeface="Aptos" pitchFamily="34" charset="-122"/>
-                          <a:cs typeface="Aptos" pitchFamily="34" charset="-120"/>
-                        </a:rPr>
-                        <a:t>Max window</a:t>
-                      </a:r>
-                      <a:endParaRPr lang="en-US" sz="1500" dirty="0">
-                        <a:latin typeface="Aptos" charset="0"/>
-                        <a:ea typeface="Aptos" charset="0"/>
-                        <a:cs typeface="Aptos" charset="0"/>
-                      </a:endParaRPr>
-                    </a:p>
-                  </a:txBody>
-                  <a:tcPr marL="54864" marR="54864" marT="54864" marB="54864" anchor="mid">
+                  <a:tcPr marL="45720" marR="45720" marT="45720" marB="45720" anchor="mid">
                     <a:lnL w="12700" cap="flat" cmpd="sng" algn="ctr">
                       <a:solidFill>
                         <a:srgbClr val="C8C1B5"/>
@@ -12904,7 +13038,7 @@
                         <a:buNone/>
                       </a:pPr>
                       <a:r>
-                        <a:rPr lang="en-US" sz="1500" dirty="0">
+                        <a:rPr lang="en-US" sz="1300" dirty="0">
                           <a:solidFill>
                             <a:srgbClr val="17313B"/>
                           </a:solidFill>
@@ -12912,16 +13046,16 @@
                           <a:ea typeface="Aptos" pitchFamily="34" charset="-122"/>
                           <a:cs typeface="Aptos" pitchFamily="34" charset="-120"/>
                         </a:rPr>
-                        <a:t>0.667</a:t>
+                        <a:t>0.796</a:t>
                       </a:r>
-                      <a:endParaRPr lang="en-US" sz="1500" dirty="0">
+                      <a:endParaRPr lang="en-US" sz="1300" dirty="0">
                         <a:latin typeface="Aptos" charset="0"/>
                         <a:ea typeface="Aptos" charset="0"/>
                         <a:cs typeface="Aptos" charset="0"/>
                       </a:endParaRPr>
                     </a:p>
                   </a:txBody>
-                  <a:tcPr marL="54864" marR="54864" marT="54864" marB="54864" anchor="mid">
+                  <a:tcPr marL="45720" marR="45720" marT="45720" marB="45720" anchor="mid">
                     <a:lnL w="12700" cap="flat" cmpd="sng" algn="ctr">
                       <a:solidFill>
                         <a:srgbClr val="C8C1B5"/>
@@ -12972,7 +13106,7 @@
                         <a:buNone/>
                       </a:pPr>
                       <a:r>
-                        <a:rPr lang="en-US" sz="1500" dirty="0">
+                        <a:rPr lang="en-US" sz="1300" dirty="0">
                           <a:solidFill>
                             <a:srgbClr val="17313B"/>
                           </a:solidFill>
@@ -12980,16 +13114,16 @@
                           <a:ea typeface="Aptos" pitchFamily="34" charset="-122"/>
                           <a:cs typeface="Aptos" pitchFamily="34" charset="-120"/>
                         </a:rPr>
-                        <a:t>0.543</a:t>
+                        <a:t>0.629</a:t>
                       </a:r>
-                      <a:endParaRPr lang="en-US" sz="1500" dirty="0">
+                      <a:endParaRPr lang="en-US" sz="1300" dirty="0">
                         <a:latin typeface="Aptos" charset="0"/>
                         <a:ea typeface="Aptos" charset="0"/>
                         <a:cs typeface="Aptos" charset="0"/>
                       </a:endParaRPr>
                     </a:p>
                   </a:txBody>
-                  <a:tcPr marL="54864" marR="54864" marT="54864" marB="54864" anchor="mid">
+                  <a:tcPr marL="45720" marR="45720" marT="45720" marB="45720" anchor="mid">
                     <a:lnL w="12700" cap="flat" cmpd="sng" algn="ctr">
                       <a:solidFill>
                         <a:srgbClr val="C8C1B5"/>
@@ -13040,7 +13174,7 @@
                         <a:buNone/>
                       </a:pPr>
                       <a:r>
-                        <a:rPr lang="en-US" sz="1500" dirty="0">
+                        <a:rPr lang="en-US" sz="1300" dirty="0">
                           <a:solidFill>
                             <a:srgbClr val="17313B"/>
                           </a:solidFill>
@@ -13048,16 +13182,16 @@
                           <a:ea typeface="Aptos" pitchFamily="34" charset="-122"/>
                           <a:cs typeface="Aptos" pitchFamily="34" charset="-120"/>
                         </a:rPr>
-                        <a:t>0.536</a:t>
+                        <a:t>0.604</a:t>
                       </a:r>
-                      <a:endParaRPr lang="en-US" sz="1500" dirty="0">
+                      <a:endParaRPr lang="en-US" sz="1300" dirty="0">
                         <a:latin typeface="Aptos" charset="0"/>
                         <a:ea typeface="Aptos" charset="0"/>
                         <a:cs typeface="Aptos" charset="0"/>
                       </a:endParaRPr>
                     </a:p>
                   </a:txBody>
-                  <a:tcPr marL="54864" marR="54864" marT="54864" marB="54864" anchor="mid">
+                  <a:tcPr marL="45720" marR="45720" marT="45720" marB="45720" anchor="mid">
                     <a:lnL w="12700" cap="flat" cmpd="sng" algn="ctr">
                       <a:solidFill>
                         <a:srgbClr val="C8C1B5"/>
@@ -13100,7 +13234,7 @@
                   </a:tcPr>
                 </a:tc>
               </a:tr>
-              <a:tr h="603504">
+              <a:tr h="749808">
                 <a:tc>
                   <a:txBody>
                     <a:bodyPr/>
@@ -13110,7 +13244,7 @@
                         <a:buNone/>
                       </a:pPr>
                       <a:r>
-                        <a:rPr lang="en-US" sz="1500" dirty="0">
+                        <a:rPr lang="en-US" sz="1300" dirty="0">
                           <a:solidFill>
                             <a:srgbClr val="17313B"/>
                           </a:solidFill>
@@ -13118,16 +13252,16 @@
                           <a:ea typeface="Aptos" pitchFamily="34" charset="-122"/>
                           <a:cs typeface="Aptos" pitchFamily="34" charset="-120"/>
                         </a:rPr>
-                        <a:t>Median + last block fine-tuned</a:t>
+                        <a:t>FIR</a:t>
                       </a:r>
-                      <a:endParaRPr lang="en-US" sz="1500" dirty="0">
+                      <a:endParaRPr lang="en-US" sz="1300" dirty="0">
                         <a:latin typeface="Aptos" charset="0"/>
                         <a:ea typeface="Aptos" charset="0"/>
                         <a:cs typeface="Aptos" charset="0"/>
                       </a:endParaRPr>
                     </a:p>
                   </a:txBody>
-                  <a:tcPr marL="54864" marR="54864" marT="54864" marB="54864" anchor="mid">
+                  <a:tcPr marL="45720" marR="45720" marT="45720" marB="45720" anchor="mid">
                     <a:lnL w="12700" cap="flat" cmpd="sng" algn="ctr">
                       <a:solidFill>
                         <a:srgbClr val="C8C1B5"/>
@@ -13178,7 +13312,7 @@
                         <a:buNone/>
                       </a:pPr>
                       <a:r>
-                        <a:rPr lang="en-US" sz="1500" dirty="0">
+                        <a:rPr lang="en-US" sz="1300" dirty="0">
                           <a:solidFill>
                             <a:srgbClr val="17313B"/>
                           </a:solidFill>
@@ -13186,16 +13320,16 @@
                           <a:ea typeface="Aptos" pitchFamily="34" charset="-122"/>
                           <a:cs typeface="Aptos" pitchFamily="34" charset="-120"/>
                         </a:rPr>
-                        <a:t>0.841</a:t>
+                        <a:t>0.682</a:t>
                       </a:r>
-                      <a:endParaRPr lang="en-US" sz="1500" dirty="0">
+                      <a:endParaRPr lang="en-US" sz="1300" dirty="0">
                         <a:latin typeface="Aptos" charset="0"/>
                         <a:ea typeface="Aptos" charset="0"/>
                         <a:cs typeface="Aptos" charset="0"/>
                       </a:endParaRPr>
                     </a:p>
                   </a:txBody>
-                  <a:tcPr marL="54864" marR="54864" marT="54864" marB="54864" anchor="mid">
+                  <a:tcPr marL="45720" marR="45720" marT="45720" marB="45720" anchor="mid">
                     <a:lnL w="12700" cap="flat" cmpd="sng" algn="ctr">
                       <a:solidFill>
                         <a:srgbClr val="C8C1B5"/>
@@ -13246,7 +13380,7 @@
                         <a:buNone/>
                       </a:pPr>
                       <a:r>
-                        <a:rPr lang="en-US" sz="1500" dirty="0">
+                        <a:rPr lang="en-US" sz="1300" dirty="0">
                           <a:solidFill>
                             <a:srgbClr val="17313B"/>
                           </a:solidFill>
@@ -13254,16 +13388,16 @@
                           <a:ea typeface="Aptos" pitchFamily="34" charset="-122"/>
                           <a:cs typeface="Aptos" pitchFamily="34" charset="-120"/>
                         </a:rPr>
-                        <a:t>0.680</a:t>
+                        <a:t>0.553</a:t>
                       </a:r>
-                      <a:endParaRPr lang="en-US" sz="1500" dirty="0">
+                      <a:endParaRPr lang="en-US" sz="1300" dirty="0">
                         <a:latin typeface="Aptos" charset="0"/>
                         <a:ea typeface="Aptos" charset="0"/>
                         <a:cs typeface="Aptos" charset="0"/>
                       </a:endParaRPr>
                     </a:p>
                   </a:txBody>
-                  <a:tcPr marL="54864" marR="54864" marT="54864" marB="54864" anchor="mid">
+                  <a:tcPr marL="45720" marR="45720" marT="45720" marB="45720" anchor="mid">
                     <a:lnL w="12700" cap="flat" cmpd="sng" algn="ctr">
                       <a:solidFill>
                         <a:srgbClr val="C8C1B5"/>
@@ -13314,7 +13448,7 @@
                         <a:buNone/>
                       </a:pPr>
                       <a:r>
-                        <a:rPr lang="en-US" sz="1500" dirty="0">
+                        <a:rPr lang="en-US" sz="1300" dirty="0">
                           <a:solidFill>
                             <a:srgbClr val="17313B"/>
                           </a:solidFill>
@@ -13322,16 +13456,220 @@
                           <a:ea typeface="Aptos" pitchFamily="34" charset="-122"/>
                           <a:cs typeface="Aptos" pitchFamily="34" charset="-120"/>
                         </a:rPr>
-                        <a:t>0.708</a:t>
+                        <a:t>0.579</a:t>
                       </a:r>
-                      <a:endParaRPr lang="en-US" sz="1500" dirty="0">
+                      <a:endParaRPr lang="en-US" sz="1300" dirty="0">
                         <a:latin typeface="Aptos" charset="0"/>
                         <a:ea typeface="Aptos" charset="0"/>
                         <a:cs typeface="Aptos" charset="0"/>
                       </a:endParaRPr>
                     </a:p>
                   </a:txBody>
-                  <a:tcPr marL="54864" marR="54864" marT="54864" marB="54864" anchor="mid">
+                  <a:tcPr marL="45720" marR="45720" marT="45720" marB="45720" anchor="mid">
+                    <a:lnL w="12700" cap="flat" cmpd="sng" algn="ctr">
+                      <a:solidFill>
+                        <a:srgbClr val="C8C1B5"/>
+                      </a:solidFill>
+                      <a:prstDash val="solid"/>
+                      <a:round/>
+                      <a:headEnd type="none" w="med" len="med"/>
+                      <a:tailEnd type="none" w="med" len="med"/>
+                    </a:lnL>
+                    <a:lnR w="12700" cap="flat" cmpd="sng" algn="ctr">
+                      <a:solidFill>
+                        <a:srgbClr val="C8C1B5"/>
+                      </a:solidFill>
+                      <a:prstDash val="solid"/>
+                      <a:round/>
+                      <a:headEnd type="none" w="med" len="med"/>
+                      <a:tailEnd type="none" w="med" len="med"/>
+                    </a:lnR>
+                    <a:lnT w="12700" cap="flat" cmpd="sng" algn="ctr">
+                      <a:solidFill>
+                        <a:srgbClr val="C8C1B5"/>
+                      </a:solidFill>
+                      <a:prstDash val="solid"/>
+                      <a:round/>
+                      <a:headEnd type="none" w="med" len="med"/>
+                      <a:tailEnd type="none" w="med" len="med"/>
+                    </a:lnT>
+                    <a:lnB w="12700" cap="flat" cmpd="sng" algn="ctr">
+                      <a:solidFill>
+                        <a:srgbClr val="C8C1B5"/>
+                      </a:solidFill>
+                      <a:prstDash val="solid"/>
+                      <a:round/>
+                      <a:headEnd type="none" w="med" len="med"/>
+                      <a:tailEnd type="none" w="med" len="med"/>
+                    </a:lnB>
+                    <a:solidFill>
+                      <a:srgbClr val="FFFDF8"/>
+                    </a:solidFill>
+                  </a:tcPr>
+                </a:tc>
+                <a:tc>
+                  <a:txBody>
+                    <a:bodyPr/>
+                    <a:lstStyle/>
+                    <a:p>
+                      <a:pPr algn="ctr" indent="0" marL="0">
+                        <a:buNone/>
+                      </a:pPr>
+                      <a:r>
+                        <a:rPr lang="en-US" sz="1300" dirty="0">
+                          <a:solidFill>
+                            <a:srgbClr val="17313B"/>
+                          </a:solidFill>
+                          <a:latin typeface="Aptos" pitchFamily="34" charset="0"/>
+                          <a:ea typeface="Aptos" pitchFamily="34" charset="-122"/>
+                          <a:cs typeface="Aptos" pitchFamily="34" charset="-120"/>
+                        </a:rPr>
+                        <a:t>0.769</a:t>
+                      </a:r>
+                      <a:endParaRPr lang="en-US" sz="1300" dirty="0">
+                        <a:latin typeface="Aptos" charset="0"/>
+                        <a:ea typeface="Aptos" charset="0"/>
+                        <a:cs typeface="Aptos" charset="0"/>
+                      </a:endParaRPr>
+                    </a:p>
+                  </a:txBody>
+                  <a:tcPr marL="45720" marR="45720" marT="45720" marB="45720" anchor="mid">
+                    <a:lnL w="12700" cap="flat" cmpd="sng" algn="ctr">
+                      <a:solidFill>
+                        <a:srgbClr val="C8C1B5"/>
+                      </a:solidFill>
+                      <a:prstDash val="solid"/>
+                      <a:round/>
+                      <a:headEnd type="none" w="med" len="med"/>
+                      <a:tailEnd type="none" w="med" len="med"/>
+                    </a:lnL>
+                    <a:lnR w="12700" cap="flat" cmpd="sng" algn="ctr">
+                      <a:solidFill>
+                        <a:srgbClr val="C8C1B5"/>
+                      </a:solidFill>
+                      <a:prstDash val="solid"/>
+                      <a:round/>
+                      <a:headEnd type="none" w="med" len="med"/>
+                      <a:tailEnd type="none" w="med" len="med"/>
+                    </a:lnR>
+                    <a:lnT w="12700" cap="flat" cmpd="sng" algn="ctr">
+                      <a:solidFill>
+                        <a:srgbClr val="C8C1B5"/>
+                      </a:solidFill>
+                      <a:prstDash val="solid"/>
+                      <a:round/>
+                      <a:headEnd type="none" w="med" len="med"/>
+                      <a:tailEnd type="none" w="med" len="med"/>
+                    </a:lnT>
+                    <a:lnB w="12700" cap="flat" cmpd="sng" algn="ctr">
+                      <a:solidFill>
+                        <a:srgbClr val="C8C1B5"/>
+                      </a:solidFill>
+                      <a:prstDash val="solid"/>
+                      <a:round/>
+                      <a:headEnd type="none" w="med" len="med"/>
+                      <a:tailEnd type="none" w="med" len="med"/>
+                    </a:lnB>
+                    <a:solidFill>
+                      <a:srgbClr val="FFFDF8"/>
+                    </a:solidFill>
+                  </a:tcPr>
+                </a:tc>
+                <a:tc>
+                  <a:txBody>
+                    <a:bodyPr/>
+                    <a:lstStyle/>
+                    <a:p>
+                      <a:pPr algn="ctr" indent="0" marL="0">
+                        <a:buNone/>
+                      </a:pPr>
+                      <a:r>
+                        <a:rPr lang="en-US" sz="1300" dirty="0">
+                          <a:solidFill>
+                            <a:srgbClr val="17313B"/>
+                          </a:solidFill>
+                          <a:latin typeface="Aptos" pitchFamily="34" charset="0"/>
+                          <a:ea typeface="Aptos" pitchFamily="34" charset="-122"/>
+                          <a:cs typeface="Aptos" pitchFamily="34" charset="-120"/>
+                        </a:rPr>
+                        <a:t>0.581</a:t>
+                      </a:r>
+                      <a:endParaRPr lang="en-US" sz="1300" dirty="0">
+                        <a:latin typeface="Aptos" charset="0"/>
+                        <a:ea typeface="Aptos" charset="0"/>
+                        <a:cs typeface="Aptos" charset="0"/>
+                      </a:endParaRPr>
+                    </a:p>
+                  </a:txBody>
+                  <a:tcPr marL="45720" marR="45720" marT="45720" marB="45720" anchor="mid">
+                    <a:lnL w="12700" cap="flat" cmpd="sng" algn="ctr">
+                      <a:solidFill>
+                        <a:srgbClr val="C8C1B5"/>
+                      </a:solidFill>
+                      <a:prstDash val="solid"/>
+                      <a:round/>
+                      <a:headEnd type="none" w="med" len="med"/>
+                      <a:tailEnd type="none" w="med" len="med"/>
+                    </a:lnL>
+                    <a:lnR w="12700" cap="flat" cmpd="sng" algn="ctr">
+                      <a:solidFill>
+                        <a:srgbClr val="C8C1B5"/>
+                      </a:solidFill>
+                      <a:prstDash val="solid"/>
+                      <a:round/>
+                      <a:headEnd type="none" w="med" len="med"/>
+                      <a:tailEnd type="none" w="med" len="med"/>
+                    </a:lnR>
+                    <a:lnT w="12700" cap="flat" cmpd="sng" algn="ctr">
+                      <a:solidFill>
+                        <a:srgbClr val="C8C1B5"/>
+                      </a:solidFill>
+                      <a:prstDash val="solid"/>
+                      <a:round/>
+                      <a:headEnd type="none" w="med" len="med"/>
+                      <a:tailEnd type="none" w="med" len="med"/>
+                    </a:lnT>
+                    <a:lnB w="12700" cap="flat" cmpd="sng" algn="ctr">
+                      <a:solidFill>
+                        <a:srgbClr val="C8C1B5"/>
+                      </a:solidFill>
+                      <a:prstDash val="solid"/>
+                      <a:round/>
+                      <a:headEnd type="none" w="med" len="med"/>
+                      <a:tailEnd type="none" w="med" len="med"/>
+                    </a:lnB>
+                    <a:solidFill>
+                      <a:srgbClr val="FFFDF8"/>
+                    </a:solidFill>
+                  </a:tcPr>
+                </a:tc>
+                <a:tc>
+                  <a:txBody>
+                    <a:bodyPr/>
+                    <a:lstStyle/>
+                    <a:p>
+                      <a:pPr algn="ctr" indent="0" marL="0">
+                        <a:buNone/>
+                      </a:pPr>
+                      <a:r>
+                        <a:rPr lang="en-US" sz="1300" dirty="0">
+                          <a:solidFill>
+                            <a:srgbClr val="17313B"/>
+                          </a:solidFill>
+                          <a:latin typeface="Aptos" pitchFamily="34" charset="0"/>
+                          <a:ea typeface="Aptos" pitchFamily="34" charset="-122"/>
+                          <a:cs typeface="Aptos" pitchFamily="34" charset="-120"/>
+                        </a:rPr>
+                        <a:t>0.524</a:t>
+                      </a:r>
+                      <a:endParaRPr lang="en-US" sz="1300" dirty="0">
+                        <a:latin typeface="Aptos" charset="0"/>
+                        <a:ea typeface="Aptos" charset="0"/>
+                        <a:cs typeface="Aptos" charset="0"/>
+                      </a:endParaRPr>
+                    </a:p>
+                  </a:txBody>
+                  <a:tcPr marL="45720" marR="45720" marT="45720" marB="45720" anchor="mid">
                     <a:lnL w="12700" cap="flat" cmpd="sng" algn="ctr">
                       <a:solidFill>
                         <a:srgbClr val="C8C1B5"/>
@@ -13386,8 +13724,8 @@
         </p:nvSpPr>
         <p:spPr>
           <a:xfrm>
-            <a:off x="8549640" y="1737360"/>
-            <a:ext cx="2788920" cy="1234440"/>
+            <a:off x="9235440" y="1737360"/>
+            <a:ext cx="2057400" cy="1234440"/>
           </a:xfrm>
           <a:prstGeom prst="rect">
             <a:avLst/>
@@ -13411,8 +13749,8 @@
         </p:nvSpPr>
         <p:spPr>
           <a:xfrm>
-            <a:off x="8549640" y="1737360"/>
-            <a:ext cx="2788920" cy="73152"/>
+            <a:off x="9235440" y="1737360"/>
+            <a:ext cx="2057400" cy="73152"/>
           </a:xfrm>
           <a:prstGeom prst="rect">
             <a:avLst/>
@@ -13436,8 +13774,8 @@
         </p:nvSpPr>
         <p:spPr>
           <a:xfrm>
-            <a:off x="8778240" y="1901952"/>
-            <a:ext cx="2423160" cy="420624"/>
+            <a:off x="9464040" y="1901952"/>
+            <a:ext cx="1691640" cy="420624"/>
           </a:xfrm>
           <a:prstGeom prst="rect">
             <a:avLst/>
@@ -13463,7 +13801,7 @@
                 <a:ea typeface="Aptos" pitchFamily="34" charset="-122"/>
                 <a:cs typeface="Aptos" pitchFamily="34" charset="-120"/>
               </a:rPr>
-              <a:t>0.710</a:t>
+              <a:t>0.667</a:t>
             </a:r>
             <a:endParaRPr lang="en-US" sz="2700" dirty="0"/>
           </a:p>
@@ -13477,8 +13815,8 @@
         </p:nvSpPr>
         <p:spPr>
           <a:xfrm>
-            <a:off x="8778240" y="2395728"/>
-            <a:ext cx="2423160" cy="256032"/>
+            <a:off x="9464040" y="2395728"/>
+            <a:ext cx="1691640" cy="256032"/>
           </a:xfrm>
           <a:prstGeom prst="rect">
             <a:avLst/>
@@ -13504,7 +13842,7 @@
                 <a:ea typeface="Georgia" pitchFamily="34" charset="-122"/>
                 <a:cs typeface="Georgia" pitchFamily="34" charset="-120"/>
               </a:rPr>
-              <a:t>Best CNN Macro-F1</a:t>
+              <a:t>Best CNN WAcc</a:t>
             </a:r>
             <a:endParaRPr lang="en-US" sz="1500" dirty="0"/>
           </a:p>
@@ -13518,8 +13856,8 @@
         </p:nvSpPr>
         <p:spPr>
           <a:xfrm>
-            <a:off x="8778240" y="2688336"/>
-            <a:ext cx="2423160" cy="182880"/>
+            <a:off x="9464040" y="2688336"/>
+            <a:ext cx="1691640" cy="182880"/>
           </a:xfrm>
           <a:prstGeom prst="rect">
             <a:avLst/>
@@ -13545,7 +13883,7 @@
                 <a:ea typeface="Aptos" pitchFamily="34" charset="-122"/>
                 <a:cs typeface="Aptos" pitchFamily="34" charset="-120"/>
               </a:rPr>
-              <a:t>Median aggregation</a:t>
+              <a:t>Butterworth</a:t>
             </a:r>
             <a:endParaRPr lang="en-US" sz="1300" dirty="0"/>
           </a:p>
@@ -13559,8 +13897,8 @@
         </p:nvSpPr>
         <p:spPr>
           <a:xfrm>
-            <a:off x="8549640" y="3200400"/>
-            <a:ext cx="2788920" cy="1234440"/>
+            <a:off x="9235440" y="3200400"/>
+            <a:ext cx="2057400" cy="1234440"/>
           </a:xfrm>
           <a:prstGeom prst="rect">
             <a:avLst/>
@@ -13584,8 +13922,8 @@
         </p:nvSpPr>
         <p:spPr>
           <a:xfrm>
-            <a:off x="8549640" y="3200400"/>
-            <a:ext cx="2788920" cy="73152"/>
+            <a:off x="9235440" y="3200400"/>
+            <a:ext cx="2057400" cy="73152"/>
           </a:xfrm>
           <a:prstGeom prst="rect">
             <a:avLst/>
@@ -13609,8 +13947,8 @@
         </p:nvSpPr>
         <p:spPr>
           <a:xfrm>
-            <a:off x="8778240" y="3364992"/>
-            <a:ext cx="2423160" cy="420624"/>
+            <a:off x="9464040" y="3364992"/>
+            <a:ext cx="1691640" cy="420624"/>
           </a:xfrm>
           <a:prstGeom prst="rect">
             <a:avLst/>
@@ -13636,7 +13974,7 @@
                 <a:ea typeface="Aptos" pitchFamily="34" charset="-122"/>
                 <a:cs typeface="Aptos" pitchFamily="34" charset="-120"/>
               </a:rPr>
-              <a:t>0.62</a:t>
+              <a:t>0.796</a:t>
             </a:r>
             <a:endParaRPr lang="en-US" sz="2700" dirty="0"/>
           </a:p>
@@ -13650,8 +13988,8 @@
         </p:nvSpPr>
         <p:spPr>
           <a:xfrm>
-            <a:off x="8778240" y="3858768"/>
-            <a:ext cx="2423160" cy="256032"/>
+            <a:off x="9464040" y="3858768"/>
+            <a:ext cx="1691640" cy="256032"/>
           </a:xfrm>
           <a:prstGeom prst="rect">
             <a:avLst/>
@@ -13677,7 +14015,7 @@
                 <a:ea typeface="Georgia" pitchFamily="34" charset="-122"/>
                 <a:cs typeface="Georgia" pitchFamily="34" charset="-120"/>
               </a:rPr>
-              <a:t>Threshold</a:t>
+              <a:t>Best AUROC</a:t>
             </a:r>
             <a:endParaRPr lang="en-US" sz="1500" dirty="0"/>
           </a:p>
@@ -13691,8 +14029,8 @@
         </p:nvSpPr>
         <p:spPr>
           <a:xfrm>
-            <a:off x="8778240" y="4151376"/>
-            <a:ext cx="2423160" cy="182880"/>
+            <a:off x="9464040" y="4151376"/>
+            <a:ext cx="1691640" cy="182880"/>
           </a:xfrm>
           <a:prstGeom prst="rect">
             <a:avLst/>
@@ -13718,7 +14056,7 @@
                 <a:ea typeface="Aptos" pitchFamily="34" charset="-122"/>
                 <a:cs typeface="Aptos" pitchFamily="34" charset="-120"/>
               </a:rPr>
-              <a:t>Tuned on validation only</a:t>
+              <a:t>Butterworth</a:t>
             </a:r>
             <a:endParaRPr lang="en-US" sz="1300" dirty="0"/>
           </a:p>
@@ -13732,8 +14070,8 @@
         </p:nvSpPr>
         <p:spPr>
           <a:xfrm>
-            <a:off x="8549640" y="4663440"/>
-            <a:ext cx="2788920" cy="1051560"/>
+            <a:off x="9235440" y="4663440"/>
+            <a:ext cx="2057400" cy="1051560"/>
           </a:xfrm>
           <a:prstGeom prst="rect">
             <a:avLst/>
@@ -13757,8 +14095,8 @@
         </p:nvSpPr>
         <p:spPr>
           <a:xfrm>
-            <a:off x="8549640" y="4663440"/>
-            <a:ext cx="2788920" cy="73152"/>
+            <a:off x="9235440" y="4663440"/>
+            <a:ext cx="2057400" cy="73152"/>
           </a:xfrm>
           <a:prstGeom prst="rect">
             <a:avLst/>
@@ -13782,8 +14120,8 @@
         </p:nvSpPr>
         <p:spPr>
           <a:xfrm>
-            <a:off x="8778240" y="4864608"/>
-            <a:ext cx="2423160" cy="256032"/>
+            <a:off x="9464040" y="4864608"/>
+            <a:ext cx="1691640" cy="256032"/>
           </a:xfrm>
           <a:prstGeom prst="rect">
             <a:avLst/>
@@ -13809,7 +14147,7 @@
                 <a:ea typeface="Georgia" pitchFamily="34" charset="-122"/>
                 <a:cs typeface="Georgia" pitchFamily="34" charset="-120"/>
               </a:rPr>
-              <a:t>Seed stability</a:t>
+              <a:t>Status</a:t>
             </a:r>
             <a:endParaRPr lang="en-US" sz="1500" dirty="0"/>
           </a:p>
@@ -13823,8 +14161,8 @@
         </p:nvSpPr>
         <p:spPr>
           <a:xfrm>
-            <a:off x="8778240" y="5193792"/>
-            <a:ext cx="2423160" cy="411480"/>
+            <a:off x="9464040" y="5193792"/>
+            <a:ext cx="1691640" cy="411480"/>
           </a:xfrm>
           <a:prstGeom prst="rect">
             <a:avLst/>
@@ -13850,7 +14188,7 @@
                 <a:ea typeface="Aptos" pitchFamily="34" charset="-122"/>
                 <a:cs typeface="Aptos" pitchFamily="34" charset="-120"/>
               </a:rPr>
-              <a:t>Macro-F1 0.688 ± 0.025</a:t>
+              <a:t>Frozen pretrained baseline</a:t>
             </a:r>
             <a:endParaRPr lang="en-US" sz="1300" dirty="0"/>
           </a:p>
@@ -13864,8 +14202,8 @@
         </p:nvSpPr>
         <p:spPr>
           <a:xfrm>
-            <a:off x="685800" y="5806440"/>
-            <a:ext cx="7543800" cy="411480"/>
+            <a:off x="685800" y="5486400"/>
+            <a:ext cx="8458200" cy="411480"/>
           </a:xfrm>
           <a:prstGeom prst="rect">
             <a:avLst/>
@@ -13891,7 +14229,7 @@
                 <a:ea typeface="Aptos" pitchFamily="34" charset="-122"/>
                 <a:cs typeface="Aptos" pitchFamily="34" charset="-120"/>
               </a:rPr>
-              <a:t>Kết luận: median ổn định hơn; max/top-25% overreact với window bất thường; unfreeze block cuối không đem lại lợi ích rõ.</a:t>
+              <a:t>Kết luận: Butterworth giúp MobileNet tăng WAcc và AUROC; FIR suy giảm. Chưa fine-tune toàn backbone.</a:t>
             </a:r>
             <a:endParaRPr lang="en-US" sz="1500" dirty="0"/>
           </a:p>
@@ -16808,12 +17146,12 @@
           </a:bodyPr>
           <a:lstStyle/>
           <a:p>
-            <a:pPr marL="228600" indent="-228600">
+            <a:pPr marL="203200" indent="-203200">
               <a:buSzPct val="100000"/>
               <a:buChar char="•"/>
             </a:pPr>
             <a:r>
-              <a:rPr lang="en-US" sz="1800" dirty="0">
+              <a:rPr lang="en-US" sz="1600" dirty="0">
                 <a:solidFill>
                   <a:srgbClr val="D7E5EE"/>
                 </a:solidFill>
@@ -16821,17 +17159,17 @@
                 <a:ea typeface="Aptos" pitchFamily="34" charset="-122"/>
                 <a:cs typeface="Aptos" pitchFamily="34" charset="-120"/>
               </a:rPr>
-              <a:t>Full benchmark: 1 kHz nhanh nhất; 4 kHz + none đạt Macro-F1 0.637 trong split hiện tại.</a:t>
-            </a:r>
-            <a:endParaRPr lang="en-US" sz="1800" dirty="0"/>
-          </a:p>
-          <a:p>
-            <a:pPr marL="228600" indent="-228600">
+              <a:t>Primary: MobileNet + Butterworth đạt WAcc 0.667 · UAR 0.641 · AUROC 0.796 · AUPRC 0.629.</a:t>
+            </a:r>
+            <a:endParaRPr lang="en-US" sz="1600" dirty="0"/>
+          </a:p>
+          <a:p>
+            <a:pPr marL="203200" indent="-203200">
               <a:buSzPct val="100000"/>
               <a:buChar char="•"/>
             </a:pPr>
             <a:r>
-              <a:rPr lang="en-US" sz="1800" dirty="0">
+              <a:rPr lang="en-US" sz="1600" dirty="0">
                 <a:solidFill>
                   <a:srgbClr val="D7E5EE"/>
                 </a:solidFill>
@@ -16839,17 +17177,17 @@
                 <a:ea typeface="Aptos" pitchFamily="34" charset="-122"/>
                 <a:cs typeface="Aptos" pitchFamily="34" charset="-120"/>
               </a:rPr>
-              <a:t>CNN frozen + median aggregation đạt Macro-F1 0.710; seed stability khoảng 0.688 ± 0.025.</a:t>
-            </a:r>
-            <a:endParaRPr lang="en-US" sz="1800" dirty="0"/>
-          </a:p>
-          <a:p>
-            <a:pPr marL="228600" indent="-228600">
+              <a:t>DSP-only tốt nhất: SVM + none + hybrid đạt WAcc 0.644.</a:t>
+            </a:r>
+            <a:endParaRPr lang="en-US" sz="1600" dirty="0"/>
+          </a:p>
+          <a:p>
+            <a:pPr marL="203200" indent="-203200">
               <a:buSzPct val="100000"/>
               <a:buChar char="•"/>
             </a:pPr>
             <a:r>
-              <a:rPr lang="en-US" sz="1800" dirty="0">
+              <a:rPr lang="en-US" sz="1600" dirty="0">
                 <a:solidFill>
                   <a:srgbClr val="D7E5EE"/>
                 </a:solidFill>
@@ -16857,17 +17195,17 @@
                 <a:ea typeface="Aptos" pitchFamily="34" charset="-122"/>
                 <a:cs typeface="Aptos" pitchFamily="34" charset="-120"/>
               </a:rPr>
-              <a:t>Pipeline, model bundle và Streamlit FE đã chạy end-to-end.</a:t>
-            </a:r>
-            <a:endParaRPr lang="en-US" sz="1800" dirty="0"/>
-          </a:p>
-          <a:p>
-            <a:pPr marL="228600" indent="-228600">
+              <a:t>Binary DSP matrix (MLP MFCC Macro-F1 0.693) chỉ là ablation phụ.</a:t>
+            </a:r>
+            <a:endParaRPr lang="en-US" sz="1600" dirty="0"/>
+          </a:p>
+          <a:p>
+            <a:pPr marL="203200" indent="-203200">
               <a:buSzPct val="100000"/>
               <a:buChar char="•"/>
             </a:pPr>
             <a:r>
-              <a:rPr lang="en-US" sz="1800" dirty="0">
+              <a:rPr lang="en-US" sz="1600" dirty="0">
                 <a:solidFill>
                   <a:srgbClr val="D7E5EE"/>
                 </a:solidFill>
@@ -16875,9 +17213,9 @@
                 <a:ea typeface="Aptos" pitchFamily="34" charset="-122"/>
                 <a:cs typeface="Aptos" pitchFamily="34" charset="-120"/>
               </a:rPr>
-              <a:t>Bước tiếp theo: segmentation-aware features và calibration.</a:t>
-            </a:r>
-            <a:endParaRPr lang="en-US" sz="1800" dirty="0"/>
+              <a:t>Pipeline, model bundle và Streamlit FE đã chạy end-to-end.</a:t>
+            </a:r>
+            <a:endParaRPr lang="en-US" sz="1600" dirty="0"/>
           </a:p>
         </p:txBody>
       </p:sp>
@@ -16985,7 +17323,7 @@
                 <a:ea typeface="Aptos" pitchFamily="34" charset="-122"/>
                 <a:cs typeface="Aptos" pitchFamily="34" charset="-120"/>
               </a:rPr>
-              <a:t>Public training release 942 bệnh nhân</a:t>
+              <a:t>Public split 942 bệnh nhân · test 236</a:t>
             </a:r>
             <a:endParaRPr lang="en-US" sz="1600" dirty="0"/>
           </a:p>
@@ -17003,7 +17341,7 @@
                 <a:ea typeface="Aptos" pitchFamily="34" charset="-122"/>
                 <a:cs typeface="Aptos" pitchFamily="34" charset="-120"/>
               </a:rPr>
-              <a:t>Test set 132 bệnh nhân · seed 42</a:t>
+              <a:t>Official hidden test chưa tái lập được</a:t>
             </a:r>
             <a:endParaRPr lang="en-US" sz="1600" dirty="0"/>
           </a:p>
@@ -18971,8 +19309,8 @@
         </p:nvSpPr>
         <p:spPr>
           <a:xfrm>
-            <a:off x="6217920" y="3246120"/>
-            <a:ext cx="4434840" cy="1554480"/>
+            <a:off x="6217920" y="3154680"/>
+            <a:ext cx="4434840" cy="1874520"/>
           </a:xfrm>
           <a:prstGeom prst="rect">
             <a:avLst/>
@@ -18986,12 +19324,12 @@
           </a:bodyPr>
           <a:lstStyle/>
           <a:p>
-            <a:pPr marL="203200" indent="-203200">
+            <a:pPr marL="190500" indent="-190500">
               <a:buSzPct val="100000"/>
               <a:buChar char="•"/>
             </a:pPr>
             <a:r>
-              <a:rPr lang="en-US" sz="1600" dirty="0">
+              <a:rPr lang="en-US" sz="1500" dirty="0">
                 <a:solidFill>
                   <a:srgbClr val="17313B"/>
                 </a:solidFill>
@@ -19001,15 +19339,15 @@
               </a:rPr>
               <a:t>Absent: 695 patients</a:t>
             </a:r>
-            <a:endParaRPr lang="en-US" sz="1600" dirty="0"/>
-          </a:p>
-          <a:p>
-            <a:pPr marL="203200" indent="-203200">
+            <a:endParaRPr lang="en-US" sz="1500" dirty="0"/>
+          </a:p>
+          <a:p>
+            <a:pPr marL="190500" indent="-190500">
               <a:buSzPct val="100000"/>
               <a:buChar char="•"/>
             </a:pPr>
             <a:r>
-              <a:rPr lang="en-US" sz="1600" dirty="0">
+              <a:rPr lang="en-US" sz="1500" dirty="0">
                 <a:solidFill>
                   <a:srgbClr val="17313B"/>
                 </a:solidFill>
@@ -19019,15 +19357,15 @@
               </a:rPr>
               <a:t>Present: 179 patients</a:t>
             </a:r>
-            <a:endParaRPr lang="en-US" sz="1600" dirty="0"/>
-          </a:p>
-          <a:p>
-            <a:pPr marL="203200" indent="-203200">
+            <a:endParaRPr lang="en-US" sz="1500" dirty="0"/>
+          </a:p>
+          <a:p>
+            <a:pPr marL="190500" indent="-190500">
               <a:buSzPct val="100000"/>
               <a:buChar char="•"/>
             </a:pPr>
             <a:r>
-              <a:rPr lang="en-US" sz="1600" dirty="0">
+              <a:rPr lang="en-US" sz="1500" dirty="0">
                 <a:solidFill>
                   <a:srgbClr val="17313B"/>
                 </a:solidFill>
@@ -19037,15 +19375,15 @@
               </a:rPr>
               <a:t>Unknown: 68 patients</a:t>
             </a:r>
-            <a:endParaRPr lang="en-US" sz="1600" dirty="0"/>
-          </a:p>
-          <a:p>
-            <a:pPr marL="203200" indent="-203200">
+            <a:endParaRPr lang="en-US" sz="1500" dirty="0"/>
+          </a:p>
+          <a:p>
+            <a:pPr marL="190500" indent="-190500">
               <a:buSzPct val="100000"/>
               <a:buChar char="•"/>
             </a:pPr>
             <a:r>
-              <a:rPr lang="en-US" sz="1600" dirty="0">
+              <a:rPr lang="en-US" sz="1500" dirty="0">
                 <a:solidFill>
                   <a:srgbClr val="17313B"/>
                 </a:solidFill>
@@ -19053,9 +19391,27 @@
                 <a:ea typeface="Aptos" pitchFamily="34" charset="-122"/>
                 <a:cs typeface="Aptos" pitchFamily="34" charset="-120"/>
               </a:rPr>
-              <a:t>874 labeled patients dùng cho supervised training</a:t>
-            </a:r>
-            <a:endParaRPr lang="en-US" sz="1600" dirty="0"/>
+              <a:t>Primary track giữ đủ 942 patients</a:t>
+            </a:r>
+            <a:endParaRPr lang="en-US" sz="1500" dirty="0"/>
+          </a:p>
+          <a:p>
+            <a:pPr marL="190500" indent="-190500">
+              <a:buSzPct val="100000"/>
+              <a:buChar char="•"/>
+            </a:pPr>
+            <a:r>
+              <a:rPr lang="en-US" sz="1500" dirty="0">
+                <a:solidFill>
+                  <a:srgbClr val="17313B"/>
+                </a:solidFill>
+                <a:latin typeface="Aptos" pitchFamily="34" charset="0"/>
+                <a:ea typeface="Aptos" pitchFamily="34" charset="-122"/>
+                <a:cs typeface="Aptos" pitchFamily="34" charset="-120"/>
+              </a:rPr>
+              <a:t>Binary ablation: 874 patients</a:t>
+            </a:r>
+            <a:endParaRPr lang="en-US" sz="1500" dirty="0"/>
           </a:p>
         </p:txBody>
       </p:sp>
@@ -24844,7 +25200,7 @@
                 <a:ea typeface="Aptos" pitchFamily="34" charset="-122"/>
                 <a:cs typeface="Aptos" pitchFamily="34" charset="-120"/>
               </a:rPr>
-              <a:t>611</a:t>
+              <a:t>612</a:t>
             </a:r>
             <a:endParaRPr lang="en-US" sz="2200" dirty="0"/>
           </a:p>
@@ -24929,7 +25285,7 @@
                 <a:ea typeface="Aptos" pitchFamily="34" charset="-122"/>
                 <a:cs typeface="Aptos" pitchFamily="34" charset="-120"/>
               </a:rPr>
-              <a:t>131</a:t>
+              <a:t>94</a:t>
             </a:r>
             <a:endParaRPr lang="en-US" sz="2200" dirty="0"/>
           </a:p>
@@ -25014,7 +25370,7 @@
                 <a:ea typeface="Aptos" pitchFamily="34" charset="-122"/>
                 <a:cs typeface="Aptos" pitchFamily="34" charset="-120"/>
               </a:rPr>
-              <a:t>132</a:t>
+              <a:t>236</a:t>
             </a:r>
             <a:endParaRPr lang="en-US" sz="2200" dirty="0"/>
           </a:p>
@@ -25071,7 +25427,7 @@
               <a:buNone/>
             </a:pPr>
             <a:r>
-              <a:rPr lang="en-US" sz="1900" b="1" dirty="0">
+              <a:rPr lang="en-US" sz="1700" b="1" dirty="0">
                 <a:solidFill>
                   <a:srgbClr val="17313B"/>
                 </a:solidFill>
@@ -25079,9 +25435,9 @@
                 <a:ea typeface="Aptos" pitchFamily="34" charset="-122"/>
                 <a:cs typeface="Aptos" pitchFamily="34" charset="-120"/>
               </a:rPr>
-              <a:t>Tất cả location của cùng patient nằm trong cùng một partition.</a:t>
-            </a:r>
-            <a:endParaRPr lang="en-US" sz="1900" dirty="0"/>
+              <a:t>Primary challenge-aligned split: 65 / 10 / 25 · 612 / 94 / 236 patients.</a:t>
+            </a:r>
+            <a:endParaRPr lang="en-US" sz="1700" dirty="0"/>
           </a:p>
         </p:txBody>
       </p:sp>
@@ -26938,7 +27294,7 @@
                 <a:ea typeface="Aptos" pitchFamily="34" charset="-122"/>
                 <a:cs typeface="Aptos" pitchFamily="34" charset="-120"/>
               </a:rPr>
-              <a:t>F1</a:t>
+              <a:t>WAcc</a:t>
             </a:r>
             <a:endParaRPr lang="en-US" sz="2700" dirty="0"/>
           </a:p>
@@ -27020,7 +27376,7 @@
                 <a:ea typeface="Aptos" pitchFamily="34" charset="-122"/>
                 <a:cs typeface="Aptos" pitchFamily="34" charset="-120"/>
               </a:rPr>
-              <a:t>Macro-F1</a:t>
+              <a:t>Weighted Accuracy</a:t>
             </a:r>
             <a:endParaRPr lang="en-US" sz="1300" dirty="0"/>
           </a:p>

</xml_diff>

<commit_message>
Make Streamlit DSP demo presentation-ready
</commit_message>
<xml_diff>
--- a/docs/project_deliverables/DSP501_final_presentation.pptx
+++ b/docs/project_deliverables/DSP501_final_presentation.pptx
@@ -15169,7 +15169,7 @@
                 <a:ea typeface="Aptos" pitchFamily="34" charset="-122"/>
                 <a:cs typeface="Aptos" pitchFamily="34" charset="-120"/>
               </a:rPr>
-              <a:t>Upload WAV</a:t>
+              <a:t>Start</a:t>
             </a:r>
             <a:endParaRPr lang="en-US" sz="1800" dirty="0"/>
           </a:p>
@@ -15210,7 +15210,7 @@
                 <a:ea typeface="Aptos" pitchFamily="34" charset="-122"/>
                 <a:cs typeface="Aptos" pitchFamily="34" charset="-120"/>
               </a:rPr>
-              <a:t>Chọn một recording PCG</a:t>
+              <a:t>Use demo WAV or upload</a:t>
             </a:r>
             <a:endParaRPr lang="en-US" sz="1200" dirty="0"/>
           </a:p>
@@ -15409,7 +15409,7 @@
                 <a:ea typeface="Aptos" pitchFamily="34" charset="-122"/>
                 <a:cs typeface="Aptos" pitchFamily="34" charset="-120"/>
               </a:rPr>
-              <a:t>Chạy đúng DSP pipeline</a:t>
+              <a:t>Run baseline + selected DSP</a:t>
             </a:r>
             <a:endParaRPr lang="en-US" sz="1200" dirty="0"/>
           </a:p>
@@ -15567,7 +15567,7 @@
                 <a:ea typeface="Aptos" pitchFamily="34" charset="-122"/>
                 <a:cs typeface="Aptos" pitchFamily="34" charset="-120"/>
               </a:rPr>
-              <a:t>Inspect</a:t>
+              <a:t>Compare</a:t>
             </a:r>
             <a:endParaRPr lang="en-US" sz="1800" dirty="0"/>
           </a:p>
@@ -15608,7 +15608,7 @@
                 <a:ea typeface="Aptos" pitchFamily="34" charset="-122"/>
                 <a:cs typeface="Aptos" pitchFamily="34" charset="-120"/>
               </a:rPr>
-              <a:t>Waveform · FFT · PSD · STFT</a:t>
+              <a:t>Audio · A/B · filter response</a:t>
             </a:r>
             <a:endParaRPr lang="en-US" sz="1200" dirty="0"/>
           </a:p>
@@ -15766,7 +15766,7 @@
                 <a:ea typeface="Aptos" pitchFamily="34" charset="-122"/>
                 <a:cs typeface="Aptos" pitchFamily="34" charset="-120"/>
               </a:rPr>
-              <a:t>Decide</a:t>
+              <a:t>Explain</a:t>
             </a:r>
             <a:endParaRPr lang="en-US" sz="1800" dirty="0"/>
           </a:p>
@@ -15807,7 +15807,7 @@
                 <a:ea typeface="Aptos" pitchFamily="34" charset="-122"/>
                 <a:cs typeface="Aptos" pitchFamily="34" charset="-120"/>
               </a:rPr>
-              <a:t>Label + probabilities</a:t>
+              <a:t>Probability + confidence + JSON</a:t>
             </a:r>
             <a:endParaRPr lang="en-US" sz="1200" dirty="0"/>
           </a:p>
@@ -15959,7 +15959,7 @@
                 <a:ea typeface="Aptos" pitchFamily="34" charset="-122"/>
                 <a:cs typeface="Aptos" pitchFamily="34" charset="-120"/>
               </a:rPr>
-              <a:t>“Tôi đổi 16-bit sang 8-bit để kiểm tra robustness.”</a:t>
+              <a:t>“Tôi đổi fs/bit depth/filter để xem A/B probability thay đổi.”</a:t>
             </a:r>
             <a:endParaRPr lang="en-US" sz="1500" dirty="0"/>
           </a:p>
@@ -15977,7 +15977,7 @@
                 <a:ea typeface="Aptos" pitchFamily="34" charset="-122"/>
                 <a:cs typeface="Aptos" pitchFamily="34" charset="-120"/>
               </a:rPr>
-              <a:t>“Model đã train trước; FE chỉ inference, không train lại.”</a:t>
+              <a:t>“Filter response cho thấy dải PCG 25–400 Hz được giữ lại.”</a:t>
             </a:r>
             <a:endParaRPr lang="en-US" sz="1500" dirty="0"/>
           </a:p>

</xml_diff>